<commit_message>
Make final-slide links explicit and clickable
Link the LIVE APPLICATION and SOURCE CODE labels as well as their displayed URL text on slide 20. Keep the full visible URLs underlined and blue for clear click targets.

Co-authored-by: arena-agent <297053741+arena-agent@users.noreply.github.com>
</commit_message>
<xml_diff>
--- a/presentation/RetainIQ_Project_Review.pptx
+++ b/presentation/RetainIQ_Project_Review.pptx
@@ -26111,11 +26111,12 @@
               </a:spcAft>
             </a:pPr>
             <a:r>
-              <a:rPr sz="1050" b="1">
+              <a:rPr sz="1050" b="1" u="sng">
                 <a:solidFill>
                   <a:srgbClr val="2FD8B4"/>
                 </a:solidFill>
                 <a:latin typeface="Consolas"/>
+                <a:hlinkClick r:id="rId2"/>
               </a:rPr>
               <a:t>LIVE APPLICATION</a:t>
             </a:r>
@@ -26169,11 +26170,12 @@
               </a:spcAft>
             </a:pPr>
             <a:r>
-              <a:rPr sz="1050" b="1">
+              <a:rPr sz="1050" b="1" u="sng">
                 <a:solidFill>
                   <a:srgbClr val="4C8DFF"/>
                 </a:solidFill>
                 <a:latin typeface="Consolas"/>
+                <a:hlinkClick r:id="rId3"/>
               </a:rPr>
               <a:t>SOURCE CODE</a:t>
             </a:r>

</xml_diff>

<commit_message>
Add existing-versus-RetainIQ comparison slide
Replace the business-understanding slide with a concise comparison of the existing Power BI reporting layer and the customer-level RetainIQ Signal Ops workflow. Place it as slide 3, after the cycle map and before data collection, preserving the 20-slide limit.

Co-authored-by: arena-agent <297053741+arena-agent@users.noreply.github.com>
</commit_message>
<xml_diff>
--- a/presentation/RetainIQ_Project_Review.pptx
+++ b/presentation/RetainIQ_Project_Review.pptx
@@ -1884,27 +1884,48 @@
           <a:lstStyle/>
           <a:p>
             <a:r>
-              <a:t>(1:05–1:55) Frame the pain, then the four questions — they structure the entire</a:t>
-            </a:r>
-          </a:p>
-          <a:p>
-            <a:r>
-              <a:t>solution. Finish on the donut: "Notice the trap. If I predict nobody churns I'm</a:t>
-            </a:r>
-          </a:p>
-          <a:p>
-            <a:r>
-              <a:t>73.46% accurate and completely useless. That single number is why no model in</a:t>
-            </a:r>
-          </a:p>
-          <a:p>
-            <a:r>
-              <a:t>this deck is chosen on accuracy."</a:t>
-            </a:r>
-          </a:p>
-          <a:p>
-            <a:r>
-              <a:t>That line earns credibility early and sets up Phase 07.</a:t>
+              <a:t>(1:05–1:55) Make clear this is a comparison between two layers in this project,</a:t>
+            </a:r>
+          </a:p>
+          <a:p>
+            <a:r>
+              <a:t>not a claim that RetainIQ replaces an external product. Power BI is useful for</a:t>
+            </a:r>
+          </a:p>
+          <a:p>
+            <a:r>
+              <a:t>portfolio and segment monitoring: where is churn concentrated? The Signal Ops</a:t>
+            </a:r>
+          </a:p>
+          <a:p>
+            <a:r>
+              <a:t>Console adds a different capability: upload customers, score each row with the</a:t>
+            </a:r>
+          </a:p>
+          <a:p>
+            <a:r>
+              <a:t>deployed Logistic Regression, assign a risk tier, show coefficient-based drivers</a:t>
+            </a:r>
+          </a:p>
+          <a:p>
+            <a:r>
+              <a:t>and a rule-based suggestion, then export the work for review.</a:t>
+            </a:r>
+          </a:p>
+          <a:p/>
+          <a:p>
+            <a:r>
+              <a:t>The two layers are complementary. Close with the caveat: recommendations are</a:t>
+            </a:r>
+          </a:p>
+          <a:p>
+            <a:r>
+              <a:t>decision support; no campaign uplift has been measured, and revenue is framed as</a:t>
+            </a:r>
+          </a:p>
+          <a:p>
+            <a:r>
+              <a:t>at risk rather than saved.</a:t>
             </a:r>
           </a:p>
         </p:txBody>
@@ -26989,7 +27010,7 @@
                 </a:solidFill>
                 <a:latin typeface="Segoe UI"/>
               </a:rPr>
-              <a:t>The problem: retention is still reactive</a:t>
+              <a:t>What RetainIQ adds to the existing project</a:t>
             </a:r>
           </a:p>
         </p:txBody>
@@ -27031,7 +27052,7 @@
                 </a:solidFill>
                 <a:latin typeface="Segoe UI"/>
               </a:rPr>
-              <a:t>Reports explain what happened. They do not say who leaves next.</a:t>
+              <a:t>Power BI gives a portfolio view; the Signal Ops Console adds customer-level scoring and review.</a:t>
             </a:r>
           </a:p>
         </p:txBody>
@@ -27082,14 +27103,106 @@
       </p:sp>
       <p:sp>
         <p:nvSpPr>
-          <p:cNvPr id="7" name="TextBox 6"/>
+          <p:cNvPr id="7" name="Rounded Rectangle 6"/>
+          <p:cNvSpPr/>
+          <p:nvPr/>
+        </p:nvSpPr>
+        <p:spPr>
+          <a:xfrm>
+            <a:off x="566928" y="1517904"/>
+            <a:ext cx="5428335" cy="3429000"/>
+          </a:xfrm>
+          <a:prstGeom prst="roundRect">
+            <a:avLst>
+              <a:gd name="adj" fmla="val 8000"/>
+            </a:avLst>
+          </a:prstGeom>
+          <a:solidFill>
+            <a:srgbClr val="111A2C"/>
+          </a:solidFill>
+          <a:ln w="12700">
+            <a:solidFill>
+              <a:srgbClr val="223049"/>
+            </a:solidFill>
+          </a:ln>
+          <a:effectLst/>
+        </p:spPr>
+        <p:style>
+          <a:lnRef idx="1">
+            <a:schemeClr val="accent1"/>
+          </a:lnRef>
+          <a:fillRef idx="3">
+            <a:schemeClr val="accent1"/>
+          </a:fillRef>
+          <a:effectRef idx="2">
+            <a:schemeClr val="accent1"/>
+          </a:effectRef>
+          <a:fontRef idx="minor">
+            <a:schemeClr val="lt1"/>
+          </a:fontRef>
+        </p:style>
+        <p:txBody>
+          <a:bodyPr rtlCol="0" anchor="ctr"/>
+          <a:lstStyle/>
+          <a:p>
+            <a:pPr algn="ctr"/>
+          </a:p>
+        </p:txBody>
+      </p:sp>
+      <p:sp>
+        <p:nvSpPr>
+          <p:cNvPr id="8" name="Rectangle 7"/>
+          <p:cNvSpPr/>
+          <p:nvPr/>
+        </p:nvSpPr>
+        <p:spPr>
+          <a:xfrm>
+            <a:off x="566928" y="1517904"/>
+            <a:ext cx="41148" cy="3429000"/>
+          </a:xfrm>
+          <a:prstGeom prst="rect">
+            <a:avLst/>
+          </a:prstGeom>
+          <a:solidFill>
+            <a:srgbClr val="4C8DFF"/>
+          </a:solidFill>
+          <a:ln>
+            <a:noFill/>
+          </a:ln>
+          <a:effectLst/>
+        </p:spPr>
+        <p:style>
+          <a:lnRef idx="1">
+            <a:schemeClr val="accent1"/>
+          </a:lnRef>
+          <a:fillRef idx="3">
+            <a:schemeClr val="accent1"/>
+          </a:fillRef>
+          <a:effectRef idx="2">
+            <a:schemeClr val="accent1"/>
+          </a:effectRef>
+          <a:fontRef idx="minor">
+            <a:schemeClr val="lt1"/>
+          </a:fontRef>
+        </p:style>
+        <p:txBody>
+          <a:bodyPr rtlCol="0" anchor="ctr"/>
+          <a:lstStyle/>
+          <a:p>
+            <a:pPr algn="ctr"/>
+          </a:p>
+        </p:txBody>
+      </p:sp>
+      <p:sp>
+        <p:nvSpPr>
+          <p:cNvPr id="9" name="TextBox 8"/>
           <p:cNvSpPr txBox="1"/>
           <p:nvPr/>
         </p:nvSpPr>
         <p:spPr>
           <a:xfrm>
-            <a:off x="566928" y="1517904"/>
-            <a:ext cx="5989320" cy="2194560"/>
+            <a:off x="786384" y="1719072"/>
+            <a:ext cx="4989423" cy="3063240"/>
           </a:xfrm>
           <a:prstGeom prst="rect">
             <a:avLst/>
@@ -27107,132 +27220,107 @@
                 <a:spcPct val="112000"/>
               </a:lnSpc>
               <a:spcAft>
-                <a:spcPts val="100"/>
+                <a:spcPts val="800"/>
               </a:spcAft>
             </a:pPr>
             <a:r>
-              <a:rPr sz="1150" b="1">
+              <a:rPr sz="1080" b="1">
                 <a:solidFill>
-                  <a:srgbClr val="2FD8B4"/>
+                  <a:srgbClr val="4C8DFF"/>
                 </a:solidFill>
-                <a:latin typeface="Segoe UI"/>
+                <a:latin typeface="Consolas"/>
               </a:rPr>
-              <a:t>▸  Churn compounds.</a:t>
+              <a:t>EXISTING · POWER BI</a:t>
             </a:r>
           </a:p>
           <a:p>
             <a:pPr algn="l">
               <a:lnSpc>
-                <a:spcPct val="118000"/>
+                <a:spcPct val="112000"/>
               </a:lnSpc>
               <a:spcAft>
-                <a:spcPts val="0"/>
+                <a:spcPts val="1300"/>
               </a:spcAft>
             </a:pPr>
             <a:r>
-              <a:rPr sz="1100" b="0">
+              <a:rPr sz="1500" b="1">
                 <a:solidFill>
                   <a:srgbClr val="EAF0F7"/>
                 </a:solidFill>
                 <a:latin typeface="Segoe UI"/>
               </a:rPr>
-              <a:t>     26.54% of this customer base churned — 1,869 of 7,043 customers.</a:t>
+              <a:t>Portfolio reporting</a:t>
             </a:r>
           </a:p>
           <a:p>
             <a:pPr algn="l">
               <a:lnSpc>
-                <a:spcPct val="112000"/>
+                <a:spcPct val="122000"/>
               </a:lnSpc>
-              <a:spcBef>
-                <a:spcPts val="800"/>
-              </a:spcBef>
               <a:spcAft>
-                <a:spcPts val="100"/>
+                <a:spcPts val="1100"/>
               </a:spcAft>
             </a:pPr>
             <a:r>
-              <a:rPr sz="1150" b="1">
-                <a:solidFill>
-                  <a:srgbClr val="2FD8B4"/>
-                </a:solidFill>
-                <a:latin typeface="Segoe UI"/>
-              </a:rPr>
-              <a:t>▸  Dashboards describe, they do not prioritise.</a:t>
-            </a:r>
-          </a:p>
-          <a:p>
-            <a:pPr algn="l">
-              <a:lnSpc>
-                <a:spcPct val="118000"/>
-              </a:lnSpc>
-              <a:spcAft>
-                <a:spcPts val="0"/>
-              </a:spcAft>
-            </a:pPr>
-            <a:r>
-              <a:rPr sz="1100" b="0">
+              <a:rPr sz="1260" b="0">
                 <a:solidFill>
                   <a:srgbClr val="EAF0F7"/>
                 </a:solidFill>
                 <a:latin typeface="Segoe UI"/>
               </a:rPr>
-              <a:t>     Knowing last quarter's churn rate does not tell a retention team whom to call today.</a:t>
+              <a:t>•  Aggregates historical churn and portfolio KPIs.</a:t>
             </a:r>
           </a:p>
           <a:p>
             <a:pPr algn="l">
               <a:lnSpc>
-                <a:spcPct val="112000"/>
+                <a:spcPct val="122000"/>
               </a:lnSpc>
-              <a:spcBef>
-                <a:spcPts val="800"/>
-              </a:spcBef>
               <a:spcAft>
-                <a:spcPts val="100"/>
+                <a:spcPts val="1100"/>
               </a:spcAft>
             </a:pPr>
             <a:r>
-              <a:rPr sz="1150" b="1">
-                <a:solidFill>
-                  <a:srgbClr val="2FD8B4"/>
-                </a:solidFill>
-                <a:latin typeface="Segoe UI"/>
-              </a:rPr>
-              <a:t>▸  Generic campaigns waste budget.</a:t>
-            </a:r>
-          </a:p>
-          <a:p>
-            <a:pPr algn="l">
-              <a:lnSpc>
-                <a:spcPct val="118000"/>
-              </a:lnSpc>
-              <a:spcAft>
-                <a:spcPts val="0"/>
-              </a:spcAft>
-            </a:pPr>
-            <a:r>
-              <a:rPr sz="1100" b="0">
+              <a:rPr sz="1260" b="0">
                 <a:solidFill>
                   <a:srgbClr val="EAF0F7"/>
                 </a:solidFill>
                 <a:latin typeface="Segoe UI"/>
               </a:rPr>
-              <a:t>     Blanket offers discount loyal customers and still miss the ones about to leave.</a:t>
-            </a:r>
-          </a:p>
-        </p:txBody>
-      </p:sp>
-      <p:sp>
-        <p:nvSpPr>
-          <p:cNvPr id="8" name="Rounded Rectangle 7"/>
-          <p:cNvSpPr/>
-          <p:nvPr/>
-        </p:nvSpPr>
-        <p:spPr>
-          <a:xfrm>
-            <a:off x="566928" y="3895344"/>
-            <a:ext cx="2889504" cy="1097280"/>
+              <a:t>•  Compares patterns across contract, tenure and service.</a:t>
+            </a:r>
+          </a:p>
+          <a:p>
+            <a:pPr algn="l">
+              <a:lnSpc>
+                <a:spcPct val="122000"/>
+              </a:lnSpc>
+              <a:spcAft>
+                <a:spcPts val="1100"/>
+              </a:spcAft>
+            </a:pPr>
+            <a:r>
+              <a:rPr sz="1260" b="0">
+                <a:solidFill>
+                  <a:srgbClr val="EAF0F7"/>
+                </a:solidFill>
+                <a:latin typeface="Segoe UI"/>
+              </a:rPr>
+              <a:t>•  Answers: where is churn concentrated?</a:t>
+            </a:r>
+          </a:p>
+        </p:txBody>
+      </p:sp>
+      <p:sp>
+        <p:nvSpPr>
+          <p:cNvPr id="10" name="Rounded Rectangle 9"/>
+          <p:cNvSpPr/>
+          <p:nvPr/>
+        </p:nvSpPr>
+        <p:spPr>
+          <a:xfrm>
+            <a:off x="6196431" y="1517904"/>
+            <a:ext cx="5428335" cy="3429000"/>
           </a:xfrm>
           <a:prstGeom prst="roundRect">
             <a:avLst>
@@ -27273,20 +27361,20 @@
       </p:sp>
       <p:sp>
         <p:nvSpPr>
-          <p:cNvPr id="9" name="Rectangle 8"/>
-          <p:cNvSpPr/>
-          <p:nvPr/>
-        </p:nvSpPr>
-        <p:spPr>
-          <a:xfrm>
-            <a:off x="566928" y="4041648"/>
-            <a:ext cx="32004" cy="804671"/>
-          </a:xfrm>
-          <a:prstGeom prst="rect">
-            <a:avLst/>
-          </a:prstGeom>
-          <a:solidFill>
-            <a:srgbClr val="4C8DFF"/>
+          <p:cNvPr id="11" name="Rectangle 10"/>
+          <p:cNvSpPr/>
+          <p:nvPr/>
+        </p:nvSpPr>
+        <p:spPr>
+          <a:xfrm>
+            <a:off x="6196431" y="1517904"/>
+            <a:ext cx="41148" cy="3429000"/>
+          </a:xfrm>
+          <a:prstGeom prst="rect">
+            <a:avLst/>
+          </a:prstGeom>
+          <a:solidFill>
+            <a:srgbClr val="2FD8B4"/>
           </a:solidFill>
           <a:ln>
             <a:noFill/>
@@ -27317,14 +27405,14 @@
       </p:sp>
       <p:sp>
         <p:nvSpPr>
-          <p:cNvPr id="10" name="TextBox 9"/>
+          <p:cNvPr id="12" name="TextBox 11"/>
           <p:cNvSpPr txBox="1"/>
           <p:nvPr/>
         </p:nvSpPr>
         <p:spPr>
           <a:xfrm>
-            <a:off x="768096" y="4059935"/>
-            <a:ext cx="2578608" cy="786383"/>
+            <a:off x="6415887" y="1719072"/>
+            <a:ext cx="4989423" cy="3063240"/>
           </a:xfrm>
           <a:prstGeom prst="rect">
             <a:avLst/>
@@ -27342,50 +27430,126 @@
                 <a:spcPct val="112000"/>
               </a:lnSpc>
               <a:spcAft>
-                <a:spcPts val="300"/>
+                <a:spcPts val="800"/>
               </a:spcAft>
             </a:pPr>
             <a:r>
-              <a:rPr sz="1200" b="1">
+              <a:rPr sz="1080" b="1">
+                <a:solidFill>
+                  <a:srgbClr val="2FD8B4"/>
+                </a:solidFill>
+                <a:latin typeface="Consolas"/>
+              </a:rPr>
+              <a:t>NEW · RETAINIQ SIGNAL OPS</a:t>
+            </a:r>
+          </a:p>
+          <a:p>
+            <a:pPr algn="l">
+              <a:lnSpc>
+                <a:spcPct val="112000"/>
+              </a:lnSpc>
+              <a:spcAft>
+                <a:spcPts val="1300"/>
+              </a:spcAft>
+            </a:pPr>
+            <a:r>
+              <a:rPr sz="1500" b="1">
                 <a:solidFill>
                   <a:srgbClr val="EAF0F7"/>
                 </a:solidFill>
                 <a:latin typeface="Segoe UI"/>
               </a:rPr>
-              <a:t>Who is likely to churn?</a:t>
+              <a:t>Customer-level decision support</a:t>
             </a:r>
           </a:p>
           <a:p>
             <a:pPr algn="l">
               <a:lnSpc>
-                <a:spcPct val="114000"/>
+                <a:spcPct val="122000"/>
               </a:lnSpc>
               <a:spcAft>
-                <a:spcPts val="0"/>
+                <a:spcPts val="1100"/>
               </a:spcAft>
             </a:pPr>
             <a:r>
-              <a:rPr sz="980" b="0">
+              <a:rPr sz="1260" b="0">
                 <a:solidFill>
-                  <a:srgbClr val="8CA0BE"/>
+                  <a:srgbClr val="EAF0F7"/>
                 </a:solidFill>
                 <a:latin typeface="Segoe UI"/>
               </a:rPr>
-              <a:t>Predicted churn probability per customer</a:t>
-            </a:r>
-          </a:p>
-        </p:txBody>
-      </p:sp>
-      <p:sp>
-        <p:nvSpPr>
-          <p:cNvPr id="11" name="Rounded Rectangle 10"/>
-          <p:cNvSpPr/>
-          <p:nvPr/>
-        </p:nvSpPr>
-        <p:spPr>
-          <a:xfrm>
-            <a:off x="3621024" y="3895344"/>
-            <a:ext cx="2889504" cy="1097280"/>
+              <a:t>•  Scores uploaded rows with the deployed Logistic Regression.</a:t>
+            </a:r>
+          </a:p>
+          <a:p>
+            <a:pPr algn="l">
+              <a:lnSpc>
+                <a:spcPct val="122000"/>
+              </a:lnSpc>
+              <a:spcAft>
+                <a:spcPts val="1100"/>
+              </a:spcAft>
+            </a:pPr>
+            <a:r>
+              <a:rPr sz="1260" b="0">
+                <a:solidFill>
+                  <a:srgbClr val="EAF0F7"/>
+                </a:solidFill>
+                <a:latin typeface="Segoe UI"/>
+              </a:rPr>
+              <a:t>•  Returns churn probability and a Low / Medium / High risk tier.</a:t>
+            </a:r>
+          </a:p>
+          <a:p>
+            <a:pPr algn="l">
+              <a:lnSpc>
+                <a:spcPct val="122000"/>
+              </a:lnSpc>
+              <a:spcAft>
+                <a:spcPts val="1100"/>
+              </a:spcAft>
+            </a:pPr>
+            <a:r>
+              <a:rPr sz="1260" b="0">
+                <a:solidFill>
+                  <a:srgbClr val="EAF0F7"/>
+                </a:solidFill>
+                <a:latin typeface="Segoe UI"/>
+              </a:rPr>
+              <a:t>•  Shows coefficient-based drivers and rule-based suggestions.</a:t>
+            </a:r>
+          </a:p>
+          <a:p>
+            <a:pPr algn="l">
+              <a:lnSpc>
+                <a:spcPct val="122000"/>
+              </a:lnSpc>
+              <a:spcAft>
+                <a:spcPts val="1100"/>
+              </a:spcAft>
+            </a:pPr>
+            <a:r>
+              <a:rPr sz="1260" b="0">
+                <a:solidFill>
+                  <a:srgbClr val="EAF0F7"/>
+                </a:solidFill>
+                <a:latin typeface="Segoe UI"/>
+              </a:rPr>
+              <a:t>•  Supports bulk review and private report downloads.</a:t>
+            </a:r>
+          </a:p>
+        </p:txBody>
+      </p:sp>
+      <p:sp>
+        <p:nvSpPr>
+          <p:cNvPr id="13" name="Rounded Rectangle 12"/>
+          <p:cNvSpPr/>
+          <p:nvPr/>
+        </p:nvSpPr>
+        <p:spPr>
+          <a:xfrm>
+            <a:off x="566928" y="5093208"/>
+            <a:ext cx="11057839" cy="731520"/>
           </a:xfrm>
           <a:prstGeom prst="roundRect">
             <a:avLst>
@@ -27393,11 +27557,11 @@
             </a:avLst>
           </a:prstGeom>
           <a:solidFill>
-            <a:srgbClr val="111A2C"/>
-          </a:solidFill>
-          <a:ln w="12700">
+            <a:srgbClr val="162136"/>
+          </a:solidFill>
+          <a:ln w="13970">
             <a:solidFill>
-              <a:srgbClr val="223049"/>
+              <a:srgbClr val="2FD8B4"/>
             </a:solidFill>
           </a:ln>
           <a:effectLst/>
@@ -27426,58 +27590,14 @@
       </p:sp>
       <p:sp>
         <p:nvSpPr>
-          <p:cNvPr id="12" name="Rectangle 11"/>
-          <p:cNvSpPr/>
-          <p:nvPr/>
-        </p:nvSpPr>
-        <p:spPr>
-          <a:xfrm>
-            <a:off x="3621024" y="4041648"/>
-            <a:ext cx="32004" cy="804671"/>
-          </a:xfrm>
-          <a:prstGeom prst="rect">
-            <a:avLst/>
-          </a:prstGeom>
-          <a:solidFill>
-            <a:srgbClr val="F5A623"/>
-          </a:solidFill>
-          <a:ln>
-            <a:noFill/>
-          </a:ln>
-          <a:effectLst/>
-        </p:spPr>
-        <p:style>
-          <a:lnRef idx="1">
-            <a:schemeClr val="accent1"/>
-          </a:lnRef>
-          <a:fillRef idx="3">
-            <a:schemeClr val="accent1"/>
-          </a:fillRef>
-          <a:effectRef idx="2">
-            <a:schemeClr val="accent1"/>
-          </a:effectRef>
-          <a:fontRef idx="minor">
-            <a:schemeClr val="lt1"/>
-          </a:fontRef>
-        </p:style>
-        <p:txBody>
-          <a:bodyPr rtlCol="0" anchor="ctr"/>
-          <a:lstStyle/>
-          <a:p>
-            <a:pPr algn="ctr"/>
-          </a:p>
-        </p:txBody>
-      </p:sp>
-      <p:sp>
-        <p:nvSpPr>
-          <p:cNvPr id="13" name="TextBox 12"/>
+          <p:cNvPr id="14" name="TextBox 13"/>
           <p:cNvSpPr txBox="1"/>
           <p:nvPr/>
         </p:nvSpPr>
         <p:spPr>
           <a:xfrm>
-            <a:off x="3822191" y="4059935"/>
-            <a:ext cx="2578608" cy="786383"/>
+            <a:off x="768096" y="5184648"/>
+            <a:ext cx="10655503" cy="566928"/>
           </a:xfrm>
           <a:prstGeom prst="rect">
             <a:avLst/>
@@ -27495,367 +27615,19 @@
                 <a:spcPct val="112000"/>
               </a:lnSpc>
               <a:spcAft>
-                <a:spcPts val="300"/>
+                <a:spcPts val="600"/>
               </a:spcAft>
             </a:pPr>
             <a:r>
-              <a:rPr sz="1200" b="1">
+              <a:rPr sz="1440" b="1">
                 <a:solidFill>
                   <a:srgbClr val="EAF0F7"/>
                 </a:solidFill>
                 <a:latin typeface="Segoe UI"/>
               </a:rPr>
-              <a:t>Why are they at risk?</a:t>
-            </a:r>
-          </a:p>
-          <a:p>
-            <a:pPr algn="l">
-              <a:lnSpc>
-                <a:spcPct val="114000"/>
-              </a:lnSpc>
-              <a:spcAft>
-                <a:spcPts val="0"/>
-              </a:spcAft>
-            </a:pPr>
-            <a:r>
-              <a:rPr sz="980" b="0">
-                <a:solidFill>
-                  <a:srgbClr val="8CA0BE"/>
-                </a:solidFill>
-                <a:latin typeface="Segoe UI"/>
-              </a:rPr>
-              <a:t>Feature contributions behind each prediction</a:t>
-            </a:r>
-          </a:p>
-        </p:txBody>
-      </p:sp>
-      <p:sp>
-        <p:nvSpPr>
-          <p:cNvPr id="14" name="Rounded Rectangle 13"/>
-          <p:cNvSpPr/>
-          <p:nvPr/>
-        </p:nvSpPr>
-        <p:spPr>
-          <a:xfrm>
-            <a:off x="566928" y="5120640"/>
-            <a:ext cx="2889504" cy="1097280"/>
-          </a:xfrm>
-          <a:prstGeom prst="roundRect">
-            <a:avLst>
-              <a:gd name="adj" fmla="val 8000"/>
-            </a:avLst>
-          </a:prstGeom>
-          <a:solidFill>
-            <a:srgbClr val="111A2C"/>
-          </a:solidFill>
-          <a:ln w="12700">
-            <a:solidFill>
-              <a:srgbClr val="223049"/>
-            </a:solidFill>
-          </a:ln>
-          <a:effectLst/>
-        </p:spPr>
-        <p:style>
-          <a:lnRef idx="1">
-            <a:schemeClr val="accent1"/>
-          </a:lnRef>
-          <a:fillRef idx="3">
-            <a:schemeClr val="accent1"/>
-          </a:fillRef>
-          <a:effectRef idx="2">
-            <a:schemeClr val="accent1"/>
-          </a:effectRef>
-          <a:fontRef idx="minor">
-            <a:schemeClr val="lt1"/>
-          </a:fontRef>
-        </p:style>
-        <p:txBody>
-          <a:bodyPr rtlCol="0" anchor="ctr"/>
-          <a:lstStyle/>
-          <a:p>
-            <a:pPr algn="ctr"/>
-          </a:p>
-        </p:txBody>
-      </p:sp>
-      <p:sp>
-        <p:nvSpPr>
-          <p:cNvPr id="15" name="Rectangle 14"/>
-          <p:cNvSpPr/>
-          <p:nvPr/>
-        </p:nvSpPr>
-        <p:spPr>
-          <a:xfrm>
-            <a:off x="566928" y="5266944"/>
-            <a:ext cx="32004" cy="804671"/>
-          </a:xfrm>
-          <a:prstGeom prst="rect">
-            <a:avLst/>
-          </a:prstGeom>
-          <a:solidFill>
-            <a:srgbClr val="2FD8B4"/>
-          </a:solidFill>
-          <a:ln>
-            <a:noFill/>
-          </a:ln>
-          <a:effectLst/>
-        </p:spPr>
-        <p:style>
-          <a:lnRef idx="1">
-            <a:schemeClr val="accent1"/>
-          </a:lnRef>
-          <a:fillRef idx="3">
-            <a:schemeClr val="accent1"/>
-          </a:fillRef>
-          <a:effectRef idx="2">
-            <a:schemeClr val="accent1"/>
-          </a:effectRef>
-          <a:fontRef idx="minor">
-            <a:schemeClr val="lt1"/>
-          </a:fontRef>
-        </p:style>
-        <p:txBody>
-          <a:bodyPr rtlCol="0" anchor="ctr"/>
-          <a:lstStyle/>
-          <a:p>
-            <a:pPr algn="ctr"/>
-          </a:p>
-        </p:txBody>
-      </p:sp>
-      <p:sp>
-        <p:nvSpPr>
-          <p:cNvPr id="16" name="TextBox 15"/>
-          <p:cNvSpPr txBox="1"/>
-          <p:nvPr/>
-        </p:nvSpPr>
-        <p:spPr>
-          <a:xfrm>
-            <a:off x="768096" y="5285231"/>
-            <a:ext cx="2578608" cy="786383"/>
-          </a:xfrm>
-          <a:prstGeom prst="rect">
-            <a:avLst/>
-          </a:prstGeom>
-          <a:noFill/>
-        </p:spPr>
-        <p:txBody>
-          <a:bodyPr wrap="square" lIns="0" rIns="0" tIns="0" bIns="0" anchor="t">
-            <a:spAutoFit/>
-          </a:bodyPr>
-          <a:lstStyle/>
-          <a:p>
-            <a:pPr algn="l">
-              <a:lnSpc>
-                <a:spcPct val="112000"/>
-              </a:lnSpc>
-              <a:spcAft>
-                <a:spcPts val="300"/>
-              </a:spcAft>
-            </a:pPr>
-            <a:r>
-              <a:rPr sz="1200" b="1">
-                <a:solidFill>
-                  <a:srgbClr val="EAF0F7"/>
-                </a:solidFill>
-                <a:latin typeface="Segoe UI"/>
-              </a:rPr>
-              <a:t>What should we do?</a:t>
-            </a:r>
-          </a:p>
-          <a:p>
-            <a:pPr algn="l">
-              <a:lnSpc>
-                <a:spcPct val="114000"/>
-              </a:lnSpc>
-              <a:spcAft>
-                <a:spcPts val="0"/>
-              </a:spcAft>
-            </a:pPr>
-            <a:r>
-              <a:rPr sz="980" b="0">
-                <a:solidFill>
-                  <a:srgbClr val="8CA0BE"/>
-                </a:solidFill>
-                <a:latin typeface="Segoe UI"/>
-              </a:rPr>
-              <a:t>A retention action matched to the risk drivers</a:t>
-            </a:r>
-          </a:p>
-        </p:txBody>
-      </p:sp>
-      <p:sp>
-        <p:nvSpPr>
-          <p:cNvPr id="17" name="Rounded Rectangle 16"/>
-          <p:cNvSpPr/>
-          <p:nvPr/>
-        </p:nvSpPr>
-        <p:spPr>
-          <a:xfrm>
-            <a:off x="3621024" y="5120640"/>
-            <a:ext cx="2889504" cy="1097280"/>
-          </a:xfrm>
-          <a:prstGeom prst="roundRect">
-            <a:avLst>
-              <a:gd name="adj" fmla="val 8000"/>
-            </a:avLst>
-          </a:prstGeom>
-          <a:solidFill>
-            <a:srgbClr val="111A2C"/>
-          </a:solidFill>
-          <a:ln w="12700">
-            <a:solidFill>
-              <a:srgbClr val="223049"/>
-            </a:solidFill>
-          </a:ln>
-          <a:effectLst/>
-        </p:spPr>
-        <p:style>
-          <a:lnRef idx="1">
-            <a:schemeClr val="accent1"/>
-          </a:lnRef>
-          <a:fillRef idx="3">
-            <a:schemeClr val="accent1"/>
-          </a:fillRef>
-          <a:effectRef idx="2">
-            <a:schemeClr val="accent1"/>
-          </a:effectRef>
-          <a:fontRef idx="minor">
-            <a:schemeClr val="lt1"/>
-          </a:fontRef>
-        </p:style>
-        <p:txBody>
-          <a:bodyPr rtlCol="0" anchor="ctr"/>
-          <a:lstStyle/>
-          <a:p>
-            <a:pPr algn="ctr"/>
-          </a:p>
-        </p:txBody>
-      </p:sp>
-      <p:sp>
-        <p:nvSpPr>
-          <p:cNvPr id="18" name="Rectangle 17"/>
-          <p:cNvSpPr/>
-          <p:nvPr/>
-        </p:nvSpPr>
-        <p:spPr>
-          <a:xfrm>
-            <a:off x="3621024" y="5266944"/>
-            <a:ext cx="32004" cy="804671"/>
-          </a:xfrm>
-          <a:prstGeom prst="rect">
-            <a:avLst/>
-          </a:prstGeom>
-          <a:solidFill>
-            <a:srgbClr val="FF5C6C"/>
-          </a:solidFill>
-          <a:ln>
-            <a:noFill/>
-          </a:ln>
-          <a:effectLst/>
-        </p:spPr>
-        <p:style>
-          <a:lnRef idx="1">
-            <a:schemeClr val="accent1"/>
-          </a:lnRef>
-          <a:fillRef idx="3">
-            <a:schemeClr val="accent1"/>
-          </a:fillRef>
-          <a:effectRef idx="2">
-            <a:schemeClr val="accent1"/>
-          </a:effectRef>
-          <a:fontRef idx="minor">
-            <a:schemeClr val="lt1"/>
-          </a:fontRef>
-        </p:style>
-        <p:txBody>
-          <a:bodyPr rtlCol="0" anchor="ctr"/>
-          <a:lstStyle/>
-          <a:p>
-            <a:pPr algn="ctr"/>
-          </a:p>
-        </p:txBody>
-      </p:sp>
-      <p:sp>
-        <p:nvSpPr>
-          <p:cNvPr id="19" name="TextBox 18"/>
-          <p:cNvSpPr txBox="1"/>
-          <p:nvPr/>
-        </p:nvSpPr>
-        <p:spPr>
-          <a:xfrm>
-            <a:off x="3822191" y="5285231"/>
-            <a:ext cx="2578608" cy="786383"/>
-          </a:xfrm>
-          <a:prstGeom prst="rect">
-            <a:avLst/>
-          </a:prstGeom>
-          <a:noFill/>
-        </p:spPr>
-        <p:txBody>
-          <a:bodyPr wrap="square" lIns="0" rIns="0" tIns="0" bIns="0" anchor="t">
-            <a:spAutoFit/>
-          </a:bodyPr>
-          <a:lstStyle/>
-          <a:p>
-            <a:pPr algn="l">
-              <a:lnSpc>
-                <a:spcPct val="112000"/>
-              </a:lnSpc>
-              <a:spcAft>
-                <a:spcPts val="300"/>
-              </a:spcAft>
-            </a:pPr>
-            <a:r>
-              <a:rPr sz="1200" b="1">
-                <a:solidFill>
-                  <a:srgbClr val="EAF0F7"/>
-                </a:solidFill>
-                <a:latin typeface="Segoe UI"/>
-              </a:rPr>
-              <a:t>What is at stake?</a:t>
-            </a:r>
-          </a:p>
-          <a:p>
-            <a:pPr algn="l">
-              <a:lnSpc>
-                <a:spcPct val="114000"/>
-              </a:lnSpc>
-              <a:spcAft>
-                <a:spcPts val="0"/>
-              </a:spcAft>
-            </a:pPr>
-            <a:r>
-              <a:rPr sz="980" b="0">
-                <a:solidFill>
-                  <a:srgbClr val="8CA0BE"/>
-                </a:solidFill>
-                <a:latin typeface="Segoe UI"/>
-              </a:rPr>
-              <a:t>Monthly recurring revenue exposed in each risk band</a:t>
-            </a:r>
-          </a:p>
-        </p:txBody>
-      </p:sp>
-      <p:sp>
-        <p:nvSpPr>
-          <p:cNvPr id="20" name="TextBox 19"/>
-          <p:cNvSpPr txBox="1"/>
-          <p:nvPr/>
-        </p:nvSpPr>
-        <p:spPr>
-          <a:xfrm>
-            <a:off x="7187184" y="1700784"/>
-            <a:ext cx="4206240" cy="274320"/>
-          </a:xfrm>
-          <a:prstGeom prst="rect">
-            <a:avLst/>
-          </a:prstGeom>
-          <a:noFill/>
-        </p:spPr>
-        <p:txBody>
-          <a:bodyPr wrap="square" lIns="0" rIns="0" tIns="0" bIns="0" anchor="t">
-            <a:spAutoFit/>
-          </a:bodyPr>
-          <a:lstStyle/>
+              <a:t>POWER BI monitors the portfolio. RETAINIQ prioritises new customer uploads for review.</a:t>
+            </a:r>
+          </a:p>
           <a:p>
             <a:pPr algn="l">
               <a:lnSpc>
@@ -27866,753 +27638,27 @@
               </a:spcAft>
             </a:pPr>
             <a:r>
-              <a:rPr sz="1050" b="1">
+              <a:rPr sz="1120" b="0">
                 <a:solidFill>
-                  <a:srgbClr val="8CA0BE"/>
-                </a:solidFill>
-                <a:latin typeface="Consolas"/>
-              </a:rPr>
-              <a:t>THE BASE RATE</a:t>
-            </a:r>
-          </a:p>
-        </p:txBody>
-      </p:sp>
-      <p:pic>
-        <p:nvPicPr>
-          <p:cNvPr id="21" name="Picture 20" descr="chart_churn_split.png"/>
-          <p:cNvPicPr>
-            <a:picLocks noChangeAspect="1"/>
-          </p:cNvPicPr>
-          <p:nvPr/>
-        </p:nvPicPr>
-        <p:blipFill>
-          <a:blip r:embed="rId2"/>
-          <a:stretch>
-            <a:fillRect/>
-          </a:stretch>
-        </p:blipFill>
-        <p:spPr>
-          <a:xfrm>
-            <a:off x="7511796" y="1956815"/>
-            <a:ext cx="3566159" cy="3566159"/>
-          </a:xfrm>
-          <a:prstGeom prst="rect">
-            <a:avLst/>
-          </a:prstGeom>
-        </p:spPr>
-      </p:pic>
-      <p:sp>
-        <p:nvSpPr>
-          <p:cNvPr id="22" name="TextBox 21"/>
-          <p:cNvSpPr txBox="1"/>
-          <p:nvPr/>
-        </p:nvSpPr>
-        <p:spPr>
-          <a:xfrm>
-            <a:off x="7187184" y="5614416"/>
-            <a:ext cx="4206240" cy="603504"/>
-          </a:xfrm>
-          <a:prstGeom prst="rect">
-            <a:avLst/>
-          </a:prstGeom>
-          <a:noFill/>
-        </p:spPr>
-        <p:txBody>
-          <a:bodyPr wrap="square" lIns="0" rIns="0" tIns="0" bIns="0" anchor="t">
-            <a:spAutoFit/>
-          </a:bodyPr>
-          <a:lstStyle/>
-          <a:p>
-            <a:pPr algn="l">
-              <a:lnSpc>
-                <a:spcPct val="116000"/>
-              </a:lnSpc>
-              <a:spcAft>
-                <a:spcPts val="0"/>
-              </a:spcAft>
-            </a:pPr>
-            <a:r>
-              <a:rPr sz="1050" b="0">
-                <a:solidFill>
-                  <a:srgbClr val="8CA0BE"/>
+                  <a:srgbClr val="2FD8B4"/>
                 </a:solidFill>
                 <a:latin typeface="Segoe UI"/>
               </a:rPr>
-              <a:t>1,869 churned · 5,174 retained of 7,043. Predicting "nobody churns" is already 73.46% accurate — which is why accuracy alone decides nothing here.</a:t>
-            </a:r>
-          </a:p>
-        </p:txBody>
-      </p:sp>
-      <p:sp>
-        <p:nvSpPr>
-          <p:cNvPr id="23" name="Rectangle 22"/>
-          <p:cNvSpPr/>
-          <p:nvPr/>
-        </p:nvSpPr>
-        <p:spPr>
-          <a:xfrm>
-            <a:off x="566928" y="6296558"/>
-            <a:ext cx="743145" cy="68580"/>
-          </a:xfrm>
-          <a:prstGeom prst="rect">
-            <a:avLst/>
-          </a:prstGeom>
-          <a:solidFill>
-            <a:srgbClr val="2FD8B4"/>
-          </a:solidFill>
-          <a:ln>
-            <a:noFill/>
-          </a:ln>
-          <a:effectLst/>
-        </p:spPr>
-        <p:style>
-          <a:lnRef idx="1">
-            <a:schemeClr val="accent1"/>
-          </a:lnRef>
-          <a:fillRef idx="3">
-            <a:schemeClr val="accent1"/>
-          </a:fillRef>
-          <a:effectRef idx="2">
-            <a:schemeClr val="accent1"/>
-          </a:effectRef>
-          <a:fontRef idx="minor">
-            <a:schemeClr val="lt1"/>
-          </a:fontRef>
-        </p:style>
-        <p:txBody>
-          <a:bodyPr rtlCol="0" anchor="ctr"/>
-          <a:lstStyle/>
-          <a:p>
-            <a:pPr algn="ctr"/>
-          </a:p>
-        </p:txBody>
-      </p:sp>
-      <p:sp>
-        <p:nvSpPr>
-          <p:cNvPr id="24" name="Rectangle 23"/>
-          <p:cNvSpPr/>
-          <p:nvPr/>
-        </p:nvSpPr>
-        <p:spPr>
-          <a:xfrm>
-            <a:off x="1360365" y="6309360"/>
-            <a:ext cx="743145" cy="43891"/>
-          </a:xfrm>
-          <a:prstGeom prst="rect">
-            <a:avLst/>
-          </a:prstGeom>
-          <a:solidFill>
-            <a:srgbClr val="223049"/>
-          </a:solidFill>
-          <a:ln>
-            <a:noFill/>
-          </a:ln>
-          <a:effectLst/>
-        </p:spPr>
-        <p:style>
-          <a:lnRef idx="1">
-            <a:schemeClr val="accent1"/>
-          </a:lnRef>
-          <a:fillRef idx="3">
-            <a:schemeClr val="accent1"/>
-          </a:fillRef>
-          <a:effectRef idx="2">
-            <a:schemeClr val="accent1"/>
-          </a:effectRef>
-          <a:fontRef idx="minor">
-            <a:schemeClr val="lt1"/>
-          </a:fontRef>
-        </p:style>
-        <p:txBody>
-          <a:bodyPr rtlCol="0" anchor="ctr"/>
-          <a:lstStyle/>
-          <a:p>
-            <a:pPr algn="ctr"/>
-          </a:p>
-        </p:txBody>
-      </p:sp>
-      <p:sp>
-        <p:nvSpPr>
-          <p:cNvPr id="25" name="Rectangle 24"/>
-          <p:cNvSpPr/>
-          <p:nvPr/>
-        </p:nvSpPr>
-        <p:spPr>
-          <a:xfrm>
-            <a:off x="2153803" y="6309360"/>
-            <a:ext cx="743145" cy="43891"/>
-          </a:xfrm>
-          <a:prstGeom prst="rect">
-            <a:avLst/>
-          </a:prstGeom>
-          <a:solidFill>
-            <a:srgbClr val="223049"/>
-          </a:solidFill>
-          <a:ln>
-            <a:noFill/>
-          </a:ln>
-          <a:effectLst/>
-        </p:spPr>
-        <p:style>
-          <a:lnRef idx="1">
-            <a:schemeClr val="accent1"/>
-          </a:lnRef>
-          <a:fillRef idx="3">
-            <a:schemeClr val="accent1"/>
-          </a:fillRef>
-          <a:effectRef idx="2">
-            <a:schemeClr val="accent1"/>
-          </a:effectRef>
-          <a:fontRef idx="minor">
-            <a:schemeClr val="lt1"/>
-          </a:fontRef>
-        </p:style>
-        <p:txBody>
-          <a:bodyPr rtlCol="0" anchor="ctr"/>
-          <a:lstStyle/>
-          <a:p>
-            <a:pPr algn="ctr"/>
-          </a:p>
-        </p:txBody>
-      </p:sp>
-      <p:sp>
-        <p:nvSpPr>
-          <p:cNvPr id="26" name="Rectangle 25"/>
-          <p:cNvSpPr/>
-          <p:nvPr/>
-        </p:nvSpPr>
-        <p:spPr>
-          <a:xfrm>
-            <a:off x="2947241" y="6309360"/>
-            <a:ext cx="743145" cy="43891"/>
-          </a:xfrm>
-          <a:prstGeom prst="rect">
-            <a:avLst/>
-          </a:prstGeom>
-          <a:solidFill>
-            <a:srgbClr val="223049"/>
-          </a:solidFill>
-          <a:ln>
-            <a:noFill/>
-          </a:ln>
-          <a:effectLst/>
-        </p:spPr>
-        <p:style>
-          <a:lnRef idx="1">
-            <a:schemeClr val="accent1"/>
-          </a:lnRef>
-          <a:fillRef idx="3">
-            <a:schemeClr val="accent1"/>
-          </a:fillRef>
-          <a:effectRef idx="2">
-            <a:schemeClr val="accent1"/>
-          </a:effectRef>
-          <a:fontRef idx="minor">
-            <a:schemeClr val="lt1"/>
-          </a:fontRef>
-        </p:style>
-        <p:txBody>
-          <a:bodyPr rtlCol="0" anchor="ctr"/>
-          <a:lstStyle/>
-          <a:p>
-            <a:pPr algn="ctr"/>
-          </a:p>
-        </p:txBody>
-      </p:sp>
-      <p:sp>
-        <p:nvSpPr>
-          <p:cNvPr id="27" name="Rectangle 26"/>
-          <p:cNvSpPr/>
-          <p:nvPr/>
-        </p:nvSpPr>
-        <p:spPr>
-          <a:xfrm>
-            <a:off x="3740679" y="6309360"/>
-            <a:ext cx="743145" cy="43891"/>
-          </a:xfrm>
-          <a:prstGeom prst="rect">
-            <a:avLst/>
-          </a:prstGeom>
-          <a:solidFill>
-            <a:srgbClr val="223049"/>
-          </a:solidFill>
-          <a:ln>
-            <a:noFill/>
-          </a:ln>
-          <a:effectLst/>
-        </p:spPr>
-        <p:style>
-          <a:lnRef idx="1">
-            <a:schemeClr val="accent1"/>
-          </a:lnRef>
-          <a:fillRef idx="3">
-            <a:schemeClr val="accent1"/>
-          </a:fillRef>
-          <a:effectRef idx="2">
-            <a:schemeClr val="accent1"/>
-          </a:effectRef>
-          <a:fontRef idx="minor">
-            <a:schemeClr val="lt1"/>
-          </a:fontRef>
-        </p:style>
-        <p:txBody>
-          <a:bodyPr rtlCol="0" anchor="ctr"/>
-          <a:lstStyle/>
-          <a:p>
-            <a:pPr algn="ctr"/>
-          </a:p>
-        </p:txBody>
-      </p:sp>
-      <p:sp>
-        <p:nvSpPr>
-          <p:cNvPr id="28" name="Rectangle 27"/>
-          <p:cNvSpPr/>
-          <p:nvPr/>
-        </p:nvSpPr>
-        <p:spPr>
-          <a:xfrm>
-            <a:off x="4534117" y="6309360"/>
-            <a:ext cx="743145" cy="43891"/>
-          </a:xfrm>
-          <a:prstGeom prst="rect">
-            <a:avLst/>
-          </a:prstGeom>
-          <a:solidFill>
-            <a:srgbClr val="223049"/>
-          </a:solidFill>
-          <a:ln>
-            <a:noFill/>
-          </a:ln>
-          <a:effectLst/>
-        </p:spPr>
-        <p:style>
-          <a:lnRef idx="1">
-            <a:schemeClr val="accent1"/>
-          </a:lnRef>
-          <a:fillRef idx="3">
-            <a:schemeClr val="accent1"/>
-          </a:fillRef>
-          <a:effectRef idx="2">
-            <a:schemeClr val="accent1"/>
-          </a:effectRef>
-          <a:fontRef idx="minor">
-            <a:schemeClr val="lt1"/>
-          </a:fontRef>
-        </p:style>
-        <p:txBody>
-          <a:bodyPr rtlCol="0" anchor="ctr"/>
-          <a:lstStyle/>
-          <a:p>
-            <a:pPr algn="ctr"/>
-          </a:p>
-        </p:txBody>
-      </p:sp>
-      <p:sp>
-        <p:nvSpPr>
-          <p:cNvPr id="29" name="Rectangle 28"/>
-          <p:cNvSpPr/>
-          <p:nvPr/>
-        </p:nvSpPr>
-        <p:spPr>
-          <a:xfrm>
-            <a:off x="5327555" y="6309360"/>
-            <a:ext cx="743145" cy="43891"/>
-          </a:xfrm>
-          <a:prstGeom prst="rect">
-            <a:avLst/>
-          </a:prstGeom>
-          <a:solidFill>
-            <a:srgbClr val="223049"/>
-          </a:solidFill>
-          <a:ln>
-            <a:noFill/>
-          </a:ln>
-          <a:effectLst/>
-        </p:spPr>
-        <p:style>
-          <a:lnRef idx="1">
-            <a:schemeClr val="accent1"/>
-          </a:lnRef>
-          <a:fillRef idx="3">
-            <a:schemeClr val="accent1"/>
-          </a:fillRef>
-          <a:effectRef idx="2">
-            <a:schemeClr val="accent1"/>
-          </a:effectRef>
-          <a:fontRef idx="minor">
-            <a:schemeClr val="lt1"/>
-          </a:fontRef>
-        </p:style>
-        <p:txBody>
-          <a:bodyPr rtlCol="0" anchor="ctr"/>
-          <a:lstStyle/>
-          <a:p>
-            <a:pPr algn="ctr"/>
-          </a:p>
-        </p:txBody>
-      </p:sp>
-      <p:sp>
-        <p:nvSpPr>
-          <p:cNvPr id="30" name="Rectangle 29"/>
-          <p:cNvSpPr/>
-          <p:nvPr/>
-        </p:nvSpPr>
-        <p:spPr>
-          <a:xfrm>
-            <a:off x="6120993" y="6309360"/>
-            <a:ext cx="743145" cy="43891"/>
-          </a:xfrm>
-          <a:prstGeom prst="rect">
-            <a:avLst/>
-          </a:prstGeom>
-          <a:solidFill>
-            <a:srgbClr val="223049"/>
-          </a:solidFill>
-          <a:ln>
-            <a:noFill/>
-          </a:ln>
-          <a:effectLst/>
-        </p:spPr>
-        <p:style>
-          <a:lnRef idx="1">
-            <a:schemeClr val="accent1"/>
-          </a:lnRef>
-          <a:fillRef idx="3">
-            <a:schemeClr val="accent1"/>
-          </a:fillRef>
-          <a:effectRef idx="2">
-            <a:schemeClr val="accent1"/>
-          </a:effectRef>
-          <a:fontRef idx="minor">
-            <a:schemeClr val="lt1"/>
-          </a:fontRef>
-        </p:style>
-        <p:txBody>
-          <a:bodyPr rtlCol="0" anchor="ctr"/>
-          <a:lstStyle/>
-          <a:p>
-            <a:pPr algn="ctr"/>
-          </a:p>
-        </p:txBody>
-      </p:sp>
-      <p:sp>
-        <p:nvSpPr>
-          <p:cNvPr id="31" name="Rectangle 30"/>
-          <p:cNvSpPr/>
-          <p:nvPr/>
-        </p:nvSpPr>
-        <p:spPr>
-          <a:xfrm>
-            <a:off x="6914431" y="6309360"/>
-            <a:ext cx="743145" cy="43891"/>
-          </a:xfrm>
-          <a:prstGeom prst="rect">
-            <a:avLst/>
-          </a:prstGeom>
-          <a:solidFill>
-            <a:srgbClr val="223049"/>
-          </a:solidFill>
-          <a:ln>
-            <a:noFill/>
-          </a:ln>
-          <a:effectLst/>
-        </p:spPr>
-        <p:style>
-          <a:lnRef idx="1">
-            <a:schemeClr val="accent1"/>
-          </a:lnRef>
-          <a:fillRef idx="3">
-            <a:schemeClr val="accent1"/>
-          </a:fillRef>
-          <a:effectRef idx="2">
-            <a:schemeClr val="accent1"/>
-          </a:effectRef>
-          <a:fontRef idx="minor">
-            <a:schemeClr val="lt1"/>
-          </a:fontRef>
-        </p:style>
-        <p:txBody>
-          <a:bodyPr rtlCol="0" anchor="ctr"/>
-          <a:lstStyle/>
-          <a:p>
-            <a:pPr algn="ctr"/>
-          </a:p>
-        </p:txBody>
-      </p:sp>
-      <p:sp>
-        <p:nvSpPr>
-          <p:cNvPr id="32" name="Rectangle 31"/>
-          <p:cNvSpPr/>
-          <p:nvPr/>
-        </p:nvSpPr>
-        <p:spPr>
-          <a:xfrm>
-            <a:off x="7707869" y="6309360"/>
-            <a:ext cx="743145" cy="43891"/>
-          </a:xfrm>
-          <a:prstGeom prst="rect">
-            <a:avLst/>
-          </a:prstGeom>
-          <a:solidFill>
-            <a:srgbClr val="223049"/>
-          </a:solidFill>
-          <a:ln>
-            <a:noFill/>
-          </a:ln>
-          <a:effectLst/>
-        </p:spPr>
-        <p:style>
-          <a:lnRef idx="1">
-            <a:schemeClr val="accent1"/>
-          </a:lnRef>
-          <a:fillRef idx="3">
-            <a:schemeClr val="accent1"/>
-          </a:fillRef>
-          <a:effectRef idx="2">
-            <a:schemeClr val="accent1"/>
-          </a:effectRef>
-          <a:fontRef idx="minor">
-            <a:schemeClr val="lt1"/>
-          </a:fontRef>
-        </p:style>
-        <p:txBody>
-          <a:bodyPr rtlCol="0" anchor="ctr"/>
-          <a:lstStyle/>
-          <a:p>
-            <a:pPr algn="ctr"/>
-          </a:p>
-        </p:txBody>
-      </p:sp>
-      <p:sp>
-        <p:nvSpPr>
-          <p:cNvPr id="33" name="Rectangle 32"/>
-          <p:cNvSpPr/>
-          <p:nvPr/>
-        </p:nvSpPr>
-        <p:spPr>
-          <a:xfrm>
-            <a:off x="8501307" y="6309360"/>
-            <a:ext cx="743145" cy="43891"/>
-          </a:xfrm>
-          <a:prstGeom prst="rect">
-            <a:avLst/>
-          </a:prstGeom>
-          <a:solidFill>
-            <a:srgbClr val="223049"/>
-          </a:solidFill>
-          <a:ln>
-            <a:noFill/>
-          </a:ln>
-          <a:effectLst/>
-        </p:spPr>
-        <p:style>
-          <a:lnRef idx="1">
-            <a:schemeClr val="accent1"/>
-          </a:lnRef>
-          <a:fillRef idx="3">
-            <a:schemeClr val="accent1"/>
-          </a:fillRef>
-          <a:effectRef idx="2">
-            <a:schemeClr val="accent1"/>
-          </a:effectRef>
-          <a:fontRef idx="minor">
-            <a:schemeClr val="lt1"/>
-          </a:fontRef>
-        </p:style>
-        <p:txBody>
-          <a:bodyPr rtlCol="0" anchor="ctr"/>
-          <a:lstStyle/>
-          <a:p>
-            <a:pPr algn="ctr"/>
-          </a:p>
-        </p:txBody>
-      </p:sp>
-      <p:sp>
-        <p:nvSpPr>
-          <p:cNvPr id="34" name="Rectangle 33"/>
-          <p:cNvSpPr/>
-          <p:nvPr/>
-        </p:nvSpPr>
-        <p:spPr>
-          <a:xfrm>
-            <a:off x="9294745" y="6309360"/>
-            <a:ext cx="743145" cy="43891"/>
-          </a:xfrm>
-          <a:prstGeom prst="rect">
-            <a:avLst/>
-          </a:prstGeom>
-          <a:solidFill>
-            <a:srgbClr val="223049"/>
-          </a:solidFill>
-          <a:ln>
-            <a:noFill/>
-          </a:ln>
-          <a:effectLst/>
-        </p:spPr>
-        <p:style>
-          <a:lnRef idx="1">
-            <a:schemeClr val="accent1"/>
-          </a:lnRef>
-          <a:fillRef idx="3">
-            <a:schemeClr val="accent1"/>
-          </a:fillRef>
-          <a:effectRef idx="2">
-            <a:schemeClr val="accent1"/>
-          </a:effectRef>
-          <a:fontRef idx="minor">
-            <a:schemeClr val="lt1"/>
-          </a:fontRef>
-        </p:style>
-        <p:txBody>
-          <a:bodyPr rtlCol="0" anchor="ctr"/>
-          <a:lstStyle/>
-          <a:p>
-            <a:pPr algn="ctr"/>
-          </a:p>
-        </p:txBody>
-      </p:sp>
-      <p:sp>
-        <p:nvSpPr>
-          <p:cNvPr id="35" name="Rectangle 34"/>
-          <p:cNvSpPr/>
-          <p:nvPr/>
-        </p:nvSpPr>
-        <p:spPr>
-          <a:xfrm>
-            <a:off x="10088183" y="6309360"/>
-            <a:ext cx="743145" cy="43891"/>
-          </a:xfrm>
-          <a:prstGeom prst="rect">
-            <a:avLst/>
-          </a:prstGeom>
-          <a:solidFill>
-            <a:srgbClr val="223049"/>
-          </a:solidFill>
-          <a:ln>
-            <a:noFill/>
-          </a:ln>
-          <a:effectLst/>
-        </p:spPr>
-        <p:style>
-          <a:lnRef idx="1">
-            <a:schemeClr val="accent1"/>
-          </a:lnRef>
-          <a:fillRef idx="3">
-            <a:schemeClr val="accent1"/>
-          </a:fillRef>
-          <a:effectRef idx="2">
-            <a:schemeClr val="accent1"/>
-          </a:effectRef>
-          <a:fontRef idx="minor">
-            <a:schemeClr val="lt1"/>
-          </a:fontRef>
-        </p:style>
-        <p:txBody>
-          <a:bodyPr rtlCol="0" anchor="ctr"/>
-          <a:lstStyle/>
-          <a:p>
-            <a:pPr algn="ctr"/>
-          </a:p>
-        </p:txBody>
-      </p:sp>
-      <p:sp>
-        <p:nvSpPr>
-          <p:cNvPr id="36" name="Rectangle 35"/>
-          <p:cNvSpPr/>
-          <p:nvPr/>
-        </p:nvSpPr>
-        <p:spPr>
-          <a:xfrm>
-            <a:off x="10881621" y="6309360"/>
-            <a:ext cx="743145" cy="43891"/>
-          </a:xfrm>
-          <a:prstGeom prst="rect">
-            <a:avLst/>
-          </a:prstGeom>
-          <a:solidFill>
-            <a:srgbClr val="223049"/>
-          </a:solidFill>
-          <a:ln>
-            <a:noFill/>
-          </a:ln>
-          <a:effectLst/>
-        </p:spPr>
-        <p:style>
-          <a:lnRef idx="1">
-            <a:schemeClr val="accent1"/>
-          </a:lnRef>
-          <a:fillRef idx="3">
-            <a:schemeClr val="accent1"/>
-          </a:fillRef>
-          <a:effectRef idx="2">
-            <a:schemeClr val="accent1"/>
-          </a:effectRef>
-          <a:fontRef idx="minor">
-            <a:schemeClr val="lt1"/>
-          </a:fontRef>
-        </p:style>
-        <p:txBody>
-          <a:bodyPr rtlCol="0" anchor="ctr"/>
-          <a:lstStyle/>
-          <a:p>
-            <a:pPr algn="ctr"/>
-          </a:p>
-        </p:txBody>
-      </p:sp>
-      <p:sp>
-        <p:nvSpPr>
-          <p:cNvPr id="37" name="Rectangle 36"/>
-          <p:cNvSpPr/>
-          <p:nvPr/>
-        </p:nvSpPr>
-        <p:spPr>
-          <a:xfrm>
-            <a:off x="566928" y="6455664"/>
-            <a:ext cx="11057839" cy="9144"/>
-          </a:xfrm>
-          <a:prstGeom prst="rect">
-            <a:avLst/>
-          </a:prstGeom>
-          <a:solidFill>
-            <a:srgbClr val="223049"/>
-          </a:solidFill>
-          <a:ln>
-            <a:noFill/>
-          </a:ln>
-          <a:effectLst/>
-        </p:spPr>
-        <p:style>
-          <a:lnRef idx="1">
-            <a:schemeClr val="accent1"/>
-          </a:lnRef>
-          <a:fillRef idx="3">
-            <a:schemeClr val="accent1"/>
-          </a:fillRef>
-          <a:effectRef idx="2">
-            <a:schemeClr val="accent1"/>
-          </a:effectRef>
-          <a:fontRef idx="minor">
-            <a:schemeClr val="lt1"/>
-          </a:fontRef>
-        </p:style>
-        <p:txBody>
-          <a:bodyPr rtlCol="0" anchor="ctr"/>
-          <a:lstStyle/>
-          <a:p>
-            <a:pPr algn="ctr"/>
-          </a:p>
-        </p:txBody>
-      </p:sp>
-      <p:sp>
-        <p:nvSpPr>
-          <p:cNvPr id="38" name="TextBox 37"/>
+              <a:t>Complementary layers: reporting → risk priority → driver → suggested next step.</a:t>
+            </a:r>
+          </a:p>
+        </p:txBody>
+      </p:sp>
+      <p:sp>
+        <p:nvSpPr>
+          <p:cNvPr id="15" name="TextBox 14"/>
           <p:cNvSpPr txBox="1"/>
           <p:nvPr/>
         </p:nvSpPr>
         <p:spPr>
           <a:xfrm>
-            <a:off x="566928" y="6510528"/>
-            <a:ext cx="9509760" cy="219456"/>
+            <a:off x="566928" y="5897880"/>
+            <a:ext cx="11057839" cy="274320"/>
           </a:xfrm>
           <a:prstGeom prst="rect">
             <a:avLst/>
@@ -28634,6 +27680,708 @@
               </a:spcAft>
             </a:pPr>
             <a:r>
+              <a:rPr sz="1030" b="0">
+                <a:solidFill>
+                  <a:srgbClr val="8CA0BE"/>
+                </a:solidFill>
+                <a:latin typeface="Segoe UI"/>
+              </a:rPr>
+              <a:t>Decision support only: campaign uplift has not been measured; revenue figures are exposure, not confirmed savings.</a:t>
+            </a:r>
+          </a:p>
+        </p:txBody>
+      </p:sp>
+      <p:sp>
+        <p:nvSpPr>
+          <p:cNvPr id="16" name="Rectangle 15"/>
+          <p:cNvSpPr/>
+          <p:nvPr/>
+        </p:nvSpPr>
+        <p:spPr>
+          <a:xfrm>
+            <a:off x="566928" y="6296558"/>
+            <a:ext cx="743145" cy="68580"/>
+          </a:xfrm>
+          <a:prstGeom prst="rect">
+            <a:avLst/>
+          </a:prstGeom>
+          <a:solidFill>
+            <a:srgbClr val="2FD8B4"/>
+          </a:solidFill>
+          <a:ln>
+            <a:noFill/>
+          </a:ln>
+          <a:effectLst/>
+        </p:spPr>
+        <p:style>
+          <a:lnRef idx="1">
+            <a:schemeClr val="accent1"/>
+          </a:lnRef>
+          <a:fillRef idx="3">
+            <a:schemeClr val="accent1"/>
+          </a:fillRef>
+          <a:effectRef idx="2">
+            <a:schemeClr val="accent1"/>
+          </a:effectRef>
+          <a:fontRef idx="minor">
+            <a:schemeClr val="lt1"/>
+          </a:fontRef>
+        </p:style>
+        <p:txBody>
+          <a:bodyPr rtlCol="0" anchor="ctr"/>
+          <a:lstStyle/>
+          <a:p>
+            <a:pPr algn="ctr"/>
+          </a:p>
+        </p:txBody>
+      </p:sp>
+      <p:sp>
+        <p:nvSpPr>
+          <p:cNvPr id="17" name="Rectangle 16"/>
+          <p:cNvSpPr/>
+          <p:nvPr/>
+        </p:nvSpPr>
+        <p:spPr>
+          <a:xfrm>
+            <a:off x="1360365" y="6309360"/>
+            <a:ext cx="743145" cy="43891"/>
+          </a:xfrm>
+          <a:prstGeom prst="rect">
+            <a:avLst/>
+          </a:prstGeom>
+          <a:solidFill>
+            <a:srgbClr val="223049"/>
+          </a:solidFill>
+          <a:ln>
+            <a:noFill/>
+          </a:ln>
+          <a:effectLst/>
+        </p:spPr>
+        <p:style>
+          <a:lnRef idx="1">
+            <a:schemeClr val="accent1"/>
+          </a:lnRef>
+          <a:fillRef idx="3">
+            <a:schemeClr val="accent1"/>
+          </a:fillRef>
+          <a:effectRef idx="2">
+            <a:schemeClr val="accent1"/>
+          </a:effectRef>
+          <a:fontRef idx="minor">
+            <a:schemeClr val="lt1"/>
+          </a:fontRef>
+        </p:style>
+        <p:txBody>
+          <a:bodyPr rtlCol="0" anchor="ctr"/>
+          <a:lstStyle/>
+          <a:p>
+            <a:pPr algn="ctr"/>
+          </a:p>
+        </p:txBody>
+      </p:sp>
+      <p:sp>
+        <p:nvSpPr>
+          <p:cNvPr id="18" name="Rectangle 17"/>
+          <p:cNvSpPr/>
+          <p:nvPr/>
+        </p:nvSpPr>
+        <p:spPr>
+          <a:xfrm>
+            <a:off x="2153803" y="6309360"/>
+            <a:ext cx="743145" cy="43891"/>
+          </a:xfrm>
+          <a:prstGeom prst="rect">
+            <a:avLst/>
+          </a:prstGeom>
+          <a:solidFill>
+            <a:srgbClr val="223049"/>
+          </a:solidFill>
+          <a:ln>
+            <a:noFill/>
+          </a:ln>
+          <a:effectLst/>
+        </p:spPr>
+        <p:style>
+          <a:lnRef idx="1">
+            <a:schemeClr val="accent1"/>
+          </a:lnRef>
+          <a:fillRef idx="3">
+            <a:schemeClr val="accent1"/>
+          </a:fillRef>
+          <a:effectRef idx="2">
+            <a:schemeClr val="accent1"/>
+          </a:effectRef>
+          <a:fontRef idx="minor">
+            <a:schemeClr val="lt1"/>
+          </a:fontRef>
+        </p:style>
+        <p:txBody>
+          <a:bodyPr rtlCol="0" anchor="ctr"/>
+          <a:lstStyle/>
+          <a:p>
+            <a:pPr algn="ctr"/>
+          </a:p>
+        </p:txBody>
+      </p:sp>
+      <p:sp>
+        <p:nvSpPr>
+          <p:cNvPr id="19" name="Rectangle 18"/>
+          <p:cNvSpPr/>
+          <p:nvPr/>
+        </p:nvSpPr>
+        <p:spPr>
+          <a:xfrm>
+            <a:off x="2947241" y="6309360"/>
+            <a:ext cx="743145" cy="43891"/>
+          </a:xfrm>
+          <a:prstGeom prst="rect">
+            <a:avLst/>
+          </a:prstGeom>
+          <a:solidFill>
+            <a:srgbClr val="223049"/>
+          </a:solidFill>
+          <a:ln>
+            <a:noFill/>
+          </a:ln>
+          <a:effectLst/>
+        </p:spPr>
+        <p:style>
+          <a:lnRef idx="1">
+            <a:schemeClr val="accent1"/>
+          </a:lnRef>
+          <a:fillRef idx="3">
+            <a:schemeClr val="accent1"/>
+          </a:fillRef>
+          <a:effectRef idx="2">
+            <a:schemeClr val="accent1"/>
+          </a:effectRef>
+          <a:fontRef idx="minor">
+            <a:schemeClr val="lt1"/>
+          </a:fontRef>
+        </p:style>
+        <p:txBody>
+          <a:bodyPr rtlCol="0" anchor="ctr"/>
+          <a:lstStyle/>
+          <a:p>
+            <a:pPr algn="ctr"/>
+          </a:p>
+        </p:txBody>
+      </p:sp>
+      <p:sp>
+        <p:nvSpPr>
+          <p:cNvPr id="20" name="Rectangle 19"/>
+          <p:cNvSpPr/>
+          <p:nvPr/>
+        </p:nvSpPr>
+        <p:spPr>
+          <a:xfrm>
+            <a:off x="3740679" y="6309360"/>
+            <a:ext cx="743145" cy="43891"/>
+          </a:xfrm>
+          <a:prstGeom prst="rect">
+            <a:avLst/>
+          </a:prstGeom>
+          <a:solidFill>
+            <a:srgbClr val="223049"/>
+          </a:solidFill>
+          <a:ln>
+            <a:noFill/>
+          </a:ln>
+          <a:effectLst/>
+        </p:spPr>
+        <p:style>
+          <a:lnRef idx="1">
+            <a:schemeClr val="accent1"/>
+          </a:lnRef>
+          <a:fillRef idx="3">
+            <a:schemeClr val="accent1"/>
+          </a:fillRef>
+          <a:effectRef idx="2">
+            <a:schemeClr val="accent1"/>
+          </a:effectRef>
+          <a:fontRef idx="minor">
+            <a:schemeClr val="lt1"/>
+          </a:fontRef>
+        </p:style>
+        <p:txBody>
+          <a:bodyPr rtlCol="0" anchor="ctr"/>
+          <a:lstStyle/>
+          <a:p>
+            <a:pPr algn="ctr"/>
+          </a:p>
+        </p:txBody>
+      </p:sp>
+      <p:sp>
+        <p:nvSpPr>
+          <p:cNvPr id="21" name="Rectangle 20"/>
+          <p:cNvSpPr/>
+          <p:nvPr/>
+        </p:nvSpPr>
+        <p:spPr>
+          <a:xfrm>
+            <a:off x="4534117" y="6309360"/>
+            <a:ext cx="743145" cy="43891"/>
+          </a:xfrm>
+          <a:prstGeom prst="rect">
+            <a:avLst/>
+          </a:prstGeom>
+          <a:solidFill>
+            <a:srgbClr val="223049"/>
+          </a:solidFill>
+          <a:ln>
+            <a:noFill/>
+          </a:ln>
+          <a:effectLst/>
+        </p:spPr>
+        <p:style>
+          <a:lnRef idx="1">
+            <a:schemeClr val="accent1"/>
+          </a:lnRef>
+          <a:fillRef idx="3">
+            <a:schemeClr val="accent1"/>
+          </a:fillRef>
+          <a:effectRef idx="2">
+            <a:schemeClr val="accent1"/>
+          </a:effectRef>
+          <a:fontRef idx="minor">
+            <a:schemeClr val="lt1"/>
+          </a:fontRef>
+        </p:style>
+        <p:txBody>
+          <a:bodyPr rtlCol="0" anchor="ctr"/>
+          <a:lstStyle/>
+          <a:p>
+            <a:pPr algn="ctr"/>
+          </a:p>
+        </p:txBody>
+      </p:sp>
+      <p:sp>
+        <p:nvSpPr>
+          <p:cNvPr id="22" name="Rectangle 21"/>
+          <p:cNvSpPr/>
+          <p:nvPr/>
+        </p:nvSpPr>
+        <p:spPr>
+          <a:xfrm>
+            <a:off x="5327555" y="6309360"/>
+            <a:ext cx="743145" cy="43891"/>
+          </a:xfrm>
+          <a:prstGeom prst="rect">
+            <a:avLst/>
+          </a:prstGeom>
+          <a:solidFill>
+            <a:srgbClr val="223049"/>
+          </a:solidFill>
+          <a:ln>
+            <a:noFill/>
+          </a:ln>
+          <a:effectLst/>
+        </p:spPr>
+        <p:style>
+          <a:lnRef idx="1">
+            <a:schemeClr val="accent1"/>
+          </a:lnRef>
+          <a:fillRef idx="3">
+            <a:schemeClr val="accent1"/>
+          </a:fillRef>
+          <a:effectRef idx="2">
+            <a:schemeClr val="accent1"/>
+          </a:effectRef>
+          <a:fontRef idx="minor">
+            <a:schemeClr val="lt1"/>
+          </a:fontRef>
+        </p:style>
+        <p:txBody>
+          <a:bodyPr rtlCol="0" anchor="ctr"/>
+          <a:lstStyle/>
+          <a:p>
+            <a:pPr algn="ctr"/>
+          </a:p>
+        </p:txBody>
+      </p:sp>
+      <p:sp>
+        <p:nvSpPr>
+          <p:cNvPr id="23" name="Rectangle 22"/>
+          <p:cNvSpPr/>
+          <p:nvPr/>
+        </p:nvSpPr>
+        <p:spPr>
+          <a:xfrm>
+            <a:off x="6120993" y="6309360"/>
+            <a:ext cx="743145" cy="43891"/>
+          </a:xfrm>
+          <a:prstGeom prst="rect">
+            <a:avLst/>
+          </a:prstGeom>
+          <a:solidFill>
+            <a:srgbClr val="223049"/>
+          </a:solidFill>
+          <a:ln>
+            <a:noFill/>
+          </a:ln>
+          <a:effectLst/>
+        </p:spPr>
+        <p:style>
+          <a:lnRef idx="1">
+            <a:schemeClr val="accent1"/>
+          </a:lnRef>
+          <a:fillRef idx="3">
+            <a:schemeClr val="accent1"/>
+          </a:fillRef>
+          <a:effectRef idx="2">
+            <a:schemeClr val="accent1"/>
+          </a:effectRef>
+          <a:fontRef idx="minor">
+            <a:schemeClr val="lt1"/>
+          </a:fontRef>
+        </p:style>
+        <p:txBody>
+          <a:bodyPr rtlCol="0" anchor="ctr"/>
+          <a:lstStyle/>
+          <a:p>
+            <a:pPr algn="ctr"/>
+          </a:p>
+        </p:txBody>
+      </p:sp>
+      <p:sp>
+        <p:nvSpPr>
+          <p:cNvPr id="24" name="Rectangle 23"/>
+          <p:cNvSpPr/>
+          <p:nvPr/>
+        </p:nvSpPr>
+        <p:spPr>
+          <a:xfrm>
+            <a:off x="6914431" y="6309360"/>
+            <a:ext cx="743145" cy="43891"/>
+          </a:xfrm>
+          <a:prstGeom prst="rect">
+            <a:avLst/>
+          </a:prstGeom>
+          <a:solidFill>
+            <a:srgbClr val="223049"/>
+          </a:solidFill>
+          <a:ln>
+            <a:noFill/>
+          </a:ln>
+          <a:effectLst/>
+        </p:spPr>
+        <p:style>
+          <a:lnRef idx="1">
+            <a:schemeClr val="accent1"/>
+          </a:lnRef>
+          <a:fillRef idx="3">
+            <a:schemeClr val="accent1"/>
+          </a:fillRef>
+          <a:effectRef idx="2">
+            <a:schemeClr val="accent1"/>
+          </a:effectRef>
+          <a:fontRef idx="minor">
+            <a:schemeClr val="lt1"/>
+          </a:fontRef>
+        </p:style>
+        <p:txBody>
+          <a:bodyPr rtlCol="0" anchor="ctr"/>
+          <a:lstStyle/>
+          <a:p>
+            <a:pPr algn="ctr"/>
+          </a:p>
+        </p:txBody>
+      </p:sp>
+      <p:sp>
+        <p:nvSpPr>
+          <p:cNvPr id="25" name="Rectangle 24"/>
+          <p:cNvSpPr/>
+          <p:nvPr/>
+        </p:nvSpPr>
+        <p:spPr>
+          <a:xfrm>
+            <a:off x="7707869" y="6309360"/>
+            <a:ext cx="743145" cy="43891"/>
+          </a:xfrm>
+          <a:prstGeom prst="rect">
+            <a:avLst/>
+          </a:prstGeom>
+          <a:solidFill>
+            <a:srgbClr val="223049"/>
+          </a:solidFill>
+          <a:ln>
+            <a:noFill/>
+          </a:ln>
+          <a:effectLst/>
+        </p:spPr>
+        <p:style>
+          <a:lnRef idx="1">
+            <a:schemeClr val="accent1"/>
+          </a:lnRef>
+          <a:fillRef idx="3">
+            <a:schemeClr val="accent1"/>
+          </a:fillRef>
+          <a:effectRef idx="2">
+            <a:schemeClr val="accent1"/>
+          </a:effectRef>
+          <a:fontRef idx="minor">
+            <a:schemeClr val="lt1"/>
+          </a:fontRef>
+        </p:style>
+        <p:txBody>
+          <a:bodyPr rtlCol="0" anchor="ctr"/>
+          <a:lstStyle/>
+          <a:p>
+            <a:pPr algn="ctr"/>
+          </a:p>
+        </p:txBody>
+      </p:sp>
+      <p:sp>
+        <p:nvSpPr>
+          <p:cNvPr id="26" name="Rectangle 25"/>
+          <p:cNvSpPr/>
+          <p:nvPr/>
+        </p:nvSpPr>
+        <p:spPr>
+          <a:xfrm>
+            <a:off x="8501307" y="6309360"/>
+            <a:ext cx="743145" cy="43891"/>
+          </a:xfrm>
+          <a:prstGeom prst="rect">
+            <a:avLst/>
+          </a:prstGeom>
+          <a:solidFill>
+            <a:srgbClr val="223049"/>
+          </a:solidFill>
+          <a:ln>
+            <a:noFill/>
+          </a:ln>
+          <a:effectLst/>
+        </p:spPr>
+        <p:style>
+          <a:lnRef idx="1">
+            <a:schemeClr val="accent1"/>
+          </a:lnRef>
+          <a:fillRef idx="3">
+            <a:schemeClr val="accent1"/>
+          </a:fillRef>
+          <a:effectRef idx="2">
+            <a:schemeClr val="accent1"/>
+          </a:effectRef>
+          <a:fontRef idx="minor">
+            <a:schemeClr val="lt1"/>
+          </a:fontRef>
+        </p:style>
+        <p:txBody>
+          <a:bodyPr rtlCol="0" anchor="ctr"/>
+          <a:lstStyle/>
+          <a:p>
+            <a:pPr algn="ctr"/>
+          </a:p>
+        </p:txBody>
+      </p:sp>
+      <p:sp>
+        <p:nvSpPr>
+          <p:cNvPr id="27" name="Rectangle 26"/>
+          <p:cNvSpPr/>
+          <p:nvPr/>
+        </p:nvSpPr>
+        <p:spPr>
+          <a:xfrm>
+            <a:off x="9294745" y="6309360"/>
+            <a:ext cx="743145" cy="43891"/>
+          </a:xfrm>
+          <a:prstGeom prst="rect">
+            <a:avLst/>
+          </a:prstGeom>
+          <a:solidFill>
+            <a:srgbClr val="223049"/>
+          </a:solidFill>
+          <a:ln>
+            <a:noFill/>
+          </a:ln>
+          <a:effectLst/>
+        </p:spPr>
+        <p:style>
+          <a:lnRef idx="1">
+            <a:schemeClr val="accent1"/>
+          </a:lnRef>
+          <a:fillRef idx="3">
+            <a:schemeClr val="accent1"/>
+          </a:fillRef>
+          <a:effectRef idx="2">
+            <a:schemeClr val="accent1"/>
+          </a:effectRef>
+          <a:fontRef idx="minor">
+            <a:schemeClr val="lt1"/>
+          </a:fontRef>
+        </p:style>
+        <p:txBody>
+          <a:bodyPr rtlCol="0" anchor="ctr"/>
+          <a:lstStyle/>
+          <a:p>
+            <a:pPr algn="ctr"/>
+          </a:p>
+        </p:txBody>
+      </p:sp>
+      <p:sp>
+        <p:nvSpPr>
+          <p:cNvPr id="28" name="Rectangle 27"/>
+          <p:cNvSpPr/>
+          <p:nvPr/>
+        </p:nvSpPr>
+        <p:spPr>
+          <a:xfrm>
+            <a:off x="10088183" y="6309360"/>
+            <a:ext cx="743145" cy="43891"/>
+          </a:xfrm>
+          <a:prstGeom prst="rect">
+            <a:avLst/>
+          </a:prstGeom>
+          <a:solidFill>
+            <a:srgbClr val="223049"/>
+          </a:solidFill>
+          <a:ln>
+            <a:noFill/>
+          </a:ln>
+          <a:effectLst/>
+        </p:spPr>
+        <p:style>
+          <a:lnRef idx="1">
+            <a:schemeClr val="accent1"/>
+          </a:lnRef>
+          <a:fillRef idx="3">
+            <a:schemeClr val="accent1"/>
+          </a:fillRef>
+          <a:effectRef idx="2">
+            <a:schemeClr val="accent1"/>
+          </a:effectRef>
+          <a:fontRef idx="minor">
+            <a:schemeClr val="lt1"/>
+          </a:fontRef>
+        </p:style>
+        <p:txBody>
+          <a:bodyPr rtlCol="0" anchor="ctr"/>
+          <a:lstStyle/>
+          <a:p>
+            <a:pPr algn="ctr"/>
+          </a:p>
+        </p:txBody>
+      </p:sp>
+      <p:sp>
+        <p:nvSpPr>
+          <p:cNvPr id="29" name="Rectangle 28"/>
+          <p:cNvSpPr/>
+          <p:nvPr/>
+        </p:nvSpPr>
+        <p:spPr>
+          <a:xfrm>
+            <a:off x="10881621" y="6309360"/>
+            <a:ext cx="743145" cy="43891"/>
+          </a:xfrm>
+          <a:prstGeom prst="rect">
+            <a:avLst/>
+          </a:prstGeom>
+          <a:solidFill>
+            <a:srgbClr val="223049"/>
+          </a:solidFill>
+          <a:ln>
+            <a:noFill/>
+          </a:ln>
+          <a:effectLst/>
+        </p:spPr>
+        <p:style>
+          <a:lnRef idx="1">
+            <a:schemeClr val="accent1"/>
+          </a:lnRef>
+          <a:fillRef idx="3">
+            <a:schemeClr val="accent1"/>
+          </a:fillRef>
+          <a:effectRef idx="2">
+            <a:schemeClr val="accent1"/>
+          </a:effectRef>
+          <a:fontRef idx="minor">
+            <a:schemeClr val="lt1"/>
+          </a:fontRef>
+        </p:style>
+        <p:txBody>
+          <a:bodyPr rtlCol="0" anchor="ctr"/>
+          <a:lstStyle/>
+          <a:p>
+            <a:pPr algn="ctr"/>
+          </a:p>
+        </p:txBody>
+      </p:sp>
+      <p:sp>
+        <p:nvSpPr>
+          <p:cNvPr id="30" name="Rectangle 29"/>
+          <p:cNvSpPr/>
+          <p:nvPr/>
+        </p:nvSpPr>
+        <p:spPr>
+          <a:xfrm>
+            <a:off x="566928" y="6455664"/>
+            <a:ext cx="11057839" cy="9144"/>
+          </a:xfrm>
+          <a:prstGeom prst="rect">
+            <a:avLst/>
+          </a:prstGeom>
+          <a:solidFill>
+            <a:srgbClr val="223049"/>
+          </a:solidFill>
+          <a:ln>
+            <a:noFill/>
+          </a:ln>
+          <a:effectLst/>
+        </p:spPr>
+        <p:style>
+          <a:lnRef idx="1">
+            <a:schemeClr val="accent1"/>
+          </a:lnRef>
+          <a:fillRef idx="3">
+            <a:schemeClr val="accent1"/>
+          </a:fillRef>
+          <a:effectRef idx="2">
+            <a:schemeClr val="accent1"/>
+          </a:effectRef>
+          <a:fontRef idx="minor">
+            <a:schemeClr val="lt1"/>
+          </a:fontRef>
+        </p:style>
+        <p:txBody>
+          <a:bodyPr rtlCol="0" anchor="ctr"/>
+          <a:lstStyle/>
+          <a:p>
+            <a:pPr algn="ctr"/>
+          </a:p>
+        </p:txBody>
+      </p:sp>
+      <p:sp>
+        <p:nvSpPr>
+          <p:cNvPr id="31" name="TextBox 30"/>
+          <p:cNvSpPr txBox="1"/>
+          <p:nvPr/>
+        </p:nvSpPr>
+        <p:spPr>
+          <a:xfrm>
+            <a:off x="566928" y="6510528"/>
+            <a:ext cx="9509760" cy="219456"/>
+          </a:xfrm>
+          <a:prstGeom prst="rect">
+            <a:avLst/>
+          </a:prstGeom>
+          <a:noFill/>
+        </p:spPr>
+        <p:txBody>
+          <a:bodyPr wrap="square" lIns="0" rIns="0" tIns="0" bIns="0" anchor="t">
+            <a:spAutoFit/>
+          </a:bodyPr>
+          <a:lstStyle/>
+          <a:p>
+            <a:pPr algn="l">
+              <a:lnSpc>
+                <a:spcPct val="112000"/>
+              </a:lnSpc>
+              <a:spcAft>
+                <a:spcPts val="0"/>
+              </a:spcAft>
+            </a:pPr>
+            <a:r>
               <a:rPr sz="900" b="0">
                 <a:solidFill>
                   <a:srgbClr val="8CA0BE"/>
@@ -28647,7 +28395,7 @@
       </p:sp>
       <p:sp>
         <p:nvSpPr>
-          <p:cNvPr id="39" name="TextBox 38"/>
+          <p:cNvPr id="32" name="TextBox 31"/>
           <p:cNvSpPr txBox="1"/>
           <p:nvPr/>
         </p:nvSpPr>

</xml_diff>

<commit_message>
Redesign deployment slide with clearer visual hierarchy
Rework the deployment slide into a numbered risk-to-mitigation grid and a compact runtime stack strip, improving scanability while preserving operational caveats.

Co-authored-by: arena-agent <297053741+arena-agent@users.noreply.github.com>
</commit_message>
<xml_diff>
--- a/presentation/RetainIQ_Project_Review.pptx
+++ b/presentation/RetainIQ_Project_Review.pptx
@@ -20784,7 +20784,7 @@
         <p:spPr>
           <a:xfrm>
             <a:off x="566928" y="1664207"/>
-            <a:ext cx="32004" cy="1481327"/>
+            <a:ext cx="41148" cy="1481327"/>
           </a:xfrm>
           <a:prstGeom prst="rect">
             <a:avLst/>
@@ -20827,8 +20827,8 @@
         </p:nvSpPr>
         <p:spPr>
           <a:xfrm>
-            <a:off x="786384" y="1682495"/>
-            <a:ext cx="4952847" cy="1444751"/>
+            <a:off x="731520" y="1719072"/>
+            <a:ext cx="621792" cy="384048"/>
           </a:xfrm>
           <a:prstGeom prst="rect">
             <a:avLst/>
@@ -20840,44 +20840,6 @@
             <a:spAutoFit/>
           </a:bodyPr>
           <a:lstStyle/>
-          <a:p>
-            <a:pPr algn="l">
-              <a:lnSpc>
-                <a:spcPct val="112000"/>
-              </a:lnSpc>
-              <a:spcAft>
-                <a:spcPts val="400"/>
-              </a:spcAft>
-            </a:pPr>
-            <a:r>
-              <a:rPr sz="1200" b="1">
-                <a:solidFill>
-                  <a:srgbClr val="EAF0F7"/>
-                </a:solidFill>
-                <a:latin typeface="Segoe UI"/>
-              </a:rPr>
-              <a:t>Slow scoring on a shared CPU</a:t>
-            </a:r>
-          </a:p>
-          <a:p>
-            <a:pPr algn="l">
-              <a:lnSpc>
-                <a:spcPct val="116000"/>
-              </a:lnSpc>
-              <a:spcAft>
-                <a:spcPts val="500"/>
-              </a:spcAft>
-            </a:pPr>
-            <a:r>
-              <a:rPr sz="1019" b="0">
-                <a:solidFill>
-                  <a:srgbClr val="8CA0BE"/>
-                </a:solidFill>
-                <a:latin typeface="Segoe UI"/>
-              </a:rPr>
-              <a:t>A large CSV can take far longer than the default 30-second worker timeout, so the worker is killed mid-request and the browser shows a 502.</a:t>
-            </a:r>
-          </a:p>
           <a:p>
             <a:pPr algn="l">
               <a:lnSpc>
@@ -20888,119 +20850,27 @@
               </a:spcAft>
             </a:pPr>
             <a:r>
-              <a:rPr sz="1040" b="1">
+              <a:rPr sz="2200" b="1">
                 <a:solidFill>
                   <a:srgbClr val="2FD8B4"/>
                 </a:solidFill>
                 <a:latin typeface="Consolas"/>
               </a:rPr>
-              <a:t>→ fixed by 300-second timeout</a:t>
-            </a:r>
-          </a:p>
-        </p:txBody>
-      </p:sp>
-      <p:sp>
-        <p:nvSpPr>
-          <p:cNvPr id="10" name="Rounded Rectangle 9"/>
-          <p:cNvSpPr/>
-          <p:nvPr/>
-        </p:nvSpPr>
-        <p:spPr>
-          <a:xfrm>
-            <a:off x="6214719" y="1517904"/>
-            <a:ext cx="5410047" cy="1773935"/>
-          </a:xfrm>
-          <a:prstGeom prst="roundRect">
-            <a:avLst>
-              <a:gd name="adj" fmla="val 8000"/>
-            </a:avLst>
-          </a:prstGeom>
-          <a:solidFill>
-            <a:srgbClr val="111A2C"/>
-          </a:solidFill>
-          <a:ln w="12700">
-            <a:solidFill>
-              <a:srgbClr val="223049"/>
-            </a:solidFill>
-          </a:ln>
-          <a:effectLst/>
-        </p:spPr>
-        <p:style>
-          <a:lnRef idx="1">
-            <a:schemeClr val="accent1"/>
-          </a:lnRef>
-          <a:fillRef idx="3">
-            <a:schemeClr val="accent1"/>
-          </a:fillRef>
-          <a:effectRef idx="2">
-            <a:schemeClr val="accent1"/>
-          </a:effectRef>
-          <a:fontRef idx="minor">
-            <a:schemeClr val="lt1"/>
-          </a:fontRef>
-        </p:style>
-        <p:txBody>
-          <a:bodyPr rtlCol="0" anchor="ctr"/>
-          <a:lstStyle/>
-          <a:p>
-            <a:pPr algn="ctr"/>
-          </a:p>
-        </p:txBody>
-      </p:sp>
-      <p:sp>
-        <p:nvSpPr>
-          <p:cNvPr id="11" name="Rectangle 10"/>
-          <p:cNvSpPr/>
-          <p:nvPr/>
-        </p:nvSpPr>
-        <p:spPr>
-          <a:xfrm>
-            <a:off x="6214719" y="1664207"/>
-            <a:ext cx="32004" cy="1481327"/>
-          </a:xfrm>
-          <a:prstGeom prst="rect">
-            <a:avLst/>
-          </a:prstGeom>
-          <a:solidFill>
-            <a:srgbClr val="2FD8B4"/>
-          </a:solidFill>
-          <a:ln>
-            <a:noFill/>
-          </a:ln>
-          <a:effectLst/>
-        </p:spPr>
-        <p:style>
-          <a:lnRef idx="1">
-            <a:schemeClr val="accent1"/>
-          </a:lnRef>
-          <a:fillRef idx="3">
-            <a:schemeClr val="accent1"/>
-          </a:fillRef>
-          <a:effectRef idx="2">
-            <a:schemeClr val="accent1"/>
-          </a:effectRef>
-          <a:fontRef idx="minor">
-            <a:schemeClr val="lt1"/>
-          </a:fontRef>
-        </p:style>
-        <p:txBody>
-          <a:bodyPr rtlCol="0" anchor="ctr"/>
-          <a:lstStyle/>
-          <a:p>
-            <a:pPr algn="ctr"/>
-          </a:p>
-        </p:txBody>
-      </p:sp>
-      <p:sp>
-        <p:nvSpPr>
-          <p:cNvPr id="12" name="TextBox 11"/>
+              <a:t>01</a:t>
+            </a:r>
+          </a:p>
+        </p:txBody>
+      </p:sp>
+      <p:sp>
+        <p:nvSpPr>
+          <p:cNvPr id="10" name="TextBox 9"/>
           <p:cNvSpPr txBox="1"/>
           <p:nvPr/>
         </p:nvSpPr>
         <p:spPr>
           <a:xfrm>
-            <a:off x="6434175" y="1682495"/>
-            <a:ext cx="4952847" cy="1444751"/>
+            <a:off x="731520" y="2221991"/>
+            <a:ext cx="749808" cy="256032"/>
           </a:xfrm>
           <a:prstGeom prst="rect">
             <a:avLst/>
@@ -21012,44 +20882,6 @@
             <a:spAutoFit/>
           </a:bodyPr>
           <a:lstStyle/>
-          <a:p>
-            <a:pPr algn="l">
-              <a:lnSpc>
-                <a:spcPct val="112000"/>
-              </a:lnSpc>
-              <a:spcAft>
-                <a:spcPts val="400"/>
-              </a:spcAft>
-            </a:pPr>
-            <a:r>
-              <a:rPr sz="1200" b="1">
-                <a:solidFill>
-                  <a:srgbClr val="EAF0F7"/>
-                </a:solidFill>
-                <a:latin typeface="Segoe UI"/>
-              </a:rPr>
-              <a:t>Reloading the model per request</a:t>
-            </a:r>
-          </a:p>
-          <a:p>
-            <a:pPr algn="l">
-              <a:lnSpc>
-                <a:spcPct val="116000"/>
-              </a:lnSpc>
-              <a:spcAft>
-                <a:spcPts val="500"/>
-              </a:spcAft>
-            </a:pPr>
-            <a:r>
-              <a:rPr sz="1019" b="0">
-                <a:solidFill>
-                  <a:srgbClr val="8CA0BE"/>
-                </a:solidFill>
-                <a:latin typeface="Segoe UI"/>
-              </a:rPr>
-              <a:t>Reading the pickled model on every request wastes the little memory the instance has.</a:t>
-            </a:r>
-          </a:p>
           <a:p>
             <a:pPr algn="l">
               <a:lnSpc>
@@ -21060,81 +20892,33 @@
               </a:spcAft>
             </a:pPr>
             <a:r>
-              <a:rPr sz="1040" b="1">
+              <a:rPr sz="819" b="1">
                 <a:solidFill>
-                  <a:srgbClr val="2FD8B4"/>
+                  <a:srgbClr val="8CA0BE"/>
                 </a:solidFill>
                 <a:latin typeface="Consolas"/>
               </a:rPr>
-              <a:t>→ fixed by worker preload</a:t>
-            </a:r>
-          </a:p>
-        </p:txBody>
-      </p:sp>
-      <p:sp>
-        <p:nvSpPr>
-          <p:cNvPr id="13" name="Rounded Rectangle 12"/>
-          <p:cNvSpPr/>
-          <p:nvPr/>
-        </p:nvSpPr>
-        <p:spPr>
-          <a:xfrm>
-            <a:off x="566928" y="3438144"/>
-            <a:ext cx="5410047" cy="1773935"/>
-          </a:xfrm>
-          <a:prstGeom prst="roundRect">
-            <a:avLst>
-              <a:gd name="adj" fmla="val 8000"/>
-            </a:avLst>
-          </a:prstGeom>
-          <a:solidFill>
-            <a:srgbClr val="111A2C"/>
-          </a:solidFill>
-          <a:ln w="12700">
-            <a:solidFill>
-              <a:srgbClr val="223049"/>
-            </a:solidFill>
-          </a:ln>
-          <a:effectLst/>
-        </p:spPr>
-        <p:style>
-          <a:lnRef idx="1">
-            <a:schemeClr val="accent1"/>
-          </a:lnRef>
-          <a:fillRef idx="3">
-            <a:schemeClr val="accent1"/>
-          </a:fillRef>
-          <a:effectRef idx="2">
-            <a:schemeClr val="accent1"/>
-          </a:effectRef>
-          <a:fontRef idx="minor">
-            <a:schemeClr val="lt1"/>
-          </a:fontRef>
-        </p:style>
-        <p:txBody>
-          <a:bodyPr rtlCol="0" anchor="ctr"/>
-          <a:lstStyle/>
-          <a:p>
-            <a:pPr algn="ctr"/>
-          </a:p>
-        </p:txBody>
-      </p:sp>
-      <p:sp>
-        <p:nvSpPr>
-          <p:cNvPr id="14" name="Rectangle 13"/>
-          <p:cNvSpPr/>
-          <p:nvPr/>
-        </p:nvSpPr>
-        <p:spPr>
-          <a:xfrm>
-            <a:off x="566928" y="3584448"/>
-            <a:ext cx="32004" cy="1481327"/>
-          </a:xfrm>
-          <a:prstGeom prst="rect">
-            <a:avLst/>
-          </a:prstGeom>
-          <a:solidFill>
-            <a:srgbClr val="2FD8B4"/>
+              <a:t>LATENCY</a:t>
+            </a:r>
+          </a:p>
+        </p:txBody>
+      </p:sp>
+      <p:sp>
+        <p:nvSpPr>
+          <p:cNvPr id="11" name="Rectangle 10"/>
+          <p:cNvSpPr/>
+          <p:nvPr/>
+        </p:nvSpPr>
+        <p:spPr>
+          <a:xfrm>
+            <a:off x="1481328" y="1700784"/>
+            <a:ext cx="22860" cy="1408175"/>
+          </a:xfrm>
+          <a:prstGeom prst="rect">
+            <a:avLst/>
+          </a:prstGeom>
+          <a:solidFill>
+            <a:srgbClr val="223049"/>
           </a:solidFill>
           <a:ln>
             <a:noFill/>
@@ -21165,14 +20949,14 @@
       </p:sp>
       <p:sp>
         <p:nvSpPr>
-          <p:cNvPr id="15" name="TextBox 14"/>
+          <p:cNvPr id="12" name="TextBox 11"/>
           <p:cNvSpPr txBox="1"/>
           <p:nvPr/>
         </p:nvSpPr>
         <p:spPr>
           <a:xfrm>
-            <a:off x="786384" y="3602736"/>
-            <a:ext cx="4952847" cy="1444751"/>
+            <a:off x="1645919" y="1682495"/>
+            <a:ext cx="4111599" cy="292608"/>
           </a:xfrm>
           <a:prstGeom prst="rect">
             <a:avLst/>
@@ -21184,44 +20968,6 @@
             <a:spAutoFit/>
           </a:bodyPr>
           <a:lstStyle/>
-          <a:p>
-            <a:pPr algn="l">
-              <a:lnSpc>
-                <a:spcPct val="112000"/>
-              </a:lnSpc>
-              <a:spcAft>
-                <a:spcPts val="400"/>
-              </a:spcAft>
-            </a:pPr>
-            <a:r>
-              <a:rPr sz="1200" b="1">
-                <a:solidFill>
-                  <a:srgbClr val="EAF0F7"/>
-                </a:solidFill>
-                <a:latin typeface="Segoe UI"/>
-              </a:rPr>
-              <a:t>Memory creeping past the limit</a:t>
-            </a:r>
-          </a:p>
-          <a:p>
-            <a:pPr algn="l">
-              <a:lnSpc>
-                <a:spcPct val="116000"/>
-              </a:lnSpc>
-              <a:spcAft>
-                <a:spcPts val="500"/>
-              </a:spcAft>
-            </a:pPr>
-            <a:r>
-              <a:rPr sz="1019" b="0">
-                <a:solidFill>
-                  <a:srgbClr val="8CA0BE"/>
-                </a:solidFill>
-                <a:latin typeface="Segoe UI"/>
-              </a:rPr>
-              <a:t>A long-lived worker grows until the platform OOM-kills it, which surfaces as a random error.</a:t>
-            </a:r>
-          </a:p>
           <a:p>
             <a:pPr algn="l">
               <a:lnSpc>
@@ -21232,168 +20978,128 @@
               </a:spcAft>
             </a:pPr>
             <a:r>
-              <a:rPr sz="1040" b="1">
-                <a:solidFill>
-                  <a:srgbClr val="2FD8B4"/>
-                </a:solidFill>
-                <a:latin typeface="Consolas"/>
-              </a:rPr>
-              <a:t>→ fixed by request recycling</a:t>
-            </a:r>
-          </a:p>
-        </p:txBody>
-      </p:sp>
-      <p:sp>
-        <p:nvSpPr>
-          <p:cNvPr id="16" name="Rounded Rectangle 15"/>
-          <p:cNvSpPr/>
-          <p:nvPr/>
-        </p:nvSpPr>
-        <p:spPr>
-          <a:xfrm>
-            <a:off x="6214719" y="3438144"/>
-            <a:ext cx="5410047" cy="1773935"/>
-          </a:xfrm>
-          <a:prstGeom prst="roundRect">
-            <a:avLst>
-              <a:gd name="adj" fmla="val 8000"/>
-            </a:avLst>
-          </a:prstGeom>
-          <a:solidFill>
-            <a:srgbClr val="111A2C"/>
-          </a:solidFill>
-          <a:ln w="12700">
-            <a:solidFill>
-              <a:srgbClr val="223049"/>
-            </a:solidFill>
-          </a:ln>
-          <a:effectLst/>
-        </p:spPr>
-        <p:style>
-          <a:lnRef idx="1">
-            <a:schemeClr val="accent1"/>
-          </a:lnRef>
-          <a:fillRef idx="3">
-            <a:schemeClr val="accent1"/>
-          </a:fillRef>
-          <a:effectRef idx="2">
-            <a:schemeClr val="accent1"/>
-          </a:effectRef>
-          <a:fontRef idx="minor">
-            <a:schemeClr val="lt1"/>
-          </a:fontRef>
-        </p:style>
-        <p:txBody>
-          <a:bodyPr rtlCol="0" anchor="ctr"/>
-          <a:lstStyle/>
-          <a:p>
-            <a:pPr algn="ctr"/>
-          </a:p>
-        </p:txBody>
-      </p:sp>
-      <p:sp>
-        <p:nvSpPr>
-          <p:cNvPr id="17" name="Rectangle 16"/>
-          <p:cNvSpPr/>
-          <p:nvPr/>
-        </p:nvSpPr>
-        <p:spPr>
-          <a:xfrm>
-            <a:off x="6214719" y="3584448"/>
-            <a:ext cx="32004" cy="1481327"/>
-          </a:xfrm>
-          <a:prstGeom prst="rect">
-            <a:avLst/>
-          </a:prstGeom>
-          <a:solidFill>
-            <a:srgbClr val="F5A623"/>
-          </a:solidFill>
-          <a:ln>
-            <a:noFill/>
-          </a:ln>
-          <a:effectLst/>
-        </p:spPr>
-        <p:style>
-          <a:lnRef idx="1">
-            <a:schemeClr val="accent1"/>
-          </a:lnRef>
-          <a:fillRef idx="3">
-            <a:schemeClr val="accent1"/>
-          </a:fillRef>
-          <a:effectRef idx="2">
-            <a:schemeClr val="accent1"/>
-          </a:effectRef>
-          <a:fontRef idx="minor">
-            <a:schemeClr val="lt1"/>
-          </a:fontRef>
-        </p:style>
-        <p:txBody>
-          <a:bodyPr rtlCol="0" anchor="ctr"/>
-          <a:lstStyle/>
-          <a:p>
-            <a:pPr algn="ctr"/>
-          </a:p>
-        </p:txBody>
-      </p:sp>
-      <p:sp>
-        <p:nvSpPr>
-          <p:cNvPr id="18" name="TextBox 17"/>
-          <p:cNvSpPr txBox="1"/>
-          <p:nvPr/>
-        </p:nvSpPr>
-        <p:spPr>
-          <a:xfrm>
-            <a:off x="6434175" y="3602736"/>
-            <a:ext cx="4952847" cy="1444751"/>
-          </a:xfrm>
-          <a:prstGeom prst="rect">
-            <a:avLst/>
-          </a:prstGeom>
-          <a:noFill/>
-        </p:spPr>
-        <p:txBody>
-          <a:bodyPr wrap="square" lIns="0" rIns="0" tIns="0" bIns="0" anchor="t">
-            <a:spAutoFit/>
-          </a:bodyPr>
-          <a:lstStyle/>
-          <a:p>
-            <a:pPr algn="l">
-              <a:lnSpc>
-                <a:spcPct val="112000"/>
-              </a:lnSpc>
-              <a:spcAft>
-                <a:spcPts val="400"/>
-              </a:spcAft>
-            </a:pPr>
-            <a:r>
-              <a:rPr sz="1200" b="1">
+              <a:rPr sz="1220" b="1">
                 <a:solidFill>
                   <a:srgbClr val="EAF0F7"/>
                 </a:solidFill>
                 <a:latin typeface="Segoe UI"/>
               </a:rPr>
-              <a:t>The free tier sleeps</a:t>
-            </a:r>
-          </a:p>
+              <a:t>Slow bulk scoring</a:t>
+            </a:r>
+          </a:p>
+        </p:txBody>
+      </p:sp>
+      <p:sp>
+        <p:nvSpPr>
+          <p:cNvPr id="13" name="TextBox 12"/>
+          <p:cNvSpPr txBox="1"/>
+          <p:nvPr/>
+        </p:nvSpPr>
+        <p:spPr>
+          <a:xfrm>
+            <a:off x="1645919" y="2029967"/>
+            <a:ext cx="4111599" cy="612648"/>
+          </a:xfrm>
+          <a:prstGeom prst="rect">
+            <a:avLst/>
+          </a:prstGeom>
+          <a:noFill/>
+        </p:spPr>
+        <p:txBody>
+          <a:bodyPr wrap="square" lIns="0" rIns="0" tIns="0" bIns="0" anchor="t">
+            <a:spAutoFit/>
+          </a:bodyPr>
+          <a:lstStyle/>
           <a:p>
             <a:pPr algn="l">
               <a:lnSpc>
                 <a:spcPct val="116000"/>
               </a:lnSpc>
               <a:spcAft>
-                <a:spcPts val="500"/>
+                <a:spcPts val="0"/>
               </a:spcAft>
             </a:pPr>
             <a:r>
-              <a:rPr sz="1019" b="0">
+              <a:rPr sz="1040" b="0">
                 <a:solidFill>
                   <a:srgbClr val="8CA0BE"/>
                 </a:solidFill>
                 <a:latin typeface="Segoe UI"/>
               </a:rPr>
-              <a:t>An idle instance is suspended, so the first visitor waits for a cold start.</a:t>
-            </a:r>
-          </a:p>
+              <a:t>A large CSV can outlast the default 30-second timeout, killing the worker and returning a 502.</a:t>
+            </a:r>
+          </a:p>
+        </p:txBody>
+      </p:sp>
+      <p:sp>
+        <p:nvSpPr>
+          <p:cNvPr id="14" name="Rounded Rectangle 13"/>
+          <p:cNvSpPr/>
+          <p:nvPr/>
+        </p:nvSpPr>
+        <p:spPr>
+          <a:xfrm>
+            <a:off x="1645919" y="2852927"/>
+            <a:ext cx="4111599" cy="274320"/>
+          </a:xfrm>
+          <a:prstGeom prst="roundRect">
+            <a:avLst>
+              <a:gd name="adj" fmla="val 8000"/>
+            </a:avLst>
+          </a:prstGeom>
+          <a:solidFill>
+            <a:srgbClr val="162136"/>
+          </a:solidFill>
+          <a:ln w="10160">
+            <a:solidFill>
+              <a:srgbClr val="2FD8B4"/>
+            </a:solidFill>
+          </a:ln>
+          <a:effectLst/>
+        </p:spPr>
+        <p:style>
+          <a:lnRef idx="1">
+            <a:schemeClr val="accent1"/>
+          </a:lnRef>
+          <a:fillRef idx="3">
+            <a:schemeClr val="accent1"/>
+          </a:fillRef>
+          <a:effectRef idx="2">
+            <a:schemeClr val="accent1"/>
+          </a:effectRef>
+          <a:fontRef idx="minor">
+            <a:schemeClr val="lt1"/>
+          </a:fontRef>
+        </p:style>
+        <p:txBody>
+          <a:bodyPr rtlCol="0" anchor="ctr"/>
+          <a:lstStyle/>
+          <a:p>
+            <a:pPr algn="ctr"/>
+          </a:p>
+        </p:txBody>
+      </p:sp>
+      <p:sp>
+        <p:nvSpPr>
+          <p:cNvPr id="15" name="TextBox 14"/>
+          <p:cNvSpPr txBox="1"/>
+          <p:nvPr/>
+        </p:nvSpPr>
+        <p:spPr>
+          <a:xfrm>
+            <a:off x="1755648" y="2884932"/>
+            <a:ext cx="3892143" cy="201168"/>
+          </a:xfrm>
+          <a:prstGeom prst="rect">
+            <a:avLst/>
+          </a:prstGeom>
+          <a:noFill/>
+        </p:spPr>
+        <p:txBody>
+          <a:bodyPr wrap="square" lIns="0" rIns="0" tIns="0" bIns="0" anchor="t">
+            <a:spAutoFit/>
+          </a:bodyPr>
+          <a:lstStyle/>
           <a:p>
             <a:pPr algn="l">
               <a:lnSpc>
@@ -21404,27 +21110,27 @@
               </a:spcAft>
             </a:pPr>
             <a:r>
-              <a:rPr sz="1040" b="1">
+              <a:rPr sz="890" b="1">
                 <a:solidFill>
-                  <a:srgbClr val="F5A623"/>
+                  <a:srgbClr val="2FD8B4"/>
                 </a:solidFill>
                 <a:latin typeface="Consolas"/>
               </a:rPr>
-              <a:t>→ fixed by warm it before demoing</a:t>
-            </a:r>
-          </a:p>
-        </p:txBody>
-      </p:sp>
-      <p:sp>
-        <p:nvSpPr>
-          <p:cNvPr id="19" name="Rounded Rectangle 18"/>
-          <p:cNvSpPr/>
-          <p:nvPr/>
-        </p:nvSpPr>
-        <p:spPr>
-          <a:xfrm>
-            <a:off x="566928" y="5358383"/>
-            <a:ext cx="11057839" cy="859535"/>
+              <a:t>→  TIMEOUT 300S</a:t>
+            </a:r>
+          </a:p>
+        </p:txBody>
+      </p:sp>
+      <p:sp>
+        <p:nvSpPr>
+          <p:cNvPr id="16" name="Rounded Rectangle 15"/>
+          <p:cNvSpPr/>
+          <p:nvPr/>
+        </p:nvSpPr>
+        <p:spPr>
+          <a:xfrm>
+            <a:off x="6214719" y="1517904"/>
+            <a:ext cx="5410047" cy="1773935"/>
           </a:xfrm>
           <a:prstGeom prst="roundRect">
             <a:avLst>
@@ -21432,11 +21138,11 @@
             </a:avLst>
           </a:prstGeom>
           <a:solidFill>
-            <a:srgbClr val="162136"/>
-          </a:solidFill>
-          <a:ln w="15240">
+            <a:srgbClr val="111A2C"/>
+          </a:solidFill>
+          <a:ln w="12700">
             <a:solidFill>
-              <a:srgbClr val="4C8DFF"/>
+              <a:srgbClr val="223049"/>
             </a:solidFill>
           </a:ln>
           <a:effectLst/>
@@ -21465,14 +21171,58 @@
       </p:sp>
       <p:sp>
         <p:nvSpPr>
-          <p:cNvPr id="20" name="TextBox 19"/>
+          <p:cNvPr id="17" name="Rectangle 16"/>
+          <p:cNvSpPr/>
+          <p:nvPr/>
+        </p:nvSpPr>
+        <p:spPr>
+          <a:xfrm>
+            <a:off x="6214719" y="1664207"/>
+            <a:ext cx="41148" cy="1481327"/>
+          </a:xfrm>
+          <a:prstGeom prst="rect">
+            <a:avLst/>
+          </a:prstGeom>
+          <a:solidFill>
+            <a:srgbClr val="2FD8B4"/>
+          </a:solidFill>
+          <a:ln>
+            <a:noFill/>
+          </a:ln>
+          <a:effectLst/>
+        </p:spPr>
+        <p:style>
+          <a:lnRef idx="1">
+            <a:schemeClr val="accent1"/>
+          </a:lnRef>
+          <a:fillRef idx="3">
+            <a:schemeClr val="accent1"/>
+          </a:fillRef>
+          <a:effectRef idx="2">
+            <a:schemeClr val="accent1"/>
+          </a:effectRef>
+          <a:fontRef idx="minor">
+            <a:schemeClr val="lt1"/>
+          </a:fontRef>
+        </p:style>
+        <p:txBody>
+          <a:bodyPr rtlCol="0" anchor="ctr"/>
+          <a:lstStyle/>
+          <a:p>
+            <a:pPr algn="ctr"/>
+          </a:p>
+        </p:txBody>
+      </p:sp>
+      <p:sp>
+        <p:nvSpPr>
+          <p:cNvPr id="18" name="TextBox 17"/>
           <p:cNvSpPr txBox="1"/>
           <p:nvPr/>
         </p:nvSpPr>
         <p:spPr>
           <a:xfrm>
-            <a:off x="749808" y="5486399"/>
-            <a:ext cx="10692079" cy="621791"/>
+            <a:off x="6379311" y="1719072"/>
+            <a:ext cx="621792" cy="384048"/>
           </a:xfrm>
           <a:prstGeom prst="rect">
             <a:avLst/>
@@ -21490,19 +21240,170 @@
                 <a:spcPct val="112000"/>
               </a:lnSpc>
               <a:spcAft>
-                <a:spcPts val="300"/>
+                <a:spcPts val="0"/>
               </a:spcAft>
             </a:pPr>
             <a:r>
-              <a:rPr sz="1150" b="1">
+              <a:rPr sz="2200" b="1">
                 <a:solidFill>
-                  <a:srgbClr val="4C8DFF"/>
+                  <a:srgbClr val="2FD8B4"/>
+                </a:solidFill>
+                <a:latin typeface="Consolas"/>
+              </a:rPr>
+              <a:t>02</a:t>
+            </a:r>
+          </a:p>
+        </p:txBody>
+      </p:sp>
+      <p:sp>
+        <p:nvSpPr>
+          <p:cNvPr id="19" name="TextBox 18"/>
+          <p:cNvSpPr txBox="1"/>
+          <p:nvPr/>
+        </p:nvSpPr>
+        <p:spPr>
+          <a:xfrm>
+            <a:off x="6379311" y="2221991"/>
+            <a:ext cx="749808" cy="256032"/>
+          </a:xfrm>
+          <a:prstGeom prst="rect">
+            <a:avLst/>
+          </a:prstGeom>
+          <a:noFill/>
+        </p:spPr>
+        <p:txBody>
+          <a:bodyPr wrap="square" lIns="0" rIns="0" tIns="0" bIns="0" anchor="t">
+            <a:spAutoFit/>
+          </a:bodyPr>
+          <a:lstStyle/>
+          <a:p>
+            <a:pPr algn="l">
+              <a:lnSpc>
+                <a:spcPct val="112000"/>
+              </a:lnSpc>
+              <a:spcAft>
+                <a:spcPts val="0"/>
+              </a:spcAft>
+            </a:pPr>
+            <a:r>
+              <a:rPr sz="819" b="1">
+                <a:solidFill>
+                  <a:srgbClr val="8CA0BE"/>
+                </a:solidFill>
+                <a:latin typeface="Consolas"/>
+              </a:rPr>
+              <a:t>MODEL LOAD</a:t>
+            </a:r>
+          </a:p>
+        </p:txBody>
+      </p:sp>
+      <p:sp>
+        <p:nvSpPr>
+          <p:cNvPr id="20" name="Rectangle 19"/>
+          <p:cNvSpPr/>
+          <p:nvPr/>
+        </p:nvSpPr>
+        <p:spPr>
+          <a:xfrm>
+            <a:off x="7129119" y="1700784"/>
+            <a:ext cx="22860" cy="1408175"/>
+          </a:xfrm>
+          <a:prstGeom prst="rect">
+            <a:avLst/>
+          </a:prstGeom>
+          <a:solidFill>
+            <a:srgbClr val="223049"/>
+          </a:solidFill>
+          <a:ln>
+            <a:noFill/>
+          </a:ln>
+          <a:effectLst/>
+        </p:spPr>
+        <p:style>
+          <a:lnRef idx="1">
+            <a:schemeClr val="accent1"/>
+          </a:lnRef>
+          <a:fillRef idx="3">
+            <a:schemeClr val="accent1"/>
+          </a:fillRef>
+          <a:effectRef idx="2">
+            <a:schemeClr val="accent1"/>
+          </a:effectRef>
+          <a:fontRef idx="minor">
+            <a:schemeClr val="lt1"/>
+          </a:fontRef>
+        </p:style>
+        <p:txBody>
+          <a:bodyPr rtlCol="0" anchor="ctr"/>
+          <a:lstStyle/>
+          <a:p>
+            <a:pPr algn="ctr"/>
+          </a:p>
+        </p:txBody>
+      </p:sp>
+      <p:sp>
+        <p:nvSpPr>
+          <p:cNvPr id="21" name="TextBox 20"/>
+          <p:cNvSpPr txBox="1"/>
+          <p:nvPr/>
+        </p:nvSpPr>
+        <p:spPr>
+          <a:xfrm>
+            <a:off x="7293711" y="1682495"/>
+            <a:ext cx="4111599" cy="292608"/>
+          </a:xfrm>
+          <a:prstGeom prst="rect">
+            <a:avLst/>
+          </a:prstGeom>
+          <a:noFill/>
+        </p:spPr>
+        <p:txBody>
+          <a:bodyPr wrap="square" lIns="0" rIns="0" tIns="0" bIns="0" anchor="t">
+            <a:spAutoFit/>
+          </a:bodyPr>
+          <a:lstStyle/>
+          <a:p>
+            <a:pPr algn="l">
+              <a:lnSpc>
+                <a:spcPct val="112000"/>
+              </a:lnSpc>
+              <a:spcAft>
+                <a:spcPts val="0"/>
+              </a:spcAft>
+            </a:pPr>
+            <a:r>
+              <a:rPr sz="1220" b="1">
+                <a:solidFill>
+                  <a:srgbClr val="EAF0F7"/>
                 </a:solidFill>
                 <a:latin typeface="Segoe UI"/>
               </a:rPr>
-              <a:t>SHIPPED AS</a:t>
-            </a:r>
-          </a:p>
+              <a:t>Reloading on every request</a:t>
+            </a:r>
+          </a:p>
+        </p:txBody>
+      </p:sp>
+      <p:sp>
+        <p:nvSpPr>
+          <p:cNvPr id="22" name="TextBox 21"/>
+          <p:cNvSpPr txBox="1"/>
+          <p:nvPr/>
+        </p:nvSpPr>
+        <p:spPr>
+          <a:xfrm>
+            <a:off x="7293711" y="2029967"/>
+            <a:ext cx="4111599" cy="612648"/>
+          </a:xfrm>
+          <a:prstGeom prst="rect">
+            <a:avLst/>
+          </a:prstGeom>
+          <a:noFill/>
+        </p:spPr>
+        <p:txBody>
+          <a:bodyPr wrap="square" lIns="0" rIns="0" tIns="0" bIns="0" anchor="t">
+            <a:spAutoFit/>
+          </a:bodyPr>
+          <a:lstStyle/>
           <a:p>
             <a:pPr algn="l">
               <a:lnSpc>
@@ -21513,687 +21414,75 @@
               </a:spcAft>
             </a:pPr>
             <a:r>
-              <a:rPr sz="1080" b="0">
+              <a:rPr sz="1040" b="0">
                 <a:solidFill>
-                  <a:srgbClr val="EAF0F7"/>
+                  <a:srgbClr val="8CA0BE"/>
                 </a:solidFill>
                 <a:latin typeface="Segoe UI"/>
               </a:rPr>
-              <a:t>Gunicorn with a threaded worker · Dockerfile and Procfile · version-pinned requirements · hosted on Render, where the application answers at the URL on the closing slide.</a:t>
-            </a:r>
-          </a:p>
-        </p:txBody>
-      </p:sp>
-      <p:sp>
-        <p:nvSpPr>
-          <p:cNvPr id="21" name="Rectangle 20"/>
-          <p:cNvSpPr/>
-          <p:nvPr/>
-        </p:nvSpPr>
-        <p:spPr>
-          <a:xfrm>
-            <a:off x="566928" y="6309360"/>
-            <a:ext cx="743145" cy="43891"/>
-          </a:xfrm>
-          <a:prstGeom prst="rect">
-            <a:avLst/>
-          </a:prstGeom>
-          <a:solidFill>
-            <a:srgbClr val="223049"/>
-          </a:solidFill>
-          <a:ln>
-            <a:noFill/>
-          </a:ln>
-          <a:effectLst/>
-        </p:spPr>
-        <p:style>
-          <a:lnRef idx="1">
-            <a:schemeClr val="accent1"/>
-          </a:lnRef>
-          <a:fillRef idx="3">
-            <a:schemeClr val="accent1"/>
-          </a:fillRef>
-          <a:effectRef idx="2">
-            <a:schemeClr val="accent1"/>
-          </a:effectRef>
-          <a:fontRef idx="minor">
-            <a:schemeClr val="lt1"/>
-          </a:fontRef>
-        </p:style>
-        <p:txBody>
-          <a:bodyPr rtlCol="0" anchor="ctr"/>
-          <a:lstStyle/>
-          <a:p>
-            <a:pPr algn="ctr"/>
-          </a:p>
-        </p:txBody>
-      </p:sp>
-      <p:sp>
-        <p:nvSpPr>
-          <p:cNvPr id="22" name="Rectangle 21"/>
-          <p:cNvSpPr/>
-          <p:nvPr/>
-        </p:nvSpPr>
-        <p:spPr>
-          <a:xfrm>
-            <a:off x="1360365" y="6309360"/>
-            <a:ext cx="743145" cy="43891"/>
-          </a:xfrm>
-          <a:prstGeom prst="rect">
-            <a:avLst/>
-          </a:prstGeom>
-          <a:solidFill>
-            <a:srgbClr val="223049"/>
-          </a:solidFill>
-          <a:ln>
-            <a:noFill/>
-          </a:ln>
-          <a:effectLst/>
-        </p:spPr>
-        <p:style>
-          <a:lnRef idx="1">
-            <a:schemeClr val="accent1"/>
-          </a:lnRef>
-          <a:fillRef idx="3">
-            <a:schemeClr val="accent1"/>
-          </a:fillRef>
-          <a:effectRef idx="2">
-            <a:schemeClr val="accent1"/>
-          </a:effectRef>
-          <a:fontRef idx="minor">
-            <a:schemeClr val="lt1"/>
-          </a:fontRef>
-        </p:style>
-        <p:txBody>
-          <a:bodyPr rtlCol="0" anchor="ctr"/>
-          <a:lstStyle/>
-          <a:p>
-            <a:pPr algn="ctr"/>
-          </a:p>
-        </p:txBody>
-      </p:sp>
-      <p:sp>
-        <p:nvSpPr>
-          <p:cNvPr id="23" name="Rectangle 22"/>
-          <p:cNvSpPr/>
-          <p:nvPr/>
-        </p:nvSpPr>
-        <p:spPr>
-          <a:xfrm>
-            <a:off x="2153803" y="6309360"/>
-            <a:ext cx="743145" cy="43891"/>
-          </a:xfrm>
-          <a:prstGeom prst="rect">
-            <a:avLst/>
-          </a:prstGeom>
-          <a:solidFill>
-            <a:srgbClr val="223049"/>
-          </a:solidFill>
-          <a:ln>
-            <a:noFill/>
-          </a:ln>
-          <a:effectLst/>
-        </p:spPr>
-        <p:style>
-          <a:lnRef idx="1">
-            <a:schemeClr val="accent1"/>
-          </a:lnRef>
-          <a:fillRef idx="3">
-            <a:schemeClr val="accent1"/>
-          </a:fillRef>
-          <a:effectRef idx="2">
-            <a:schemeClr val="accent1"/>
-          </a:effectRef>
-          <a:fontRef idx="minor">
-            <a:schemeClr val="lt1"/>
-          </a:fontRef>
-        </p:style>
-        <p:txBody>
-          <a:bodyPr rtlCol="0" anchor="ctr"/>
-          <a:lstStyle/>
-          <a:p>
-            <a:pPr algn="ctr"/>
-          </a:p>
-        </p:txBody>
-      </p:sp>
-      <p:sp>
-        <p:nvSpPr>
-          <p:cNvPr id="24" name="Rectangle 23"/>
-          <p:cNvSpPr/>
-          <p:nvPr/>
-        </p:nvSpPr>
-        <p:spPr>
-          <a:xfrm>
-            <a:off x="2947241" y="6309360"/>
-            <a:ext cx="743145" cy="43891"/>
-          </a:xfrm>
-          <a:prstGeom prst="rect">
-            <a:avLst/>
-          </a:prstGeom>
-          <a:solidFill>
-            <a:srgbClr val="223049"/>
-          </a:solidFill>
-          <a:ln>
-            <a:noFill/>
-          </a:ln>
-          <a:effectLst/>
-        </p:spPr>
-        <p:style>
-          <a:lnRef idx="1">
-            <a:schemeClr val="accent1"/>
-          </a:lnRef>
-          <a:fillRef idx="3">
-            <a:schemeClr val="accent1"/>
-          </a:fillRef>
-          <a:effectRef idx="2">
-            <a:schemeClr val="accent1"/>
-          </a:effectRef>
-          <a:fontRef idx="minor">
-            <a:schemeClr val="lt1"/>
-          </a:fontRef>
-        </p:style>
-        <p:txBody>
-          <a:bodyPr rtlCol="0" anchor="ctr"/>
-          <a:lstStyle/>
-          <a:p>
-            <a:pPr algn="ctr"/>
-          </a:p>
-        </p:txBody>
-      </p:sp>
-      <p:sp>
-        <p:nvSpPr>
-          <p:cNvPr id="25" name="Rectangle 24"/>
-          <p:cNvSpPr/>
-          <p:nvPr/>
-        </p:nvSpPr>
-        <p:spPr>
-          <a:xfrm>
-            <a:off x="3740679" y="6309360"/>
-            <a:ext cx="743145" cy="43891"/>
-          </a:xfrm>
-          <a:prstGeom prst="rect">
-            <a:avLst/>
-          </a:prstGeom>
-          <a:solidFill>
-            <a:srgbClr val="223049"/>
-          </a:solidFill>
-          <a:ln>
-            <a:noFill/>
-          </a:ln>
-          <a:effectLst/>
-        </p:spPr>
-        <p:style>
-          <a:lnRef idx="1">
-            <a:schemeClr val="accent1"/>
-          </a:lnRef>
-          <a:fillRef idx="3">
-            <a:schemeClr val="accent1"/>
-          </a:fillRef>
-          <a:effectRef idx="2">
-            <a:schemeClr val="accent1"/>
-          </a:effectRef>
-          <a:fontRef idx="minor">
-            <a:schemeClr val="lt1"/>
-          </a:fontRef>
-        </p:style>
-        <p:txBody>
-          <a:bodyPr rtlCol="0" anchor="ctr"/>
-          <a:lstStyle/>
-          <a:p>
-            <a:pPr algn="ctr"/>
-          </a:p>
-        </p:txBody>
-      </p:sp>
-      <p:sp>
-        <p:nvSpPr>
-          <p:cNvPr id="26" name="Rectangle 25"/>
-          <p:cNvSpPr/>
-          <p:nvPr/>
-        </p:nvSpPr>
-        <p:spPr>
-          <a:xfrm>
-            <a:off x="4534117" y="6309360"/>
-            <a:ext cx="743145" cy="43891"/>
-          </a:xfrm>
-          <a:prstGeom prst="rect">
-            <a:avLst/>
-          </a:prstGeom>
-          <a:solidFill>
-            <a:srgbClr val="223049"/>
-          </a:solidFill>
-          <a:ln>
-            <a:noFill/>
-          </a:ln>
-          <a:effectLst/>
-        </p:spPr>
-        <p:style>
-          <a:lnRef idx="1">
-            <a:schemeClr val="accent1"/>
-          </a:lnRef>
-          <a:fillRef idx="3">
-            <a:schemeClr val="accent1"/>
-          </a:fillRef>
-          <a:effectRef idx="2">
-            <a:schemeClr val="accent1"/>
-          </a:effectRef>
-          <a:fontRef idx="minor">
-            <a:schemeClr val="lt1"/>
-          </a:fontRef>
-        </p:style>
-        <p:txBody>
-          <a:bodyPr rtlCol="0" anchor="ctr"/>
-          <a:lstStyle/>
-          <a:p>
-            <a:pPr algn="ctr"/>
-          </a:p>
-        </p:txBody>
-      </p:sp>
-      <p:sp>
-        <p:nvSpPr>
-          <p:cNvPr id="27" name="Rectangle 26"/>
-          <p:cNvSpPr/>
-          <p:nvPr/>
-        </p:nvSpPr>
-        <p:spPr>
-          <a:xfrm>
-            <a:off x="5327555" y="6309360"/>
-            <a:ext cx="743145" cy="43891"/>
-          </a:xfrm>
-          <a:prstGeom prst="rect">
-            <a:avLst/>
-          </a:prstGeom>
-          <a:solidFill>
-            <a:srgbClr val="223049"/>
-          </a:solidFill>
-          <a:ln>
-            <a:noFill/>
-          </a:ln>
-          <a:effectLst/>
-        </p:spPr>
-        <p:style>
-          <a:lnRef idx="1">
-            <a:schemeClr val="accent1"/>
-          </a:lnRef>
-          <a:fillRef idx="3">
-            <a:schemeClr val="accent1"/>
-          </a:fillRef>
-          <a:effectRef idx="2">
-            <a:schemeClr val="accent1"/>
-          </a:effectRef>
-          <a:fontRef idx="minor">
-            <a:schemeClr val="lt1"/>
-          </a:fontRef>
-        </p:style>
-        <p:txBody>
-          <a:bodyPr rtlCol="0" anchor="ctr"/>
-          <a:lstStyle/>
-          <a:p>
-            <a:pPr algn="ctr"/>
-          </a:p>
-        </p:txBody>
-      </p:sp>
-      <p:sp>
-        <p:nvSpPr>
-          <p:cNvPr id="28" name="Rectangle 27"/>
-          <p:cNvSpPr/>
-          <p:nvPr/>
-        </p:nvSpPr>
-        <p:spPr>
-          <a:xfrm>
-            <a:off x="6120993" y="6309360"/>
-            <a:ext cx="743145" cy="43891"/>
-          </a:xfrm>
-          <a:prstGeom prst="rect">
-            <a:avLst/>
-          </a:prstGeom>
-          <a:solidFill>
-            <a:srgbClr val="223049"/>
-          </a:solidFill>
-          <a:ln>
-            <a:noFill/>
-          </a:ln>
-          <a:effectLst/>
-        </p:spPr>
-        <p:style>
-          <a:lnRef idx="1">
-            <a:schemeClr val="accent1"/>
-          </a:lnRef>
-          <a:fillRef idx="3">
-            <a:schemeClr val="accent1"/>
-          </a:fillRef>
-          <a:effectRef idx="2">
-            <a:schemeClr val="accent1"/>
-          </a:effectRef>
-          <a:fontRef idx="minor">
-            <a:schemeClr val="lt1"/>
-          </a:fontRef>
-        </p:style>
-        <p:txBody>
-          <a:bodyPr rtlCol="0" anchor="ctr"/>
-          <a:lstStyle/>
-          <a:p>
-            <a:pPr algn="ctr"/>
-          </a:p>
-        </p:txBody>
-      </p:sp>
-      <p:sp>
-        <p:nvSpPr>
-          <p:cNvPr id="29" name="Rectangle 28"/>
-          <p:cNvSpPr/>
-          <p:nvPr/>
-        </p:nvSpPr>
-        <p:spPr>
-          <a:xfrm>
-            <a:off x="6914431" y="6309360"/>
-            <a:ext cx="743145" cy="43891"/>
-          </a:xfrm>
-          <a:prstGeom prst="rect">
-            <a:avLst/>
-          </a:prstGeom>
-          <a:solidFill>
-            <a:srgbClr val="223049"/>
-          </a:solidFill>
-          <a:ln>
-            <a:noFill/>
-          </a:ln>
-          <a:effectLst/>
-        </p:spPr>
-        <p:style>
-          <a:lnRef idx="1">
-            <a:schemeClr val="accent1"/>
-          </a:lnRef>
-          <a:fillRef idx="3">
-            <a:schemeClr val="accent1"/>
-          </a:fillRef>
-          <a:effectRef idx="2">
-            <a:schemeClr val="accent1"/>
-          </a:effectRef>
-          <a:fontRef idx="minor">
-            <a:schemeClr val="lt1"/>
-          </a:fontRef>
-        </p:style>
-        <p:txBody>
-          <a:bodyPr rtlCol="0" anchor="ctr"/>
-          <a:lstStyle/>
-          <a:p>
-            <a:pPr algn="ctr"/>
-          </a:p>
-        </p:txBody>
-      </p:sp>
-      <p:sp>
-        <p:nvSpPr>
-          <p:cNvPr id="30" name="Rectangle 29"/>
-          <p:cNvSpPr/>
-          <p:nvPr/>
-        </p:nvSpPr>
-        <p:spPr>
-          <a:xfrm>
-            <a:off x="7707869" y="6309360"/>
-            <a:ext cx="743145" cy="43891"/>
-          </a:xfrm>
-          <a:prstGeom prst="rect">
-            <a:avLst/>
-          </a:prstGeom>
-          <a:solidFill>
-            <a:srgbClr val="223049"/>
-          </a:solidFill>
-          <a:ln>
-            <a:noFill/>
-          </a:ln>
-          <a:effectLst/>
-        </p:spPr>
-        <p:style>
-          <a:lnRef idx="1">
-            <a:schemeClr val="accent1"/>
-          </a:lnRef>
-          <a:fillRef idx="3">
-            <a:schemeClr val="accent1"/>
-          </a:fillRef>
-          <a:effectRef idx="2">
-            <a:schemeClr val="accent1"/>
-          </a:effectRef>
-          <a:fontRef idx="minor">
-            <a:schemeClr val="lt1"/>
-          </a:fontRef>
-        </p:style>
-        <p:txBody>
-          <a:bodyPr rtlCol="0" anchor="ctr"/>
-          <a:lstStyle/>
-          <a:p>
-            <a:pPr algn="ctr"/>
-          </a:p>
-        </p:txBody>
-      </p:sp>
-      <p:sp>
-        <p:nvSpPr>
-          <p:cNvPr id="31" name="Rectangle 30"/>
-          <p:cNvSpPr/>
-          <p:nvPr/>
-        </p:nvSpPr>
-        <p:spPr>
-          <a:xfrm>
-            <a:off x="8501307" y="6309360"/>
-            <a:ext cx="743145" cy="43891"/>
-          </a:xfrm>
-          <a:prstGeom prst="rect">
-            <a:avLst/>
-          </a:prstGeom>
-          <a:solidFill>
-            <a:srgbClr val="223049"/>
-          </a:solidFill>
-          <a:ln>
-            <a:noFill/>
-          </a:ln>
-          <a:effectLst/>
-        </p:spPr>
-        <p:style>
-          <a:lnRef idx="1">
-            <a:schemeClr val="accent1"/>
-          </a:lnRef>
-          <a:fillRef idx="3">
-            <a:schemeClr val="accent1"/>
-          </a:fillRef>
-          <a:effectRef idx="2">
-            <a:schemeClr val="accent1"/>
-          </a:effectRef>
-          <a:fontRef idx="minor">
-            <a:schemeClr val="lt1"/>
-          </a:fontRef>
-        </p:style>
-        <p:txBody>
-          <a:bodyPr rtlCol="0" anchor="ctr"/>
-          <a:lstStyle/>
-          <a:p>
-            <a:pPr algn="ctr"/>
-          </a:p>
-        </p:txBody>
-      </p:sp>
-      <p:sp>
-        <p:nvSpPr>
-          <p:cNvPr id="32" name="Rectangle 31"/>
-          <p:cNvSpPr/>
-          <p:nvPr/>
-        </p:nvSpPr>
-        <p:spPr>
-          <a:xfrm>
-            <a:off x="9294745" y="6309360"/>
-            <a:ext cx="743145" cy="43891"/>
-          </a:xfrm>
-          <a:prstGeom prst="rect">
-            <a:avLst/>
-          </a:prstGeom>
-          <a:solidFill>
-            <a:srgbClr val="223049"/>
-          </a:solidFill>
-          <a:ln>
-            <a:noFill/>
-          </a:ln>
-          <a:effectLst/>
-        </p:spPr>
-        <p:style>
-          <a:lnRef idx="1">
-            <a:schemeClr val="accent1"/>
-          </a:lnRef>
-          <a:fillRef idx="3">
-            <a:schemeClr val="accent1"/>
-          </a:fillRef>
-          <a:effectRef idx="2">
-            <a:schemeClr val="accent1"/>
-          </a:effectRef>
-          <a:fontRef idx="minor">
-            <a:schemeClr val="lt1"/>
-          </a:fontRef>
-        </p:style>
-        <p:txBody>
-          <a:bodyPr rtlCol="0" anchor="ctr"/>
-          <a:lstStyle/>
-          <a:p>
-            <a:pPr algn="ctr"/>
-          </a:p>
-        </p:txBody>
-      </p:sp>
-      <p:sp>
-        <p:nvSpPr>
-          <p:cNvPr id="33" name="Rectangle 32"/>
-          <p:cNvSpPr/>
-          <p:nvPr/>
-        </p:nvSpPr>
-        <p:spPr>
-          <a:xfrm>
-            <a:off x="10088183" y="6309360"/>
-            <a:ext cx="743145" cy="43891"/>
-          </a:xfrm>
-          <a:prstGeom prst="rect">
-            <a:avLst/>
-          </a:prstGeom>
-          <a:solidFill>
-            <a:srgbClr val="223049"/>
-          </a:solidFill>
-          <a:ln>
-            <a:noFill/>
-          </a:ln>
-          <a:effectLst/>
-        </p:spPr>
-        <p:style>
-          <a:lnRef idx="1">
-            <a:schemeClr val="accent1"/>
-          </a:lnRef>
-          <a:fillRef idx="3">
-            <a:schemeClr val="accent1"/>
-          </a:fillRef>
-          <a:effectRef idx="2">
-            <a:schemeClr val="accent1"/>
-          </a:effectRef>
-          <a:fontRef idx="minor">
-            <a:schemeClr val="lt1"/>
-          </a:fontRef>
-        </p:style>
-        <p:txBody>
-          <a:bodyPr rtlCol="0" anchor="ctr"/>
-          <a:lstStyle/>
-          <a:p>
-            <a:pPr algn="ctr"/>
-          </a:p>
-        </p:txBody>
-      </p:sp>
-      <p:sp>
-        <p:nvSpPr>
-          <p:cNvPr id="34" name="Rectangle 33"/>
-          <p:cNvSpPr/>
-          <p:nvPr/>
-        </p:nvSpPr>
-        <p:spPr>
-          <a:xfrm>
-            <a:off x="10881621" y="6296558"/>
-            <a:ext cx="743145" cy="68580"/>
-          </a:xfrm>
-          <a:prstGeom prst="rect">
-            <a:avLst/>
-          </a:prstGeom>
-          <a:solidFill>
-            <a:srgbClr val="2FD8B4"/>
-          </a:solidFill>
-          <a:ln>
-            <a:noFill/>
-          </a:ln>
-          <a:effectLst/>
-        </p:spPr>
-        <p:style>
-          <a:lnRef idx="1">
-            <a:schemeClr val="accent1"/>
-          </a:lnRef>
-          <a:fillRef idx="3">
-            <a:schemeClr val="accent1"/>
-          </a:fillRef>
-          <a:effectRef idx="2">
-            <a:schemeClr val="accent1"/>
-          </a:effectRef>
-          <a:fontRef idx="minor">
-            <a:schemeClr val="lt1"/>
-          </a:fontRef>
-        </p:style>
-        <p:txBody>
-          <a:bodyPr rtlCol="0" anchor="ctr"/>
-          <a:lstStyle/>
-          <a:p>
-            <a:pPr algn="ctr"/>
-          </a:p>
-        </p:txBody>
-      </p:sp>
-      <p:sp>
-        <p:nvSpPr>
-          <p:cNvPr id="35" name="Rectangle 34"/>
-          <p:cNvSpPr/>
-          <p:nvPr/>
-        </p:nvSpPr>
-        <p:spPr>
-          <a:xfrm>
-            <a:off x="566928" y="6455664"/>
-            <a:ext cx="11057839" cy="9144"/>
-          </a:xfrm>
-          <a:prstGeom prst="rect">
-            <a:avLst/>
-          </a:prstGeom>
-          <a:solidFill>
-            <a:srgbClr val="223049"/>
-          </a:solidFill>
-          <a:ln>
-            <a:noFill/>
-          </a:ln>
-          <a:effectLst/>
-        </p:spPr>
-        <p:style>
-          <a:lnRef idx="1">
-            <a:schemeClr val="accent1"/>
-          </a:lnRef>
-          <a:fillRef idx="3">
-            <a:schemeClr val="accent1"/>
-          </a:fillRef>
-          <a:effectRef idx="2">
-            <a:schemeClr val="accent1"/>
-          </a:effectRef>
-          <a:fontRef idx="minor">
-            <a:schemeClr val="lt1"/>
-          </a:fontRef>
-        </p:style>
-        <p:txBody>
-          <a:bodyPr rtlCol="0" anchor="ctr"/>
-          <a:lstStyle/>
-          <a:p>
-            <a:pPr algn="ctr"/>
-          </a:p>
-        </p:txBody>
-      </p:sp>
-      <p:sp>
-        <p:nvSpPr>
-          <p:cNvPr id="36" name="TextBox 35"/>
+              <a:t>Reading the model pickle for every request wastes scarce instance memory.</a:t>
+            </a:r>
+          </a:p>
+        </p:txBody>
+      </p:sp>
+      <p:sp>
+        <p:nvSpPr>
+          <p:cNvPr id="23" name="Rounded Rectangle 22"/>
+          <p:cNvSpPr/>
+          <p:nvPr/>
+        </p:nvSpPr>
+        <p:spPr>
+          <a:xfrm>
+            <a:off x="7293711" y="2852927"/>
+            <a:ext cx="4111599" cy="274320"/>
+          </a:xfrm>
+          <a:prstGeom prst="roundRect">
+            <a:avLst>
+              <a:gd name="adj" fmla="val 8000"/>
+            </a:avLst>
+          </a:prstGeom>
+          <a:solidFill>
+            <a:srgbClr val="162136"/>
+          </a:solidFill>
+          <a:ln w="10160">
+            <a:solidFill>
+              <a:srgbClr val="2FD8B4"/>
+            </a:solidFill>
+          </a:ln>
+          <a:effectLst/>
+        </p:spPr>
+        <p:style>
+          <a:lnRef idx="1">
+            <a:schemeClr val="accent1"/>
+          </a:lnRef>
+          <a:fillRef idx="3">
+            <a:schemeClr val="accent1"/>
+          </a:fillRef>
+          <a:effectRef idx="2">
+            <a:schemeClr val="accent1"/>
+          </a:effectRef>
+          <a:fontRef idx="minor">
+            <a:schemeClr val="lt1"/>
+          </a:fontRef>
+        </p:style>
+        <p:txBody>
+          <a:bodyPr rtlCol="0" anchor="ctr"/>
+          <a:lstStyle/>
+          <a:p>
+            <a:pPr algn="ctr"/>
+          </a:p>
+        </p:txBody>
+      </p:sp>
+      <p:sp>
+        <p:nvSpPr>
+          <p:cNvPr id="24" name="TextBox 23"/>
           <p:cNvSpPr txBox="1"/>
           <p:nvPr/>
         </p:nvSpPr>
         <p:spPr>
           <a:xfrm>
-            <a:off x="566928" y="6510528"/>
-            <a:ext cx="9509760" cy="219456"/>
+            <a:off x="7403439" y="2884932"/>
+            <a:ext cx="3892143" cy="201168"/>
           </a:xfrm>
           <a:prstGeom prst="rect">
             <a:avLst/>
@@ -22215,6 +21504,2037 @@
               </a:spcAft>
             </a:pPr>
             <a:r>
+              <a:rPr sz="890" b="1">
+                <a:solidFill>
+                  <a:srgbClr val="2FD8B4"/>
+                </a:solidFill>
+                <a:latin typeface="Consolas"/>
+              </a:rPr>
+              <a:t>→  GUNICORN PRELOAD</a:t>
+            </a:r>
+          </a:p>
+        </p:txBody>
+      </p:sp>
+      <p:sp>
+        <p:nvSpPr>
+          <p:cNvPr id="25" name="Rounded Rectangle 24"/>
+          <p:cNvSpPr/>
+          <p:nvPr/>
+        </p:nvSpPr>
+        <p:spPr>
+          <a:xfrm>
+            <a:off x="566928" y="3438144"/>
+            <a:ext cx="5410047" cy="1773935"/>
+          </a:xfrm>
+          <a:prstGeom prst="roundRect">
+            <a:avLst>
+              <a:gd name="adj" fmla="val 8000"/>
+            </a:avLst>
+          </a:prstGeom>
+          <a:solidFill>
+            <a:srgbClr val="111A2C"/>
+          </a:solidFill>
+          <a:ln w="12700">
+            <a:solidFill>
+              <a:srgbClr val="223049"/>
+            </a:solidFill>
+          </a:ln>
+          <a:effectLst/>
+        </p:spPr>
+        <p:style>
+          <a:lnRef idx="1">
+            <a:schemeClr val="accent1"/>
+          </a:lnRef>
+          <a:fillRef idx="3">
+            <a:schemeClr val="accent1"/>
+          </a:fillRef>
+          <a:effectRef idx="2">
+            <a:schemeClr val="accent1"/>
+          </a:effectRef>
+          <a:fontRef idx="minor">
+            <a:schemeClr val="lt1"/>
+          </a:fontRef>
+        </p:style>
+        <p:txBody>
+          <a:bodyPr rtlCol="0" anchor="ctr"/>
+          <a:lstStyle/>
+          <a:p>
+            <a:pPr algn="ctr"/>
+          </a:p>
+        </p:txBody>
+      </p:sp>
+      <p:sp>
+        <p:nvSpPr>
+          <p:cNvPr id="26" name="Rectangle 25"/>
+          <p:cNvSpPr/>
+          <p:nvPr/>
+        </p:nvSpPr>
+        <p:spPr>
+          <a:xfrm>
+            <a:off x="566928" y="3584448"/>
+            <a:ext cx="41148" cy="1481327"/>
+          </a:xfrm>
+          <a:prstGeom prst="rect">
+            <a:avLst/>
+          </a:prstGeom>
+          <a:solidFill>
+            <a:srgbClr val="2FD8B4"/>
+          </a:solidFill>
+          <a:ln>
+            <a:noFill/>
+          </a:ln>
+          <a:effectLst/>
+        </p:spPr>
+        <p:style>
+          <a:lnRef idx="1">
+            <a:schemeClr val="accent1"/>
+          </a:lnRef>
+          <a:fillRef idx="3">
+            <a:schemeClr val="accent1"/>
+          </a:fillRef>
+          <a:effectRef idx="2">
+            <a:schemeClr val="accent1"/>
+          </a:effectRef>
+          <a:fontRef idx="minor">
+            <a:schemeClr val="lt1"/>
+          </a:fontRef>
+        </p:style>
+        <p:txBody>
+          <a:bodyPr rtlCol="0" anchor="ctr"/>
+          <a:lstStyle/>
+          <a:p>
+            <a:pPr algn="ctr"/>
+          </a:p>
+        </p:txBody>
+      </p:sp>
+      <p:sp>
+        <p:nvSpPr>
+          <p:cNvPr id="27" name="TextBox 26"/>
+          <p:cNvSpPr txBox="1"/>
+          <p:nvPr/>
+        </p:nvSpPr>
+        <p:spPr>
+          <a:xfrm>
+            <a:off x="731520" y="3639312"/>
+            <a:ext cx="621792" cy="384048"/>
+          </a:xfrm>
+          <a:prstGeom prst="rect">
+            <a:avLst/>
+          </a:prstGeom>
+          <a:noFill/>
+        </p:spPr>
+        <p:txBody>
+          <a:bodyPr wrap="square" lIns="0" rIns="0" tIns="0" bIns="0" anchor="t">
+            <a:spAutoFit/>
+          </a:bodyPr>
+          <a:lstStyle/>
+          <a:p>
+            <a:pPr algn="l">
+              <a:lnSpc>
+                <a:spcPct val="112000"/>
+              </a:lnSpc>
+              <a:spcAft>
+                <a:spcPts val="0"/>
+              </a:spcAft>
+            </a:pPr>
+            <a:r>
+              <a:rPr sz="2200" b="1">
+                <a:solidFill>
+                  <a:srgbClr val="2FD8B4"/>
+                </a:solidFill>
+                <a:latin typeface="Consolas"/>
+              </a:rPr>
+              <a:t>03</a:t>
+            </a:r>
+          </a:p>
+        </p:txBody>
+      </p:sp>
+      <p:sp>
+        <p:nvSpPr>
+          <p:cNvPr id="28" name="TextBox 27"/>
+          <p:cNvSpPr txBox="1"/>
+          <p:nvPr/>
+        </p:nvSpPr>
+        <p:spPr>
+          <a:xfrm>
+            <a:off x="731520" y="4142231"/>
+            <a:ext cx="749808" cy="256032"/>
+          </a:xfrm>
+          <a:prstGeom prst="rect">
+            <a:avLst/>
+          </a:prstGeom>
+          <a:noFill/>
+        </p:spPr>
+        <p:txBody>
+          <a:bodyPr wrap="square" lIns="0" rIns="0" tIns="0" bIns="0" anchor="t">
+            <a:spAutoFit/>
+          </a:bodyPr>
+          <a:lstStyle/>
+          <a:p>
+            <a:pPr algn="l">
+              <a:lnSpc>
+                <a:spcPct val="112000"/>
+              </a:lnSpc>
+              <a:spcAft>
+                <a:spcPts val="0"/>
+              </a:spcAft>
+            </a:pPr>
+            <a:r>
+              <a:rPr sz="819" b="1">
+                <a:solidFill>
+                  <a:srgbClr val="8CA0BE"/>
+                </a:solidFill>
+                <a:latin typeface="Consolas"/>
+              </a:rPr>
+              <a:t>MEMORY</a:t>
+            </a:r>
+          </a:p>
+        </p:txBody>
+      </p:sp>
+      <p:sp>
+        <p:nvSpPr>
+          <p:cNvPr id="29" name="Rectangle 28"/>
+          <p:cNvSpPr/>
+          <p:nvPr/>
+        </p:nvSpPr>
+        <p:spPr>
+          <a:xfrm>
+            <a:off x="1481328" y="3621024"/>
+            <a:ext cx="22860" cy="1408175"/>
+          </a:xfrm>
+          <a:prstGeom prst="rect">
+            <a:avLst/>
+          </a:prstGeom>
+          <a:solidFill>
+            <a:srgbClr val="223049"/>
+          </a:solidFill>
+          <a:ln>
+            <a:noFill/>
+          </a:ln>
+          <a:effectLst/>
+        </p:spPr>
+        <p:style>
+          <a:lnRef idx="1">
+            <a:schemeClr val="accent1"/>
+          </a:lnRef>
+          <a:fillRef idx="3">
+            <a:schemeClr val="accent1"/>
+          </a:fillRef>
+          <a:effectRef idx="2">
+            <a:schemeClr val="accent1"/>
+          </a:effectRef>
+          <a:fontRef idx="minor">
+            <a:schemeClr val="lt1"/>
+          </a:fontRef>
+        </p:style>
+        <p:txBody>
+          <a:bodyPr rtlCol="0" anchor="ctr"/>
+          <a:lstStyle/>
+          <a:p>
+            <a:pPr algn="ctr"/>
+          </a:p>
+        </p:txBody>
+      </p:sp>
+      <p:sp>
+        <p:nvSpPr>
+          <p:cNvPr id="30" name="TextBox 29"/>
+          <p:cNvSpPr txBox="1"/>
+          <p:nvPr/>
+        </p:nvSpPr>
+        <p:spPr>
+          <a:xfrm>
+            <a:off x="1645919" y="3602736"/>
+            <a:ext cx="4111599" cy="292608"/>
+          </a:xfrm>
+          <a:prstGeom prst="rect">
+            <a:avLst/>
+          </a:prstGeom>
+          <a:noFill/>
+        </p:spPr>
+        <p:txBody>
+          <a:bodyPr wrap="square" lIns="0" rIns="0" tIns="0" bIns="0" anchor="t">
+            <a:spAutoFit/>
+          </a:bodyPr>
+          <a:lstStyle/>
+          <a:p>
+            <a:pPr algn="l">
+              <a:lnSpc>
+                <a:spcPct val="112000"/>
+              </a:lnSpc>
+              <a:spcAft>
+                <a:spcPts val="0"/>
+              </a:spcAft>
+            </a:pPr>
+            <a:r>
+              <a:rPr sz="1220" b="1">
+                <a:solidFill>
+                  <a:srgbClr val="EAF0F7"/>
+                </a:solidFill>
+                <a:latin typeface="Segoe UI"/>
+              </a:rPr>
+              <a:t>Long-lived workers grow</a:t>
+            </a:r>
+          </a:p>
+        </p:txBody>
+      </p:sp>
+      <p:sp>
+        <p:nvSpPr>
+          <p:cNvPr id="31" name="TextBox 30"/>
+          <p:cNvSpPr txBox="1"/>
+          <p:nvPr/>
+        </p:nvSpPr>
+        <p:spPr>
+          <a:xfrm>
+            <a:off x="1645919" y="3950208"/>
+            <a:ext cx="4111599" cy="612648"/>
+          </a:xfrm>
+          <a:prstGeom prst="rect">
+            <a:avLst/>
+          </a:prstGeom>
+          <a:noFill/>
+        </p:spPr>
+        <p:txBody>
+          <a:bodyPr wrap="square" lIns="0" rIns="0" tIns="0" bIns="0" anchor="t">
+            <a:spAutoFit/>
+          </a:bodyPr>
+          <a:lstStyle/>
+          <a:p>
+            <a:pPr algn="l">
+              <a:lnSpc>
+                <a:spcPct val="116000"/>
+              </a:lnSpc>
+              <a:spcAft>
+                <a:spcPts val="0"/>
+              </a:spcAft>
+            </a:pPr>
+            <a:r>
+              <a:rPr sz="1040" b="0">
+                <a:solidFill>
+                  <a:srgbClr val="8CA0BE"/>
+                </a:solidFill>
+                <a:latin typeface="Segoe UI"/>
+              </a:rPr>
+              <a:t>A worker can accumulate memory over time until the host kills the process.</a:t>
+            </a:r>
+          </a:p>
+        </p:txBody>
+      </p:sp>
+      <p:sp>
+        <p:nvSpPr>
+          <p:cNvPr id="32" name="Rounded Rectangle 31"/>
+          <p:cNvSpPr/>
+          <p:nvPr/>
+        </p:nvSpPr>
+        <p:spPr>
+          <a:xfrm>
+            <a:off x="1645919" y="4773167"/>
+            <a:ext cx="4111599" cy="274320"/>
+          </a:xfrm>
+          <a:prstGeom prst="roundRect">
+            <a:avLst>
+              <a:gd name="adj" fmla="val 8000"/>
+            </a:avLst>
+          </a:prstGeom>
+          <a:solidFill>
+            <a:srgbClr val="162136"/>
+          </a:solidFill>
+          <a:ln w="10160">
+            <a:solidFill>
+              <a:srgbClr val="2FD8B4"/>
+            </a:solidFill>
+          </a:ln>
+          <a:effectLst/>
+        </p:spPr>
+        <p:style>
+          <a:lnRef idx="1">
+            <a:schemeClr val="accent1"/>
+          </a:lnRef>
+          <a:fillRef idx="3">
+            <a:schemeClr val="accent1"/>
+          </a:fillRef>
+          <a:effectRef idx="2">
+            <a:schemeClr val="accent1"/>
+          </a:effectRef>
+          <a:fontRef idx="minor">
+            <a:schemeClr val="lt1"/>
+          </a:fontRef>
+        </p:style>
+        <p:txBody>
+          <a:bodyPr rtlCol="0" anchor="ctr"/>
+          <a:lstStyle/>
+          <a:p>
+            <a:pPr algn="ctr"/>
+          </a:p>
+        </p:txBody>
+      </p:sp>
+      <p:sp>
+        <p:nvSpPr>
+          <p:cNvPr id="33" name="TextBox 32"/>
+          <p:cNvSpPr txBox="1"/>
+          <p:nvPr/>
+        </p:nvSpPr>
+        <p:spPr>
+          <a:xfrm>
+            <a:off x="1755648" y="4805171"/>
+            <a:ext cx="3892143" cy="201168"/>
+          </a:xfrm>
+          <a:prstGeom prst="rect">
+            <a:avLst/>
+          </a:prstGeom>
+          <a:noFill/>
+        </p:spPr>
+        <p:txBody>
+          <a:bodyPr wrap="square" lIns="0" rIns="0" tIns="0" bIns="0" anchor="t">
+            <a:spAutoFit/>
+          </a:bodyPr>
+          <a:lstStyle/>
+          <a:p>
+            <a:pPr algn="l">
+              <a:lnSpc>
+                <a:spcPct val="112000"/>
+              </a:lnSpc>
+              <a:spcAft>
+                <a:spcPts val="0"/>
+              </a:spcAft>
+            </a:pPr>
+            <a:r>
+              <a:rPr sz="890" b="1">
+                <a:solidFill>
+                  <a:srgbClr val="2FD8B4"/>
+                </a:solidFill>
+                <a:latin typeface="Consolas"/>
+              </a:rPr>
+              <a:t>→  REQUEST RECYCLING</a:t>
+            </a:r>
+          </a:p>
+        </p:txBody>
+      </p:sp>
+      <p:sp>
+        <p:nvSpPr>
+          <p:cNvPr id="34" name="Rounded Rectangle 33"/>
+          <p:cNvSpPr/>
+          <p:nvPr/>
+        </p:nvSpPr>
+        <p:spPr>
+          <a:xfrm>
+            <a:off x="6214719" y="3438144"/>
+            <a:ext cx="5410047" cy="1773935"/>
+          </a:xfrm>
+          <a:prstGeom prst="roundRect">
+            <a:avLst>
+              <a:gd name="adj" fmla="val 8000"/>
+            </a:avLst>
+          </a:prstGeom>
+          <a:solidFill>
+            <a:srgbClr val="111A2C"/>
+          </a:solidFill>
+          <a:ln w="12700">
+            <a:solidFill>
+              <a:srgbClr val="223049"/>
+            </a:solidFill>
+          </a:ln>
+          <a:effectLst/>
+        </p:spPr>
+        <p:style>
+          <a:lnRef idx="1">
+            <a:schemeClr val="accent1"/>
+          </a:lnRef>
+          <a:fillRef idx="3">
+            <a:schemeClr val="accent1"/>
+          </a:fillRef>
+          <a:effectRef idx="2">
+            <a:schemeClr val="accent1"/>
+          </a:effectRef>
+          <a:fontRef idx="minor">
+            <a:schemeClr val="lt1"/>
+          </a:fontRef>
+        </p:style>
+        <p:txBody>
+          <a:bodyPr rtlCol="0" anchor="ctr"/>
+          <a:lstStyle/>
+          <a:p>
+            <a:pPr algn="ctr"/>
+          </a:p>
+        </p:txBody>
+      </p:sp>
+      <p:sp>
+        <p:nvSpPr>
+          <p:cNvPr id="35" name="Rectangle 34"/>
+          <p:cNvSpPr/>
+          <p:nvPr/>
+        </p:nvSpPr>
+        <p:spPr>
+          <a:xfrm>
+            <a:off x="6214719" y="3584448"/>
+            <a:ext cx="41148" cy="1481327"/>
+          </a:xfrm>
+          <a:prstGeom prst="rect">
+            <a:avLst/>
+          </a:prstGeom>
+          <a:solidFill>
+            <a:srgbClr val="F5A623"/>
+          </a:solidFill>
+          <a:ln>
+            <a:noFill/>
+          </a:ln>
+          <a:effectLst/>
+        </p:spPr>
+        <p:style>
+          <a:lnRef idx="1">
+            <a:schemeClr val="accent1"/>
+          </a:lnRef>
+          <a:fillRef idx="3">
+            <a:schemeClr val="accent1"/>
+          </a:fillRef>
+          <a:effectRef idx="2">
+            <a:schemeClr val="accent1"/>
+          </a:effectRef>
+          <a:fontRef idx="minor">
+            <a:schemeClr val="lt1"/>
+          </a:fontRef>
+        </p:style>
+        <p:txBody>
+          <a:bodyPr rtlCol="0" anchor="ctr"/>
+          <a:lstStyle/>
+          <a:p>
+            <a:pPr algn="ctr"/>
+          </a:p>
+        </p:txBody>
+      </p:sp>
+      <p:sp>
+        <p:nvSpPr>
+          <p:cNvPr id="36" name="TextBox 35"/>
+          <p:cNvSpPr txBox="1"/>
+          <p:nvPr/>
+        </p:nvSpPr>
+        <p:spPr>
+          <a:xfrm>
+            <a:off x="6379311" y="3639312"/>
+            <a:ext cx="621792" cy="384048"/>
+          </a:xfrm>
+          <a:prstGeom prst="rect">
+            <a:avLst/>
+          </a:prstGeom>
+          <a:noFill/>
+        </p:spPr>
+        <p:txBody>
+          <a:bodyPr wrap="square" lIns="0" rIns="0" tIns="0" bIns="0" anchor="t">
+            <a:spAutoFit/>
+          </a:bodyPr>
+          <a:lstStyle/>
+          <a:p>
+            <a:pPr algn="l">
+              <a:lnSpc>
+                <a:spcPct val="112000"/>
+              </a:lnSpc>
+              <a:spcAft>
+                <a:spcPts val="0"/>
+              </a:spcAft>
+            </a:pPr>
+            <a:r>
+              <a:rPr sz="2200" b="1">
+                <a:solidFill>
+                  <a:srgbClr val="F5A623"/>
+                </a:solidFill>
+                <a:latin typeface="Consolas"/>
+              </a:rPr>
+              <a:t>04</a:t>
+            </a:r>
+          </a:p>
+        </p:txBody>
+      </p:sp>
+      <p:sp>
+        <p:nvSpPr>
+          <p:cNvPr id="37" name="TextBox 36"/>
+          <p:cNvSpPr txBox="1"/>
+          <p:nvPr/>
+        </p:nvSpPr>
+        <p:spPr>
+          <a:xfrm>
+            <a:off x="6379311" y="4142231"/>
+            <a:ext cx="749808" cy="256032"/>
+          </a:xfrm>
+          <a:prstGeom prst="rect">
+            <a:avLst/>
+          </a:prstGeom>
+          <a:noFill/>
+        </p:spPr>
+        <p:txBody>
+          <a:bodyPr wrap="square" lIns="0" rIns="0" tIns="0" bIns="0" anchor="t">
+            <a:spAutoFit/>
+          </a:bodyPr>
+          <a:lstStyle/>
+          <a:p>
+            <a:pPr algn="l">
+              <a:lnSpc>
+                <a:spcPct val="112000"/>
+              </a:lnSpc>
+              <a:spcAft>
+                <a:spcPts val="0"/>
+              </a:spcAft>
+            </a:pPr>
+            <a:r>
+              <a:rPr sz="819" b="1">
+                <a:solidFill>
+                  <a:srgbClr val="8CA0BE"/>
+                </a:solidFill>
+                <a:latin typeface="Consolas"/>
+              </a:rPr>
+              <a:t>COLD START</a:t>
+            </a:r>
+          </a:p>
+        </p:txBody>
+      </p:sp>
+      <p:sp>
+        <p:nvSpPr>
+          <p:cNvPr id="38" name="Rectangle 37"/>
+          <p:cNvSpPr/>
+          <p:nvPr/>
+        </p:nvSpPr>
+        <p:spPr>
+          <a:xfrm>
+            <a:off x="7129119" y="3621024"/>
+            <a:ext cx="22860" cy="1408175"/>
+          </a:xfrm>
+          <a:prstGeom prst="rect">
+            <a:avLst/>
+          </a:prstGeom>
+          <a:solidFill>
+            <a:srgbClr val="223049"/>
+          </a:solidFill>
+          <a:ln>
+            <a:noFill/>
+          </a:ln>
+          <a:effectLst/>
+        </p:spPr>
+        <p:style>
+          <a:lnRef idx="1">
+            <a:schemeClr val="accent1"/>
+          </a:lnRef>
+          <a:fillRef idx="3">
+            <a:schemeClr val="accent1"/>
+          </a:fillRef>
+          <a:effectRef idx="2">
+            <a:schemeClr val="accent1"/>
+          </a:effectRef>
+          <a:fontRef idx="minor">
+            <a:schemeClr val="lt1"/>
+          </a:fontRef>
+        </p:style>
+        <p:txBody>
+          <a:bodyPr rtlCol="0" anchor="ctr"/>
+          <a:lstStyle/>
+          <a:p>
+            <a:pPr algn="ctr"/>
+          </a:p>
+        </p:txBody>
+      </p:sp>
+      <p:sp>
+        <p:nvSpPr>
+          <p:cNvPr id="39" name="TextBox 38"/>
+          <p:cNvSpPr txBox="1"/>
+          <p:nvPr/>
+        </p:nvSpPr>
+        <p:spPr>
+          <a:xfrm>
+            <a:off x="7293711" y="3602736"/>
+            <a:ext cx="4111599" cy="292608"/>
+          </a:xfrm>
+          <a:prstGeom prst="rect">
+            <a:avLst/>
+          </a:prstGeom>
+          <a:noFill/>
+        </p:spPr>
+        <p:txBody>
+          <a:bodyPr wrap="square" lIns="0" rIns="0" tIns="0" bIns="0" anchor="t">
+            <a:spAutoFit/>
+          </a:bodyPr>
+          <a:lstStyle/>
+          <a:p>
+            <a:pPr algn="l">
+              <a:lnSpc>
+                <a:spcPct val="112000"/>
+              </a:lnSpc>
+              <a:spcAft>
+                <a:spcPts val="0"/>
+              </a:spcAft>
+            </a:pPr>
+            <a:r>
+              <a:rPr sz="1220" b="1">
+                <a:solidFill>
+                  <a:srgbClr val="EAF0F7"/>
+                </a:solidFill>
+                <a:latin typeface="Segoe UI"/>
+              </a:rPr>
+              <a:t>The free tier sleeps</a:t>
+            </a:r>
+          </a:p>
+        </p:txBody>
+      </p:sp>
+      <p:sp>
+        <p:nvSpPr>
+          <p:cNvPr id="40" name="TextBox 39"/>
+          <p:cNvSpPr txBox="1"/>
+          <p:nvPr/>
+        </p:nvSpPr>
+        <p:spPr>
+          <a:xfrm>
+            <a:off x="7293711" y="3950208"/>
+            <a:ext cx="4111599" cy="612648"/>
+          </a:xfrm>
+          <a:prstGeom prst="rect">
+            <a:avLst/>
+          </a:prstGeom>
+          <a:noFill/>
+        </p:spPr>
+        <p:txBody>
+          <a:bodyPr wrap="square" lIns="0" rIns="0" tIns="0" bIns="0" anchor="t">
+            <a:spAutoFit/>
+          </a:bodyPr>
+          <a:lstStyle/>
+          <a:p>
+            <a:pPr algn="l">
+              <a:lnSpc>
+                <a:spcPct val="116000"/>
+              </a:lnSpc>
+              <a:spcAft>
+                <a:spcPts val="0"/>
+              </a:spcAft>
+            </a:pPr>
+            <a:r>
+              <a:rPr sz="1040" b="0">
+                <a:solidFill>
+                  <a:srgbClr val="8CA0BE"/>
+                </a:solidFill>
+                <a:latin typeface="Segoe UI"/>
+              </a:rPr>
+              <a:t>After idle time, the host suspends the app and the first visitor waits for a cold start.</a:t>
+            </a:r>
+          </a:p>
+        </p:txBody>
+      </p:sp>
+      <p:sp>
+        <p:nvSpPr>
+          <p:cNvPr id="41" name="Rounded Rectangle 40"/>
+          <p:cNvSpPr/>
+          <p:nvPr/>
+        </p:nvSpPr>
+        <p:spPr>
+          <a:xfrm>
+            <a:off x="7293711" y="4773167"/>
+            <a:ext cx="4111599" cy="274320"/>
+          </a:xfrm>
+          <a:prstGeom prst="roundRect">
+            <a:avLst>
+              <a:gd name="adj" fmla="val 8000"/>
+            </a:avLst>
+          </a:prstGeom>
+          <a:solidFill>
+            <a:srgbClr val="162136"/>
+          </a:solidFill>
+          <a:ln w="10160">
+            <a:solidFill>
+              <a:srgbClr val="F5A623"/>
+            </a:solidFill>
+          </a:ln>
+          <a:effectLst/>
+        </p:spPr>
+        <p:style>
+          <a:lnRef idx="1">
+            <a:schemeClr val="accent1"/>
+          </a:lnRef>
+          <a:fillRef idx="3">
+            <a:schemeClr val="accent1"/>
+          </a:fillRef>
+          <a:effectRef idx="2">
+            <a:schemeClr val="accent1"/>
+          </a:effectRef>
+          <a:fontRef idx="minor">
+            <a:schemeClr val="lt1"/>
+          </a:fontRef>
+        </p:style>
+        <p:txBody>
+          <a:bodyPr rtlCol="0" anchor="ctr"/>
+          <a:lstStyle/>
+          <a:p>
+            <a:pPr algn="ctr"/>
+          </a:p>
+        </p:txBody>
+      </p:sp>
+      <p:sp>
+        <p:nvSpPr>
+          <p:cNvPr id="42" name="TextBox 41"/>
+          <p:cNvSpPr txBox="1"/>
+          <p:nvPr/>
+        </p:nvSpPr>
+        <p:spPr>
+          <a:xfrm>
+            <a:off x="7403439" y="4805171"/>
+            <a:ext cx="3892143" cy="201168"/>
+          </a:xfrm>
+          <a:prstGeom prst="rect">
+            <a:avLst/>
+          </a:prstGeom>
+          <a:noFill/>
+        </p:spPr>
+        <p:txBody>
+          <a:bodyPr wrap="square" lIns="0" rIns="0" tIns="0" bIns="0" anchor="t">
+            <a:spAutoFit/>
+          </a:bodyPr>
+          <a:lstStyle/>
+          <a:p>
+            <a:pPr algn="l">
+              <a:lnSpc>
+                <a:spcPct val="112000"/>
+              </a:lnSpc>
+              <a:spcAft>
+                <a:spcPts val="0"/>
+              </a:spcAft>
+            </a:pPr>
+            <a:r>
+              <a:rPr sz="890" b="1">
+                <a:solidFill>
+                  <a:srgbClr val="F5A623"/>
+                </a:solidFill>
+                <a:latin typeface="Consolas"/>
+              </a:rPr>
+              <a:t>→  WARM BEFORE DEMO</a:t>
+            </a:r>
+          </a:p>
+        </p:txBody>
+      </p:sp>
+      <p:sp>
+        <p:nvSpPr>
+          <p:cNvPr id="43" name="Rounded Rectangle 42"/>
+          <p:cNvSpPr/>
+          <p:nvPr/>
+        </p:nvSpPr>
+        <p:spPr>
+          <a:xfrm>
+            <a:off x="566928" y="5358383"/>
+            <a:ext cx="11057839" cy="859535"/>
+          </a:xfrm>
+          <a:prstGeom prst="roundRect">
+            <a:avLst>
+              <a:gd name="adj" fmla="val 8000"/>
+            </a:avLst>
+          </a:prstGeom>
+          <a:solidFill>
+            <a:srgbClr val="162136"/>
+          </a:solidFill>
+          <a:ln w="13970">
+            <a:solidFill>
+              <a:srgbClr val="4C8DFF"/>
+            </a:solidFill>
+          </a:ln>
+          <a:effectLst/>
+        </p:spPr>
+        <p:style>
+          <a:lnRef idx="1">
+            <a:schemeClr val="accent1"/>
+          </a:lnRef>
+          <a:fillRef idx="3">
+            <a:schemeClr val="accent1"/>
+          </a:fillRef>
+          <a:effectRef idx="2">
+            <a:schemeClr val="accent1"/>
+          </a:effectRef>
+          <a:fontRef idx="minor">
+            <a:schemeClr val="lt1"/>
+          </a:fontRef>
+        </p:style>
+        <p:txBody>
+          <a:bodyPr rtlCol="0" anchor="ctr"/>
+          <a:lstStyle/>
+          <a:p>
+            <a:pPr algn="ctr"/>
+          </a:p>
+        </p:txBody>
+      </p:sp>
+      <p:sp>
+        <p:nvSpPr>
+          <p:cNvPr id="44" name="TextBox 43"/>
+          <p:cNvSpPr txBox="1"/>
+          <p:nvPr/>
+        </p:nvSpPr>
+        <p:spPr>
+          <a:xfrm>
+            <a:off x="749808" y="5678423"/>
+            <a:ext cx="1389888" cy="256032"/>
+          </a:xfrm>
+          <a:prstGeom prst="rect">
+            <a:avLst/>
+          </a:prstGeom>
+          <a:noFill/>
+        </p:spPr>
+        <p:txBody>
+          <a:bodyPr wrap="square" lIns="0" rIns="0" tIns="0" bIns="0" anchor="t">
+            <a:spAutoFit/>
+          </a:bodyPr>
+          <a:lstStyle/>
+          <a:p>
+            <a:pPr algn="l">
+              <a:lnSpc>
+                <a:spcPct val="112000"/>
+              </a:lnSpc>
+              <a:spcAft>
+                <a:spcPts val="0"/>
+              </a:spcAft>
+            </a:pPr>
+            <a:r>
+              <a:rPr sz="919" b="1">
+                <a:solidFill>
+                  <a:srgbClr val="4C8DFF"/>
+                </a:solidFill>
+                <a:latin typeface="Consolas"/>
+              </a:rPr>
+              <a:t>DEPLOYMENT
+STACK</a:t>
+            </a:r>
+          </a:p>
+        </p:txBody>
+      </p:sp>
+      <p:sp>
+        <p:nvSpPr>
+          <p:cNvPr id="45" name="Rounded Rectangle 44"/>
+          <p:cNvSpPr/>
+          <p:nvPr/>
+        </p:nvSpPr>
+        <p:spPr>
+          <a:xfrm>
+            <a:off x="2286000" y="5650992"/>
+            <a:ext cx="1554480" cy="292608"/>
+          </a:xfrm>
+          <a:prstGeom prst="roundRect">
+            <a:avLst>
+              <a:gd name="adj" fmla="val 8000"/>
+            </a:avLst>
+          </a:prstGeom>
+          <a:solidFill>
+            <a:srgbClr val="111A2C"/>
+          </a:solidFill>
+          <a:ln w="8890">
+            <a:solidFill>
+              <a:srgbClr val="223049"/>
+            </a:solidFill>
+          </a:ln>
+          <a:effectLst/>
+        </p:spPr>
+        <p:style>
+          <a:lnRef idx="1">
+            <a:schemeClr val="accent1"/>
+          </a:lnRef>
+          <a:fillRef idx="3">
+            <a:schemeClr val="accent1"/>
+          </a:fillRef>
+          <a:effectRef idx="2">
+            <a:schemeClr val="accent1"/>
+          </a:effectRef>
+          <a:fontRef idx="minor">
+            <a:schemeClr val="lt1"/>
+          </a:fontRef>
+        </p:style>
+        <p:txBody>
+          <a:bodyPr rtlCol="0" anchor="ctr"/>
+          <a:lstStyle/>
+          <a:p>
+            <a:pPr algn="ctr"/>
+          </a:p>
+        </p:txBody>
+      </p:sp>
+      <p:sp>
+        <p:nvSpPr>
+          <p:cNvPr id="46" name="TextBox 45"/>
+          <p:cNvSpPr txBox="1"/>
+          <p:nvPr/>
+        </p:nvSpPr>
+        <p:spPr>
+          <a:xfrm>
+            <a:off x="2359152" y="5692140"/>
+            <a:ext cx="1408176" cy="201168"/>
+          </a:xfrm>
+          <a:prstGeom prst="rect">
+            <a:avLst/>
+          </a:prstGeom>
+          <a:noFill/>
+        </p:spPr>
+        <p:txBody>
+          <a:bodyPr wrap="square" lIns="0" rIns="0" tIns="0" bIns="0" anchor="t">
+            <a:spAutoFit/>
+          </a:bodyPr>
+          <a:lstStyle/>
+          <a:p>
+            <a:pPr algn="l">
+              <a:lnSpc>
+                <a:spcPct val="112000"/>
+              </a:lnSpc>
+              <a:spcAft>
+                <a:spcPts val="0"/>
+              </a:spcAft>
+            </a:pPr>
+            <a:r>
+              <a:rPr sz="800" b="1">
+                <a:solidFill>
+                  <a:srgbClr val="2FD8B4"/>
+                </a:solidFill>
+                <a:latin typeface="Consolas"/>
+              </a:rPr>
+              <a:t>GUNICORN · GTHREAD</a:t>
+            </a:r>
+          </a:p>
+        </p:txBody>
+      </p:sp>
+      <p:sp>
+        <p:nvSpPr>
+          <p:cNvPr id="47" name="Rounded Rectangle 46"/>
+          <p:cNvSpPr/>
+          <p:nvPr/>
+        </p:nvSpPr>
+        <p:spPr>
+          <a:xfrm>
+            <a:off x="3931920" y="5650992"/>
+            <a:ext cx="1188720" cy="292608"/>
+          </a:xfrm>
+          <a:prstGeom prst="roundRect">
+            <a:avLst>
+              <a:gd name="adj" fmla="val 8000"/>
+            </a:avLst>
+          </a:prstGeom>
+          <a:solidFill>
+            <a:srgbClr val="111A2C"/>
+          </a:solidFill>
+          <a:ln w="8890">
+            <a:solidFill>
+              <a:srgbClr val="223049"/>
+            </a:solidFill>
+          </a:ln>
+          <a:effectLst/>
+        </p:spPr>
+        <p:style>
+          <a:lnRef idx="1">
+            <a:schemeClr val="accent1"/>
+          </a:lnRef>
+          <a:fillRef idx="3">
+            <a:schemeClr val="accent1"/>
+          </a:fillRef>
+          <a:effectRef idx="2">
+            <a:schemeClr val="accent1"/>
+          </a:effectRef>
+          <a:fontRef idx="minor">
+            <a:schemeClr val="lt1"/>
+          </a:fontRef>
+        </p:style>
+        <p:txBody>
+          <a:bodyPr rtlCol="0" anchor="ctr"/>
+          <a:lstStyle/>
+          <a:p>
+            <a:pPr algn="ctr"/>
+          </a:p>
+        </p:txBody>
+      </p:sp>
+      <p:sp>
+        <p:nvSpPr>
+          <p:cNvPr id="48" name="TextBox 47"/>
+          <p:cNvSpPr txBox="1"/>
+          <p:nvPr/>
+        </p:nvSpPr>
+        <p:spPr>
+          <a:xfrm>
+            <a:off x="4005072" y="5692140"/>
+            <a:ext cx="1042416" cy="201168"/>
+          </a:xfrm>
+          <a:prstGeom prst="rect">
+            <a:avLst/>
+          </a:prstGeom>
+          <a:noFill/>
+        </p:spPr>
+        <p:txBody>
+          <a:bodyPr wrap="square" lIns="0" rIns="0" tIns="0" bIns="0" anchor="t">
+            <a:spAutoFit/>
+          </a:bodyPr>
+          <a:lstStyle/>
+          <a:p>
+            <a:pPr algn="l">
+              <a:lnSpc>
+                <a:spcPct val="112000"/>
+              </a:lnSpc>
+              <a:spcAft>
+                <a:spcPts val="0"/>
+              </a:spcAft>
+            </a:pPr>
+            <a:r>
+              <a:rPr sz="800" b="1">
+                <a:solidFill>
+                  <a:srgbClr val="4C8DFF"/>
+                </a:solidFill>
+                <a:latin typeface="Consolas"/>
+              </a:rPr>
+              <a:t>TIMEOUT 300S</a:t>
+            </a:r>
+          </a:p>
+        </p:txBody>
+      </p:sp>
+      <p:sp>
+        <p:nvSpPr>
+          <p:cNvPr id="49" name="Rounded Rectangle 48"/>
+          <p:cNvSpPr/>
+          <p:nvPr/>
+        </p:nvSpPr>
+        <p:spPr>
+          <a:xfrm>
+            <a:off x="5212080" y="5650992"/>
+            <a:ext cx="1572768" cy="292608"/>
+          </a:xfrm>
+          <a:prstGeom prst="roundRect">
+            <a:avLst>
+              <a:gd name="adj" fmla="val 8000"/>
+            </a:avLst>
+          </a:prstGeom>
+          <a:solidFill>
+            <a:srgbClr val="111A2C"/>
+          </a:solidFill>
+          <a:ln w="8890">
+            <a:solidFill>
+              <a:srgbClr val="223049"/>
+            </a:solidFill>
+          </a:ln>
+          <a:effectLst/>
+        </p:spPr>
+        <p:style>
+          <a:lnRef idx="1">
+            <a:schemeClr val="accent1"/>
+          </a:lnRef>
+          <a:fillRef idx="3">
+            <a:schemeClr val="accent1"/>
+          </a:fillRef>
+          <a:effectRef idx="2">
+            <a:schemeClr val="accent1"/>
+          </a:effectRef>
+          <a:fontRef idx="minor">
+            <a:schemeClr val="lt1"/>
+          </a:fontRef>
+        </p:style>
+        <p:txBody>
+          <a:bodyPr rtlCol="0" anchor="ctr"/>
+          <a:lstStyle/>
+          <a:p>
+            <a:pPr algn="ctr"/>
+          </a:p>
+        </p:txBody>
+      </p:sp>
+      <p:sp>
+        <p:nvSpPr>
+          <p:cNvPr id="50" name="TextBox 49"/>
+          <p:cNvSpPr txBox="1"/>
+          <p:nvPr/>
+        </p:nvSpPr>
+        <p:spPr>
+          <a:xfrm>
+            <a:off x="5285232" y="5692140"/>
+            <a:ext cx="1426464" cy="201168"/>
+          </a:xfrm>
+          <a:prstGeom prst="rect">
+            <a:avLst/>
+          </a:prstGeom>
+          <a:noFill/>
+        </p:spPr>
+        <p:txBody>
+          <a:bodyPr wrap="square" lIns="0" rIns="0" tIns="0" bIns="0" anchor="t">
+            <a:spAutoFit/>
+          </a:bodyPr>
+          <a:lstStyle/>
+          <a:p>
+            <a:pPr algn="l">
+              <a:lnSpc>
+                <a:spcPct val="112000"/>
+              </a:lnSpc>
+              <a:spcAft>
+                <a:spcPts val="0"/>
+              </a:spcAft>
+            </a:pPr>
+            <a:r>
+              <a:rPr sz="800" b="1">
+                <a:solidFill>
+                  <a:srgbClr val="2FD8B4"/>
+                </a:solidFill>
+                <a:latin typeface="Consolas"/>
+              </a:rPr>
+              <a:t>PRELOAD + RECYCLE</a:t>
+            </a:r>
+          </a:p>
+        </p:txBody>
+      </p:sp>
+      <p:sp>
+        <p:nvSpPr>
+          <p:cNvPr id="51" name="Rounded Rectangle 50"/>
+          <p:cNvSpPr/>
+          <p:nvPr/>
+        </p:nvSpPr>
+        <p:spPr>
+          <a:xfrm>
+            <a:off x="6876288" y="5650992"/>
+            <a:ext cx="1755648" cy="292608"/>
+          </a:xfrm>
+          <a:prstGeom prst="roundRect">
+            <a:avLst>
+              <a:gd name="adj" fmla="val 8000"/>
+            </a:avLst>
+          </a:prstGeom>
+          <a:solidFill>
+            <a:srgbClr val="111A2C"/>
+          </a:solidFill>
+          <a:ln w="8890">
+            <a:solidFill>
+              <a:srgbClr val="223049"/>
+            </a:solidFill>
+          </a:ln>
+          <a:effectLst/>
+        </p:spPr>
+        <p:style>
+          <a:lnRef idx="1">
+            <a:schemeClr val="accent1"/>
+          </a:lnRef>
+          <a:fillRef idx="3">
+            <a:schemeClr val="accent1"/>
+          </a:fillRef>
+          <a:effectRef idx="2">
+            <a:schemeClr val="accent1"/>
+          </a:effectRef>
+          <a:fontRef idx="minor">
+            <a:schemeClr val="lt1"/>
+          </a:fontRef>
+        </p:style>
+        <p:txBody>
+          <a:bodyPr rtlCol="0" anchor="ctr"/>
+          <a:lstStyle/>
+          <a:p>
+            <a:pPr algn="ctr"/>
+          </a:p>
+        </p:txBody>
+      </p:sp>
+      <p:sp>
+        <p:nvSpPr>
+          <p:cNvPr id="52" name="TextBox 51"/>
+          <p:cNvSpPr txBox="1"/>
+          <p:nvPr/>
+        </p:nvSpPr>
+        <p:spPr>
+          <a:xfrm>
+            <a:off x="6949440" y="5692140"/>
+            <a:ext cx="1609344" cy="201168"/>
+          </a:xfrm>
+          <a:prstGeom prst="rect">
+            <a:avLst/>
+          </a:prstGeom>
+          <a:noFill/>
+        </p:spPr>
+        <p:txBody>
+          <a:bodyPr wrap="square" lIns="0" rIns="0" tIns="0" bIns="0" anchor="t">
+            <a:spAutoFit/>
+          </a:bodyPr>
+          <a:lstStyle/>
+          <a:p>
+            <a:pPr algn="l">
+              <a:lnSpc>
+                <a:spcPct val="112000"/>
+              </a:lnSpc>
+              <a:spcAft>
+                <a:spcPts val="0"/>
+              </a:spcAft>
+            </a:pPr>
+            <a:r>
+              <a:rPr sz="800" b="1">
+                <a:solidFill>
+                  <a:srgbClr val="4C8DFF"/>
+                </a:solidFill>
+                <a:latin typeface="Consolas"/>
+              </a:rPr>
+              <a:t>DOCKERFILE · PROCFILE</a:t>
+            </a:r>
+          </a:p>
+        </p:txBody>
+      </p:sp>
+      <p:sp>
+        <p:nvSpPr>
+          <p:cNvPr id="53" name="Rounded Rectangle 52"/>
+          <p:cNvSpPr/>
+          <p:nvPr/>
+        </p:nvSpPr>
+        <p:spPr>
+          <a:xfrm>
+            <a:off x="8723376" y="5650992"/>
+            <a:ext cx="1783080" cy="292608"/>
+          </a:xfrm>
+          <a:prstGeom prst="roundRect">
+            <a:avLst>
+              <a:gd name="adj" fmla="val 8000"/>
+            </a:avLst>
+          </a:prstGeom>
+          <a:solidFill>
+            <a:srgbClr val="111A2C"/>
+          </a:solidFill>
+          <a:ln w="8890">
+            <a:solidFill>
+              <a:srgbClr val="223049"/>
+            </a:solidFill>
+          </a:ln>
+          <a:effectLst/>
+        </p:spPr>
+        <p:style>
+          <a:lnRef idx="1">
+            <a:schemeClr val="accent1"/>
+          </a:lnRef>
+          <a:fillRef idx="3">
+            <a:schemeClr val="accent1"/>
+          </a:fillRef>
+          <a:effectRef idx="2">
+            <a:schemeClr val="accent1"/>
+          </a:effectRef>
+          <a:fontRef idx="minor">
+            <a:schemeClr val="lt1"/>
+          </a:fontRef>
+        </p:style>
+        <p:txBody>
+          <a:bodyPr rtlCol="0" anchor="ctr"/>
+          <a:lstStyle/>
+          <a:p>
+            <a:pPr algn="ctr"/>
+          </a:p>
+        </p:txBody>
+      </p:sp>
+      <p:sp>
+        <p:nvSpPr>
+          <p:cNvPr id="54" name="TextBox 53"/>
+          <p:cNvSpPr txBox="1"/>
+          <p:nvPr/>
+        </p:nvSpPr>
+        <p:spPr>
+          <a:xfrm>
+            <a:off x="8796528" y="5692140"/>
+            <a:ext cx="1636776" cy="201168"/>
+          </a:xfrm>
+          <a:prstGeom prst="rect">
+            <a:avLst/>
+          </a:prstGeom>
+          <a:noFill/>
+        </p:spPr>
+        <p:txBody>
+          <a:bodyPr wrap="square" lIns="0" rIns="0" tIns="0" bIns="0" anchor="t">
+            <a:spAutoFit/>
+          </a:bodyPr>
+          <a:lstStyle/>
+          <a:p>
+            <a:pPr algn="l">
+              <a:lnSpc>
+                <a:spcPct val="112000"/>
+              </a:lnSpc>
+              <a:spcAft>
+                <a:spcPts val="0"/>
+              </a:spcAft>
+            </a:pPr>
+            <a:r>
+              <a:rPr sz="800" b="1">
+                <a:solidFill>
+                  <a:srgbClr val="2FD8B4"/>
+                </a:solidFill>
+                <a:latin typeface="Consolas"/>
+              </a:rPr>
+              <a:t>PINNED REQS · RENDER</a:t>
+            </a:r>
+          </a:p>
+        </p:txBody>
+      </p:sp>
+      <p:sp>
+        <p:nvSpPr>
+          <p:cNvPr id="55" name="Rectangle 54"/>
+          <p:cNvSpPr/>
+          <p:nvPr/>
+        </p:nvSpPr>
+        <p:spPr>
+          <a:xfrm>
+            <a:off x="566928" y="6309360"/>
+            <a:ext cx="743145" cy="43891"/>
+          </a:xfrm>
+          <a:prstGeom prst="rect">
+            <a:avLst/>
+          </a:prstGeom>
+          <a:solidFill>
+            <a:srgbClr val="223049"/>
+          </a:solidFill>
+          <a:ln>
+            <a:noFill/>
+          </a:ln>
+          <a:effectLst/>
+        </p:spPr>
+        <p:style>
+          <a:lnRef idx="1">
+            <a:schemeClr val="accent1"/>
+          </a:lnRef>
+          <a:fillRef idx="3">
+            <a:schemeClr val="accent1"/>
+          </a:fillRef>
+          <a:effectRef idx="2">
+            <a:schemeClr val="accent1"/>
+          </a:effectRef>
+          <a:fontRef idx="minor">
+            <a:schemeClr val="lt1"/>
+          </a:fontRef>
+        </p:style>
+        <p:txBody>
+          <a:bodyPr rtlCol="0" anchor="ctr"/>
+          <a:lstStyle/>
+          <a:p>
+            <a:pPr algn="ctr"/>
+          </a:p>
+        </p:txBody>
+      </p:sp>
+      <p:sp>
+        <p:nvSpPr>
+          <p:cNvPr id="56" name="Rectangle 55"/>
+          <p:cNvSpPr/>
+          <p:nvPr/>
+        </p:nvSpPr>
+        <p:spPr>
+          <a:xfrm>
+            <a:off x="1360365" y="6309360"/>
+            <a:ext cx="743145" cy="43891"/>
+          </a:xfrm>
+          <a:prstGeom prst="rect">
+            <a:avLst/>
+          </a:prstGeom>
+          <a:solidFill>
+            <a:srgbClr val="223049"/>
+          </a:solidFill>
+          <a:ln>
+            <a:noFill/>
+          </a:ln>
+          <a:effectLst/>
+        </p:spPr>
+        <p:style>
+          <a:lnRef idx="1">
+            <a:schemeClr val="accent1"/>
+          </a:lnRef>
+          <a:fillRef idx="3">
+            <a:schemeClr val="accent1"/>
+          </a:fillRef>
+          <a:effectRef idx="2">
+            <a:schemeClr val="accent1"/>
+          </a:effectRef>
+          <a:fontRef idx="minor">
+            <a:schemeClr val="lt1"/>
+          </a:fontRef>
+        </p:style>
+        <p:txBody>
+          <a:bodyPr rtlCol="0" anchor="ctr"/>
+          <a:lstStyle/>
+          <a:p>
+            <a:pPr algn="ctr"/>
+          </a:p>
+        </p:txBody>
+      </p:sp>
+      <p:sp>
+        <p:nvSpPr>
+          <p:cNvPr id="57" name="Rectangle 56"/>
+          <p:cNvSpPr/>
+          <p:nvPr/>
+        </p:nvSpPr>
+        <p:spPr>
+          <a:xfrm>
+            <a:off x="2153803" y="6309360"/>
+            <a:ext cx="743145" cy="43891"/>
+          </a:xfrm>
+          <a:prstGeom prst="rect">
+            <a:avLst/>
+          </a:prstGeom>
+          <a:solidFill>
+            <a:srgbClr val="223049"/>
+          </a:solidFill>
+          <a:ln>
+            <a:noFill/>
+          </a:ln>
+          <a:effectLst/>
+        </p:spPr>
+        <p:style>
+          <a:lnRef idx="1">
+            <a:schemeClr val="accent1"/>
+          </a:lnRef>
+          <a:fillRef idx="3">
+            <a:schemeClr val="accent1"/>
+          </a:fillRef>
+          <a:effectRef idx="2">
+            <a:schemeClr val="accent1"/>
+          </a:effectRef>
+          <a:fontRef idx="minor">
+            <a:schemeClr val="lt1"/>
+          </a:fontRef>
+        </p:style>
+        <p:txBody>
+          <a:bodyPr rtlCol="0" anchor="ctr"/>
+          <a:lstStyle/>
+          <a:p>
+            <a:pPr algn="ctr"/>
+          </a:p>
+        </p:txBody>
+      </p:sp>
+      <p:sp>
+        <p:nvSpPr>
+          <p:cNvPr id="58" name="Rectangle 57"/>
+          <p:cNvSpPr/>
+          <p:nvPr/>
+        </p:nvSpPr>
+        <p:spPr>
+          <a:xfrm>
+            <a:off x="2947241" y="6309360"/>
+            <a:ext cx="743145" cy="43891"/>
+          </a:xfrm>
+          <a:prstGeom prst="rect">
+            <a:avLst/>
+          </a:prstGeom>
+          <a:solidFill>
+            <a:srgbClr val="223049"/>
+          </a:solidFill>
+          <a:ln>
+            <a:noFill/>
+          </a:ln>
+          <a:effectLst/>
+        </p:spPr>
+        <p:style>
+          <a:lnRef idx="1">
+            <a:schemeClr val="accent1"/>
+          </a:lnRef>
+          <a:fillRef idx="3">
+            <a:schemeClr val="accent1"/>
+          </a:fillRef>
+          <a:effectRef idx="2">
+            <a:schemeClr val="accent1"/>
+          </a:effectRef>
+          <a:fontRef idx="minor">
+            <a:schemeClr val="lt1"/>
+          </a:fontRef>
+        </p:style>
+        <p:txBody>
+          <a:bodyPr rtlCol="0" anchor="ctr"/>
+          <a:lstStyle/>
+          <a:p>
+            <a:pPr algn="ctr"/>
+          </a:p>
+        </p:txBody>
+      </p:sp>
+      <p:sp>
+        <p:nvSpPr>
+          <p:cNvPr id="59" name="Rectangle 58"/>
+          <p:cNvSpPr/>
+          <p:nvPr/>
+        </p:nvSpPr>
+        <p:spPr>
+          <a:xfrm>
+            <a:off x="3740679" y="6309360"/>
+            <a:ext cx="743145" cy="43891"/>
+          </a:xfrm>
+          <a:prstGeom prst="rect">
+            <a:avLst/>
+          </a:prstGeom>
+          <a:solidFill>
+            <a:srgbClr val="223049"/>
+          </a:solidFill>
+          <a:ln>
+            <a:noFill/>
+          </a:ln>
+          <a:effectLst/>
+        </p:spPr>
+        <p:style>
+          <a:lnRef idx="1">
+            <a:schemeClr val="accent1"/>
+          </a:lnRef>
+          <a:fillRef idx="3">
+            <a:schemeClr val="accent1"/>
+          </a:fillRef>
+          <a:effectRef idx="2">
+            <a:schemeClr val="accent1"/>
+          </a:effectRef>
+          <a:fontRef idx="minor">
+            <a:schemeClr val="lt1"/>
+          </a:fontRef>
+        </p:style>
+        <p:txBody>
+          <a:bodyPr rtlCol="0" anchor="ctr"/>
+          <a:lstStyle/>
+          <a:p>
+            <a:pPr algn="ctr"/>
+          </a:p>
+        </p:txBody>
+      </p:sp>
+      <p:sp>
+        <p:nvSpPr>
+          <p:cNvPr id="60" name="Rectangle 59"/>
+          <p:cNvSpPr/>
+          <p:nvPr/>
+        </p:nvSpPr>
+        <p:spPr>
+          <a:xfrm>
+            <a:off x="4534117" y="6309360"/>
+            <a:ext cx="743145" cy="43891"/>
+          </a:xfrm>
+          <a:prstGeom prst="rect">
+            <a:avLst/>
+          </a:prstGeom>
+          <a:solidFill>
+            <a:srgbClr val="223049"/>
+          </a:solidFill>
+          <a:ln>
+            <a:noFill/>
+          </a:ln>
+          <a:effectLst/>
+        </p:spPr>
+        <p:style>
+          <a:lnRef idx="1">
+            <a:schemeClr val="accent1"/>
+          </a:lnRef>
+          <a:fillRef idx="3">
+            <a:schemeClr val="accent1"/>
+          </a:fillRef>
+          <a:effectRef idx="2">
+            <a:schemeClr val="accent1"/>
+          </a:effectRef>
+          <a:fontRef idx="minor">
+            <a:schemeClr val="lt1"/>
+          </a:fontRef>
+        </p:style>
+        <p:txBody>
+          <a:bodyPr rtlCol="0" anchor="ctr"/>
+          <a:lstStyle/>
+          <a:p>
+            <a:pPr algn="ctr"/>
+          </a:p>
+        </p:txBody>
+      </p:sp>
+      <p:sp>
+        <p:nvSpPr>
+          <p:cNvPr id="61" name="Rectangle 60"/>
+          <p:cNvSpPr/>
+          <p:nvPr/>
+        </p:nvSpPr>
+        <p:spPr>
+          <a:xfrm>
+            <a:off x="5327555" y="6309360"/>
+            <a:ext cx="743145" cy="43891"/>
+          </a:xfrm>
+          <a:prstGeom prst="rect">
+            <a:avLst/>
+          </a:prstGeom>
+          <a:solidFill>
+            <a:srgbClr val="223049"/>
+          </a:solidFill>
+          <a:ln>
+            <a:noFill/>
+          </a:ln>
+          <a:effectLst/>
+        </p:spPr>
+        <p:style>
+          <a:lnRef idx="1">
+            <a:schemeClr val="accent1"/>
+          </a:lnRef>
+          <a:fillRef idx="3">
+            <a:schemeClr val="accent1"/>
+          </a:fillRef>
+          <a:effectRef idx="2">
+            <a:schemeClr val="accent1"/>
+          </a:effectRef>
+          <a:fontRef idx="minor">
+            <a:schemeClr val="lt1"/>
+          </a:fontRef>
+        </p:style>
+        <p:txBody>
+          <a:bodyPr rtlCol="0" anchor="ctr"/>
+          <a:lstStyle/>
+          <a:p>
+            <a:pPr algn="ctr"/>
+          </a:p>
+        </p:txBody>
+      </p:sp>
+      <p:sp>
+        <p:nvSpPr>
+          <p:cNvPr id="62" name="Rectangle 61"/>
+          <p:cNvSpPr/>
+          <p:nvPr/>
+        </p:nvSpPr>
+        <p:spPr>
+          <a:xfrm>
+            <a:off x="6120993" y="6309360"/>
+            <a:ext cx="743145" cy="43891"/>
+          </a:xfrm>
+          <a:prstGeom prst="rect">
+            <a:avLst/>
+          </a:prstGeom>
+          <a:solidFill>
+            <a:srgbClr val="223049"/>
+          </a:solidFill>
+          <a:ln>
+            <a:noFill/>
+          </a:ln>
+          <a:effectLst/>
+        </p:spPr>
+        <p:style>
+          <a:lnRef idx="1">
+            <a:schemeClr val="accent1"/>
+          </a:lnRef>
+          <a:fillRef idx="3">
+            <a:schemeClr val="accent1"/>
+          </a:fillRef>
+          <a:effectRef idx="2">
+            <a:schemeClr val="accent1"/>
+          </a:effectRef>
+          <a:fontRef idx="minor">
+            <a:schemeClr val="lt1"/>
+          </a:fontRef>
+        </p:style>
+        <p:txBody>
+          <a:bodyPr rtlCol="0" anchor="ctr"/>
+          <a:lstStyle/>
+          <a:p>
+            <a:pPr algn="ctr"/>
+          </a:p>
+        </p:txBody>
+      </p:sp>
+      <p:sp>
+        <p:nvSpPr>
+          <p:cNvPr id="63" name="Rectangle 62"/>
+          <p:cNvSpPr/>
+          <p:nvPr/>
+        </p:nvSpPr>
+        <p:spPr>
+          <a:xfrm>
+            <a:off x="6914431" y="6309360"/>
+            <a:ext cx="743145" cy="43891"/>
+          </a:xfrm>
+          <a:prstGeom prst="rect">
+            <a:avLst/>
+          </a:prstGeom>
+          <a:solidFill>
+            <a:srgbClr val="223049"/>
+          </a:solidFill>
+          <a:ln>
+            <a:noFill/>
+          </a:ln>
+          <a:effectLst/>
+        </p:spPr>
+        <p:style>
+          <a:lnRef idx="1">
+            <a:schemeClr val="accent1"/>
+          </a:lnRef>
+          <a:fillRef idx="3">
+            <a:schemeClr val="accent1"/>
+          </a:fillRef>
+          <a:effectRef idx="2">
+            <a:schemeClr val="accent1"/>
+          </a:effectRef>
+          <a:fontRef idx="minor">
+            <a:schemeClr val="lt1"/>
+          </a:fontRef>
+        </p:style>
+        <p:txBody>
+          <a:bodyPr rtlCol="0" anchor="ctr"/>
+          <a:lstStyle/>
+          <a:p>
+            <a:pPr algn="ctr"/>
+          </a:p>
+        </p:txBody>
+      </p:sp>
+      <p:sp>
+        <p:nvSpPr>
+          <p:cNvPr id="64" name="Rectangle 63"/>
+          <p:cNvSpPr/>
+          <p:nvPr/>
+        </p:nvSpPr>
+        <p:spPr>
+          <a:xfrm>
+            <a:off x="7707869" y="6309360"/>
+            <a:ext cx="743145" cy="43891"/>
+          </a:xfrm>
+          <a:prstGeom prst="rect">
+            <a:avLst/>
+          </a:prstGeom>
+          <a:solidFill>
+            <a:srgbClr val="223049"/>
+          </a:solidFill>
+          <a:ln>
+            <a:noFill/>
+          </a:ln>
+          <a:effectLst/>
+        </p:spPr>
+        <p:style>
+          <a:lnRef idx="1">
+            <a:schemeClr val="accent1"/>
+          </a:lnRef>
+          <a:fillRef idx="3">
+            <a:schemeClr val="accent1"/>
+          </a:fillRef>
+          <a:effectRef idx="2">
+            <a:schemeClr val="accent1"/>
+          </a:effectRef>
+          <a:fontRef idx="minor">
+            <a:schemeClr val="lt1"/>
+          </a:fontRef>
+        </p:style>
+        <p:txBody>
+          <a:bodyPr rtlCol="0" anchor="ctr"/>
+          <a:lstStyle/>
+          <a:p>
+            <a:pPr algn="ctr"/>
+          </a:p>
+        </p:txBody>
+      </p:sp>
+      <p:sp>
+        <p:nvSpPr>
+          <p:cNvPr id="65" name="Rectangle 64"/>
+          <p:cNvSpPr/>
+          <p:nvPr/>
+        </p:nvSpPr>
+        <p:spPr>
+          <a:xfrm>
+            <a:off x="8501307" y="6309360"/>
+            <a:ext cx="743145" cy="43891"/>
+          </a:xfrm>
+          <a:prstGeom prst="rect">
+            <a:avLst/>
+          </a:prstGeom>
+          <a:solidFill>
+            <a:srgbClr val="223049"/>
+          </a:solidFill>
+          <a:ln>
+            <a:noFill/>
+          </a:ln>
+          <a:effectLst/>
+        </p:spPr>
+        <p:style>
+          <a:lnRef idx="1">
+            <a:schemeClr val="accent1"/>
+          </a:lnRef>
+          <a:fillRef idx="3">
+            <a:schemeClr val="accent1"/>
+          </a:fillRef>
+          <a:effectRef idx="2">
+            <a:schemeClr val="accent1"/>
+          </a:effectRef>
+          <a:fontRef idx="minor">
+            <a:schemeClr val="lt1"/>
+          </a:fontRef>
+        </p:style>
+        <p:txBody>
+          <a:bodyPr rtlCol="0" anchor="ctr"/>
+          <a:lstStyle/>
+          <a:p>
+            <a:pPr algn="ctr"/>
+          </a:p>
+        </p:txBody>
+      </p:sp>
+      <p:sp>
+        <p:nvSpPr>
+          <p:cNvPr id="66" name="Rectangle 65"/>
+          <p:cNvSpPr/>
+          <p:nvPr/>
+        </p:nvSpPr>
+        <p:spPr>
+          <a:xfrm>
+            <a:off x="9294745" y="6309360"/>
+            <a:ext cx="743145" cy="43891"/>
+          </a:xfrm>
+          <a:prstGeom prst="rect">
+            <a:avLst/>
+          </a:prstGeom>
+          <a:solidFill>
+            <a:srgbClr val="223049"/>
+          </a:solidFill>
+          <a:ln>
+            <a:noFill/>
+          </a:ln>
+          <a:effectLst/>
+        </p:spPr>
+        <p:style>
+          <a:lnRef idx="1">
+            <a:schemeClr val="accent1"/>
+          </a:lnRef>
+          <a:fillRef idx="3">
+            <a:schemeClr val="accent1"/>
+          </a:fillRef>
+          <a:effectRef idx="2">
+            <a:schemeClr val="accent1"/>
+          </a:effectRef>
+          <a:fontRef idx="minor">
+            <a:schemeClr val="lt1"/>
+          </a:fontRef>
+        </p:style>
+        <p:txBody>
+          <a:bodyPr rtlCol="0" anchor="ctr"/>
+          <a:lstStyle/>
+          <a:p>
+            <a:pPr algn="ctr"/>
+          </a:p>
+        </p:txBody>
+      </p:sp>
+      <p:sp>
+        <p:nvSpPr>
+          <p:cNvPr id="67" name="Rectangle 66"/>
+          <p:cNvSpPr/>
+          <p:nvPr/>
+        </p:nvSpPr>
+        <p:spPr>
+          <a:xfrm>
+            <a:off x="10088183" y="6309360"/>
+            <a:ext cx="743145" cy="43891"/>
+          </a:xfrm>
+          <a:prstGeom prst="rect">
+            <a:avLst/>
+          </a:prstGeom>
+          <a:solidFill>
+            <a:srgbClr val="223049"/>
+          </a:solidFill>
+          <a:ln>
+            <a:noFill/>
+          </a:ln>
+          <a:effectLst/>
+        </p:spPr>
+        <p:style>
+          <a:lnRef idx="1">
+            <a:schemeClr val="accent1"/>
+          </a:lnRef>
+          <a:fillRef idx="3">
+            <a:schemeClr val="accent1"/>
+          </a:fillRef>
+          <a:effectRef idx="2">
+            <a:schemeClr val="accent1"/>
+          </a:effectRef>
+          <a:fontRef idx="minor">
+            <a:schemeClr val="lt1"/>
+          </a:fontRef>
+        </p:style>
+        <p:txBody>
+          <a:bodyPr rtlCol="0" anchor="ctr"/>
+          <a:lstStyle/>
+          <a:p>
+            <a:pPr algn="ctr"/>
+          </a:p>
+        </p:txBody>
+      </p:sp>
+      <p:sp>
+        <p:nvSpPr>
+          <p:cNvPr id="68" name="Rectangle 67"/>
+          <p:cNvSpPr/>
+          <p:nvPr/>
+        </p:nvSpPr>
+        <p:spPr>
+          <a:xfrm>
+            <a:off x="10881621" y="6296558"/>
+            <a:ext cx="743145" cy="68580"/>
+          </a:xfrm>
+          <a:prstGeom prst="rect">
+            <a:avLst/>
+          </a:prstGeom>
+          <a:solidFill>
+            <a:srgbClr val="2FD8B4"/>
+          </a:solidFill>
+          <a:ln>
+            <a:noFill/>
+          </a:ln>
+          <a:effectLst/>
+        </p:spPr>
+        <p:style>
+          <a:lnRef idx="1">
+            <a:schemeClr val="accent1"/>
+          </a:lnRef>
+          <a:fillRef idx="3">
+            <a:schemeClr val="accent1"/>
+          </a:fillRef>
+          <a:effectRef idx="2">
+            <a:schemeClr val="accent1"/>
+          </a:effectRef>
+          <a:fontRef idx="minor">
+            <a:schemeClr val="lt1"/>
+          </a:fontRef>
+        </p:style>
+        <p:txBody>
+          <a:bodyPr rtlCol="0" anchor="ctr"/>
+          <a:lstStyle/>
+          <a:p>
+            <a:pPr algn="ctr"/>
+          </a:p>
+        </p:txBody>
+      </p:sp>
+      <p:sp>
+        <p:nvSpPr>
+          <p:cNvPr id="69" name="Rectangle 68"/>
+          <p:cNvSpPr/>
+          <p:nvPr/>
+        </p:nvSpPr>
+        <p:spPr>
+          <a:xfrm>
+            <a:off x="566928" y="6455664"/>
+            <a:ext cx="11057839" cy="9144"/>
+          </a:xfrm>
+          <a:prstGeom prst="rect">
+            <a:avLst/>
+          </a:prstGeom>
+          <a:solidFill>
+            <a:srgbClr val="223049"/>
+          </a:solidFill>
+          <a:ln>
+            <a:noFill/>
+          </a:ln>
+          <a:effectLst/>
+        </p:spPr>
+        <p:style>
+          <a:lnRef idx="1">
+            <a:schemeClr val="accent1"/>
+          </a:lnRef>
+          <a:fillRef idx="3">
+            <a:schemeClr val="accent1"/>
+          </a:fillRef>
+          <a:effectRef idx="2">
+            <a:schemeClr val="accent1"/>
+          </a:effectRef>
+          <a:fontRef idx="minor">
+            <a:schemeClr val="lt1"/>
+          </a:fontRef>
+        </p:style>
+        <p:txBody>
+          <a:bodyPr rtlCol="0" anchor="ctr"/>
+          <a:lstStyle/>
+          <a:p>
+            <a:pPr algn="ctr"/>
+          </a:p>
+        </p:txBody>
+      </p:sp>
+      <p:sp>
+        <p:nvSpPr>
+          <p:cNvPr id="70" name="TextBox 69"/>
+          <p:cNvSpPr txBox="1"/>
+          <p:nvPr/>
+        </p:nvSpPr>
+        <p:spPr>
+          <a:xfrm>
+            <a:off x="566928" y="6510528"/>
+            <a:ext cx="9509760" cy="219456"/>
+          </a:xfrm>
+          <a:prstGeom prst="rect">
+            <a:avLst/>
+          </a:prstGeom>
+          <a:noFill/>
+        </p:spPr>
+        <p:txBody>
+          <a:bodyPr wrap="square" lIns="0" rIns="0" tIns="0" bIns="0" anchor="t">
+            <a:spAutoFit/>
+          </a:bodyPr>
+          <a:lstStyle/>
+          <a:p>
+            <a:pPr algn="l">
+              <a:lnSpc>
+                <a:spcPct val="112000"/>
+              </a:lnSpc>
+              <a:spcAft>
+                <a:spcPts val="0"/>
+              </a:spcAft>
+            </a:pPr>
+            <a:r>
               <a:rPr sz="900" b="0">
                 <a:solidFill>
                   <a:srgbClr val="8CA0BE"/>
@@ -22228,7 +23548,7 @@
       </p:sp>
       <p:sp>
         <p:nvSpPr>
-          <p:cNvPr id="37" name="TextBox 36"/>
+          <p:cNvPr id="71" name="TextBox 70"/>
           <p:cNvSpPr txBox="1"/>
           <p:nvPr/>
         </p:nvSpPr>

</xml_diff>

<commit_message>
Remove final closing slide from review deck
Drop only the final See it running page and retain the previous 20 slides. Update the content checklist and rebuild previews for the shorter deck.

Co-authored-by: arena-agent <297053741+arena-agent@users.noreply.github.com>
</commit_message>
<xml_diff>
--- a/presentation/RetainIQ_Project_Review.pptx
+++ b/presentation/RetainIQ_Project_Review.pptx
@@ -25,7 +25,6 @@
     <p:sldId id="273" r:id="rId25"/>
     <p:sldId id="274" r:id="rId26"/>
     <p:sldId id="275" r:id="rId27"/>
-    <p:sldId id="276" r:id="rId28"/>
   </p:sldIdLst>
   <p:sldSz cx="12191695" cy="6858000" type="screen4x3"/>
   <p:notesSz cx="6858000" cy="9144000"/>
@@ -1799,152 +1798,6 @@
 </p:notes>
 </file>
 
-<file path=ppt/notesSlides/notesSlide21.xml><?xml version="1.0" encoding="utf-8"?>
-<p:notes xmlns:a="http://schemas.openxmlformats.org/drawingml/2006/main" xmlns:p="http://schemas.openxmlformats.org/presentationml/2006/main" xmlns:r="http://schemas.openxmlformats.org/officeDocument/2006/relationships">
-  <p:cSld>
-    <p:spTree>
-      <p:nvGrpSpPr>
-        <p:cNvPr id="1" name=""/>
-        <p:cNvGrpSpPr/>
-        <p:nvPr/>
-      </p:nvGrpSpPr>
-      <p:grpSpPr>
-        <a:xfrm>
-          <a:off x="0" y="0"/>
-          <a:ext cx="0" cy="0"/>
-          <a:chOff x="0" y="0"/>
-          <a:chExt cx="0" cy="0"/>
-        </a:xfrm>
-      </p:grpSpPr>
-      <p:sp>
-        <p:nvSpPr>
-          <p:cNvPr id="2" name="Slide Image Placeholder 1"/>
-          <p:cNvSpPr>
-            <a:spLocks noGrp="1"/>
-          </p:cNvSpPr>
-          <p:nvPr>
-            <p:ph type="sldImg" idx="2"/>
-          </p:nvPr>
-        </p:nvSpPr>
-        <p:spPr/>
-      </p:sp>
-      <p:sp>
-        <p:nvSpPr>
-          <p:cNvPr id="3" name="Notes Placeholder 2"/>
-          <p:cNvSpPr>
-            <a:spLocks noGrp="1"/>
-          </p:cNvSpPr>
-          <p:nvPr>
-            <p:ph type="body" idx="3" sz="quarter"/>
-          </p:nvPr>
-        </p:nvSpPr>
-        <p:spPr/>
-        <p:txBody>
-          <a:bodyPr/>
-          <a:lstStyle/>
-          <a:p>
-            <a:r>
-              <a:t>CLOSING (11:40–12:05) Leave this slide up for questions. It puts the live URL and</a:t>
-            </a:r>
-          </a:p>
-          <a:p>
-            <a:r>
-              <a:t>a scannable QR in front of the examiner and ends on the thesis, not a tool list.</a:t>
-            </a:r>
-          </a:p>
-          <a:p>
-            <a:r>
-              <a:t>"The contribution isn't the 80% — it's that a probability becomes a prioritised,</a:t>
-            </a:r>
-          </a:p>
-          <a:p>
-            <a:r>
-              <a:t>explained, costed action, in a product a retention team can actually open. Thank</a:t>
-            </a:r>
-          </a:p>
-          <a:p>
-            <a:r>
-              <a:t>you — happy to take questions."</a:t>
-            </a:r>
-          </a:p>
-          <a:p>
-            <a:r>
-              <a:t>Offer the demo: "if you'd like, I can upload a customer file and score it live."</a:t>
-            </a:r>
-          </a:p>
-          <a:p>
-            <a:r>
-              <a:t>Remember the free tier sleeps — warm the app before you present.</a:t>
-            </a:r>
-          </a:p>
-          <a:p/>
-          <a:p>
-            <a:r>
-              <a:t>LIKELY QUESTIONS</a:t>
-            </a:r>
-          </a:p>
-          <a:p>
-            <a:r>
-              <a:t>· Why not deep learning? 1,409 test rows and a largely linear signal; the four-way</a:t>
-            </a:r>
-          </a:p>
-          <a:p>
-            <a:r>
-              <a:t>  benchmark supports the simpler model, and it stays explainable.</a:t>
-            </a:r>
-          </a:p>
-          <a:p>
-            <a:r>
-              <a:t>· Why is recall low? The 0.5 threshold is a default. Phase 08 shows 0.35 catches</a:t>
-            </a:r>
-          </a:p>
-          <a:p>
-            <a:r>
-              <a:t>  71.7%, and balanced class weights reach 77.81% recall at identical ROC-AUC.</a:t>
-            </a:r>
-          </a:p>
-          <a:p>
-            <a:r>
-              <a:t>· Isn't revenue-at-risk optimistic? It's exposure, not savings — the deck and the</a:t>
-            </a:r>
-          </a:p>
-          <a:p>
-            <a:r>
-              <a:t>  app both say so; validating it needs a live campaign.</a:t>
-            </a:r>
-          </a:p>
-          <a:p>
-            <a:r>
-              <a:t>· How do you know it isn't leakage? Churn Score, Reason, Category and Status are</a:t>
-            </a:r>
-          </a:p>
-          <a:p>
-            <a:r>
-              <a:t>  post-outcome fields and were dropped before training.</a:t>
-            </a:r>
-          </a:p>
-        </p:txBody>
-      </p:sp>
-      <p:sp>
-        <p:nvSpPr>
-          <p:cNvPr id="4" name="Slide Number Placeholder 3"/>
-          <p:cNvSpPr>
-            <a:spLocks noGrp="1"/>
-          </p:cNvSpPr>
-          <p:nvPr>
-            <p:ph type="sldNum" idx="5" sz="quarter"/>
-          </p:nvPr>
-        </p:nvSpPr>
-        <p:spPr/>
-      </p:sp>
-    </p:spTree>
-  </p:cSld>
-  <p:clrMapOvr>
-    <a:masterClrMapping/>
-  </p:clrMapOvr>
-</p:notes>
-</file>
-
 <file path=ppt/notesSlides/notesSlide3.xml><?xml version="1.0" encoding="utf-8"?>
 <p:notes xmlns:a="http://schemas.openxmlformats.org/drawingml/2006/main" xmlns:p="http://schemas.openxmlformats.org/presentationml/2006/main" xmlns:r="http://schemas.openxmlformats.org/officeDocument/2006/relationships">
   <p:cSld>
@@ -28795,1098 +28648,6 @@
                 <a:latin typeface="Consolas"/>
               </a:rPr>
               <a:t>20</a:t>
-            </a:r>
-          </a:p>
-        </p:txBody>
-      </p:sp>
-    </p:spTree>
-  </p:cSld>
-  <p:clrMapOvr>
-    <a:masterClrMapping/>
-  </p:clrMapOvr>
-</p:sld>
-</file>
-
-<file path=ppt/slides/slide21.xml><?xml version="1.0" encoding="utf-8"?>
-<p:sld xmlns:a="http://schemas.openxmlformats.org/drawingml/2006/main" xmlns:p="http://schemas.openxmlformats.org/presentationml/2006/main" xmlns:r="http://schemas.openxmlformats.org/officeDocument/2006/relationships">
-  <p:cSld>
-    <p:spTree>
-      <p:nvGrpSpPr>
-        <p:cNvPr id="1" name=""/>
-        <p:cNvGrpSpPr/>
-        <p:nvPr/>
-      </p:nvGrpSpPr>
-      <p:grpSpPr/>
-      <p:sp>
-        <p:nvSpPr>
-          <p:cNvPr id="2" name="Rectangle 1"/>
-          <p:cNvSpPr/>
-          <p:nvPr/>
-        </p:nvSpPr>
-        <p:spPr>
-          <a:xfrm>
-            <a:off x="0" y="0"/>
-            <a:ext cx="12191695" cy="6858000"/>
-          </a:xfrm>
-          <a:prstGeom prst="rect">
-            <a:avLst/>
-          </a:prstGeom>
-          <a:solidFill>
-            <a:srgbClr val="0A0F1C"/>
-          </a:solidFill>
-          <a:ln>
-            <a:noFill/>
-          </a:ln>
-          <a:effectLst/>
-        </p:spPr>
-        <p:style>
-          <a:lnRef idx="1">
-            <a:schemeClr val="accent1"/>
-          </a:lnRef>
-          <a:fillRef idx="3">
-            <a:schemeClr val="accent1"/>
-          </a:fillRef>
-          <a:effectRef idx="2">
-            <a:schemeClr val="accent1"/>
-          </a:effectRef>
-          <a:fontRef idx="minor">
-            <a:schemeClr val="lt1"/>
-          </a:fontRef>
-        </p:style>
-        <p:txBody>
-          <a:bodyPr rtlCol="0" anchor="ctr"/>
-          <a:lstStyle/>
-          <a:p>
-            <a:pPr algn="ctr"/>
-          </a:p>
-        </p:txBody>
-      </p:sp>
-      <p:sp>
-        <p:nvSpPr>
-          <p:cNvPr id="3" name="Rectangle 2"/>
-          <p:cNvSpPr/>
-          <p:nvPr/>
-        </p:nvSpPr>
-        <p:spPr>
-          <a:xfrm>
-            <a:off x="0" y="0"/>
-            <a:ext cx="12191695" cy="77724"/>
-          </a:xfrm>
-          <a:prstGeom prst="rect">
-            <a:avLst/>
-          </a:prstGeom>
-          <a:solidFill>
-            <a:srgbClr val="2FD8B4"/>
-          </a:solidFill>
-          <a:ln>
-            <a:noFill/>
-          </a:ln>
-          <a:effectLst/>
-        </p:spPr>
-        <p:style>
-          <a:lnRef idx="1">
-            <a:schemeClr val="accent1"/>
-          </a:lnRef>
-          <a:fillRef idx="3">
-            <a:schemeClr val="accent1"/>
-          </a:fillRef>
-          <a:effectRef idx="2">
-            <a:schemeClr val="accent1"/>
-          </a:effectRef>
-          <a:fontRef idx="minor">
-            <a:schemeClr val="lt1"/>
-          </a:fontRef>
-        </p:style>
-        <p:txBody>
-          <a:bodyPr rtlCol="0" anchor="ctr"/>
-          <a:lstStyle/>
-          <a:p>
-            <a:pPr algn="ctr"/>
-          </a:p>
-        </p:txBody>
-      </p:sp>
-      <p:sp>
-        <p:nvSpPr>
-          <p:cNvPr id="4" name="TextBox 3"/>
-          <p:cNvSpPr txBox="1"/>
-          <p:nvPr/>
-        </p:nvSpPr>
-        <p:spPr>
-          <a:xfrm>
-            <a:off x="566928" y="365760"/>
-            <a:ext cx="8229600" cy="237744"/>
-          </a:xfrm>
-          <a:prstGeom prst="rect">
-            <a:avLst/>
-          </a:prstGeom>
-          <a:noFill/>
-        </p:spPr>
-        <p:txBody>
-          <a:bodyPr wrap="square" lIns="0" rIns="0" tIns="0" bIns="0" anchor="t">
-            <a:spAutoFit/>
-          </a:bodyPr>
-          <a:lstStyle/>
-          <a:p>
-            <a:pPr algn="l">
-              <a:lnSpc>
-                <a:spcPct val="112000"/>
-              </a:lnSpc>
-              <a:spcAft>
-                <a:spcPts val="0"/>
-              </a:spcAft>
-            </a:pPr>
-            <a:r>
-              <a:rPr sz="1000" b="1">
-                <a:solidFill>
-                  <a:srgbClr val="2FD8B4"/>
-                </a:solidFill>
-                <a:latin typeface="Consolas"/>
-              </a:rPr>
-              <a:t>THANK YOU</a:t>
-            </a:r>
-          </a:p>
-        </p:txBody>
-      </p:sp>
-      <p:sp>
-        <p:nvSpPr>
-          <p:cNvPr id="5" name="TextBox 4"/>
-          <p:cNvSpPr txBox="1"/>
-          <p:nvPr/>
-        </p:nvSpPr>
-        <p:spPr>
-          <a:xfrm>
-            <a:off x="566928" y="576072"/>
-            <a:ext cx="11057839" cy="475488"/>
-          </a:xfrm>
-          <a:prstGeom prst="rect">
-            <a:avLst/>
-          </a:prstGeom>
-          <a:noFill/>
-        </p:spPr>
-        <p:txBody>
-          <a:bodyPr wrap="square" lIns="0" rIns="0" tIns="0" bIns="0" anchor="t">
-            <a:spAutoFit/>
-          </a:bodyPr>
-          <a:lstStyle/>
-          <a:p>
-            <a:pPr algn="l">
-              <a:lnSpc>
-                <a:spcPct val="112000"/>
-              </a:lnSpc>
-              <a:spcAft>
-                <a:spcPts val="0"/>
-              </a:spcAft>
-            </a:pPr>
-            <a:r>
-              <a:rPr sz="2600" b="1">
-                <a:solidFill>
-                  <a:srgbClr val="EAF0F7"/>
-                </a:solidFill>
-                <a:latin typeface="Segoe UI"/>
-              </a:rPr>
-              <a:t>See it running</a:t>
-            </a:r>
-          </a:p>
-        </p:txBody>
-      </p:sp>
-      <p:sp>
-        <p:nvSpPr>
-          <p:cNvPr id="6" name="TextBox 5"/>
-          <p:cNvSpPr txBox="1"/>
-          <p:nvPr/>
-        </p:nvSpPr>
-        <p:spPr>
-          <a:xfrm>
-            <a:off x="566928" y="1060704"/>
-            <a:ext cx="11057839" cy="274320"/>
-          </a:xfrm>
-          <a:prstGeom prst="rect">
-            <a:avLst/>
-          </a:prstGeom>
-          <a:noFill/>
-        </p:spPr>
-        <p:txBody>
-          <a:bodyPr wrap="square" lIns="0" rIns="0" tIns="0" bIns="0" anchor="t">
-            <a:spAutoFit/>
-          </a:bodyPr>
-          <a:lstStyle/>
-          <a:p>
-            <a:pPr algn="l">
-              <a:lnSpc>
-                <a:spcPct val="112000"/>
-              </a:lnSpc>
-              <a:spcAft>
-                <a:spcPts val="0"/>
-              </a:spcAft>
-            </a:pPr>
-            <a:r>
-              <a:rPr sz="1250" b="0">
-                <a:solidFill>
-                  <a:srgbClr val="8CA0BE"/>
-                </a:solidFill>
-                <a:latin typeface="Segoe UI"/>
-              </a:rPr>
-              <a:t>Scan to open the live application and score a customer portfolio</a:t>
-            </a:r>
-          </a:p>
-        </p:txBody>
-      </p:sp>
-      <p:sp>
-        <p:nvSpPr>
-          <p:cNvPr id="7" name="Rectangle 6"/>
-          <p:cNvSpPr/>
-          <p:nvPr/>
-        </p:nvSpPr>
-        <p:spPr>
-          <a:xfrm>
-            <a:off x="566928" y="1371600"/>
-            <a:ext cx="11057839" cy="12801"/>
-          </a:xfrm>
-          <a:prstGeom prst="rect">
-            <a:avLst/>
-          </a:prstGeom>
-          <a:solidFill>
-            <a:srgbClr val="223049"/>
-          </a:solidFill>
-          <a:ln>
-            <a:noFill/>
-          </a:ln>
-          <a:effectLst/>
-        </p:spPr>
-        <p:style>
-          <a:lnRef idx="1">
-            <a:schemeClr val="accent1"/>
-          </a:lnRef>
-          <a:fillRef idx="3">
-            <a:schemeClr val="accent1"/>
-          </a:fillRef>
-          <a:effectRef idx="2">
-            <a:schemeClr val="accent1"/>
-          </a:effectRef>
-          <a:fontRef idx="minor">
-            <a:schemeClr val="lt1"/>
-          </a:fontRef>
-        </p:style>
-        <p:txBody>
-          <a:bodyPr rtlCol="0" anchor="ctr"/>
-          <a:lstStyle/>
-          <a:p>
-            <a:pPr algn="ctr"/>
-          </a:p>
-        </p:txBody>
-      </p:sp>
-      <p:sp>
-        <p:nvSpPr>
-          <p:cNvPr id="8" name="Rounded Rectangle 7"/>
-          <p:cNvSpPr/>
-          <p:nvPr/>
-        </p:nvSpPr>
-        <p:spPr>
-          <a:xfrm>
-            <a:off x="566928" y="1517904"/>
-            <a:ext cx="5321808" cy="3968496"/>
-          </a:xfrm>
-          <a:prstGeom prst="roundRect">
-            <a:avLst>
-              <a:gd name="adj" fmla="val 8000"/>
-            </a:avLst>
-          </a:prstGeom>
-          <a:solidFill>
-            <a:srgbClr val="111A2C"/>
-          </a:solidFill>
-          <a:ln w="17780">
-            <a:solidFill>
-              <a:srgbClr val="2FD8B4"/>
-            </a:solidFill>
-          </a:ln>
-          <a:effectLst/>
-        </p:spPr>
-        <p:style>
-          <a:lnRef idx="1">
-            <a:schemeClr val="accent1"/>
-          </a:lnRef>
-          <a:fillRef idx="3">
-            <a:schemeClr val="accent1"/>
-          </a:fillRef>
-          <a:effectRef idx="2">
-            <a:schemeClr val="accent1"/>
-          </a:effectRef>
-          <a:fontRef idx="minor">
-            <a:schemeClr val="lt1"/>
-          </a:fontRef>
-        </p:style>
-        <p:txBody>
-          <a:bodyPr rtlCol="0" anchor="ctr"/>
-          <a:lstStyle/>
-          <a:p>
-            <a:pPr algn="ctr"/>
-          </a:p>
-        </p:txBody>
-      </p:sp>
-      <p:sp>
-        <p:nvSpPr>
-          <p:cNvPr id="9" name="TextBox 8"/>
-          <p:cNvSpPr txBox="1"/>
-          <p:nvPr/>
-        </p:nvSpPr>
-        <p:spPr>
-          <a:xfrm>
-            <a:off x="822960" y="1737360"/>
-            <a:ext cx="4809744" cy="3529584"/>
-          </a:xfrm>
-          <a:prstGeom prst="rect">
-            <a:avLst/>
-          </a:prstGeom>
-          <a:noFill/>
-        </p:spPr>
-        <p:txBody>
-          <a:bodyPr wrap="square" lIns="0" rIns="0" tIns="0" bIns="0" anchor="t">
-            <a:spAutoFit/>
-          </a:bodyPr>
-          <a:lstStyle/>
-          <a:p>
-            <a:pPr algn="l">
-              <a:lnSpc>
-                <a:spcPct val="112000"/>
-              </a:lnSpc>
-              <a:spcAft>
-                <a:spcPts val="800"/>
-              </a:spcAft>
-            </a:pPr>
-            <a:r>
-              <a:rPr sz="1050" b="1" u="sng">
-                <a:solidFill>
-                  <a:srgbClr val="2FD8B4"/>
-                </a:solidFill>
-                <a:latin typeface="Consolas"/>
-                <a:hlinkClick r:id="rId2"/>
-              </a:rPr>
-              <a:t>LIVE APPLICATION</a:t>
-            </a:r>
-          </a:p>
-          <a:p>
-            <a:pPr algn="l">
-              <a:lnSpc>
-                <a:spcPct val="116000"/>
-              </a:lnSpc>
-              <a:spcAft>
-                <a:spcPts val="1000"/>
-              </a:spcAft>
-            </a:pPr>
-            <a:r>
-              <a:rPr sz="1100" b="1" u="sng">
-                <a:solidFill>
-                  <a:srgbClr val="4C8DFF"/>
-                </a:solidFill>
-                <a:latin typeface="Segoe UI"/>
-                <a:hlinkClick r:id="rId2"/>
-              </a:rPr>
-              <a:t>retainiq-predictive-customer-retention-zq6x.onrender.com</a:t>
-            </a:r>
-          </a:p>
-          <a:p>
-            <a:pPr algn="l">
-              <a:lnSpc>
-                <a:spcPct val="120000"/>
-              </a:lnSpc>
-              <a:spcAft>
-                <a:spcPts val="1200"/>
-              </a:spcAft>
-            </a:pPr>
-            <a:r>
-              <a:rPr sz="1080" b="0">
-                <a:solidFill>
-                  <a:srgbClr val="8CA0BE"/>
-                </a:solidFill>
-                <a:latin typeface="Segoe UI"/>
-              </a:rPr>
-              <a:t>Bulk score a customer CSV, read the dashboard, and download a private report. The model, risk bands, explanations and recommendations run live — the same code paths that produced every figure in this deck.</a:t>
-            </a:r>
-          </a:p>
-          <a:p>
-            <a:pPr algn="l">
-              <a:lnSpc>
-                <a:spcPct val="112000"/>
-              </a:lnSpc>
-              <a:spcAft>
-                <a:spcPts val="500"/>
-              </a:spcAft>
-            </a:pPr>
-            <a:r>
-              <a:rPr sz="1050" b="1" u="sng">
-                <a:solidFill>
-                  <a:srgbClr val="4C8DFF"/>
-                </a:solidFill>
-                <a:latin typeface="Consolas"/>
-                <a:hlinkClick r:id="rId3"/>
-              </a:rPr>
-              <a:t>SOURCE CODE</a:t>
-            </a:r>
-          </a:p>
-          <a:p>
-            <a:pPr algn="l">
-              <a:lnSpc>
-                <a:spcPct val="116000"/>
-              </a:lnSpc>
-              <a:spcAft>
-                <a:spcPts val="1200"/>
-              </a:spcAft>
-            </a:pPr>
-            <a:r>
-              <a:rPr sz="1060" b="0" u="sng">
-                <a:solidFill>
-                  <a:srgbClr val="4C8DFF"/>
-                </a:solidFill>
-                <a:latin typeface="Consolas"/>
-                <a:hlinkClick r:id="rId3"/>
-              </a:rPr>
-              <a:t>github.com/Logesh0247/RetainIQ_Signal_Ops_Console</a:t>
-            </a:r>
-          </a:p>
-          <a:p>
-            <a:pPr algn="l">
-              <a:lnSpc>
-                <a:spcPct val="118000"/>
-              </a:lnSpc>
-              <a:spcAft>
-                <a:spcPts val="1000"/>
-              </a:spcAft>
-            </a:pPr>
-            <a:r>
-              <a:rPr sz="1040" b="0">
-                <a:solidFill>
-                  <a:srgbClr val="8CA0BE"/>
-                </a:solidFill>
-                <a:latin typeface="Segoe UI"/>
-              </a:rPr>
-              <a:t>Notebooks 01–09, the Flask console, the FastAPI wrapper and the nine-test suite are all in the repository.</a:t>
-            </a:r>
-          </a:p>
-          <a:p>
-            <a:pPr algn="l">
-              <a:lnSpc>
-                <a:spcPct val="118000"/>
-              </a:lnSpc>
-              <a:spcAft>
-                <a:spcPts val="0"/>
-              </a:spcAft>
-            </a:pPr>
-            <a:r>
-              <a:rPr sz="1040" b="0">
-                <a:solidFill>
-                  <a:srgbClr val="F5A623"/>
-                </a:solidFill>
-                <a:latin typeface="Segoe UI"/>
-              </a:rPr>
-              <a:t>The host is a free tier — open it once a minute before the review so the first scan is instant.</a:t>
-            </a:r>
-          </a:p>
-        </p:txBody>
-      </p:sp>
-      <p:sp>
-        <p:nvSpPr>
-          <p:cNvPr id="10" name="Rounded Rectangle 9"/>
-          <p:cNvSpPr/>
-          <p:nvPr/>
-        </p:nvSpPr>
-        <p:spPr>
-          <a:xfrm>
-            <a:off x="5980176" y="1517904"/>
-            <a:ext cx="2724912" cy="3968496"/>
-          </a:xfrm>
-          <a:prstGeom prst="roundRect">
-            <a:avLst>
-              <a:gd name="adj" fmla="val 8000"/>
-            </a:avLst>
-          </a:prstGeom>
-          <a:solidFill>
-            <a:srgbClr val="FFFFFF"/>
-          </a:solidFill>
-          <a:ln w="12700">
-            <a:solidFill>
-              <a:srgbClr val="223049"/>
-            </a:solidFill>
-          </a:ln>
-          <a:effectLst/>
-        </p:spPr>
-        <p:style>
-          <a:lnRef idx="1">
-            <a:schemeClr val="accent1"/>
-          </a:lnRef>
-          <a:fillRef idx="3">
-            <a:schemeClr val="accent1"/>
-          </a:fillRef>
-          <a:effectRef idx="2">
-            <a:schemeClr val="accent1"/>
-          </a:effectRef>
-          <a:fontRef idx="minor">
-            <a:schemeClr val="lt1"/>
-          </a:fontRef>
-        </p:style>
-        <p:txBody>
-          <a:bodyPr rtlCol="0" anchor="ctr"/>
-          <a:lstStyle/>
-          <a:p>
-            <a:pPr algn="ctr"/>
-          </a:p>
-        </p:txBody>
-      </p:sp>
-      <p:pic>
-        <p:nvPicPr>
-          <p:cNvPr id="11" name="Picture 10" descr="qr_live_app.png"/>
-          <p:cNvPicPr>
-            <a:picLocks noChangeAspect="1"/>
-          </p:cNvPicPr>
-          <p:nvPr/>
-        </p:nvPicPr>
-        <p:blipFill>
-          <a:blip r:embed="rId4"/>
-          <a:stretch>
-            <a:fillRect/>
-          </a:stretch>
-        </p:blipFill>
-        <p:spPr>
-          <a:xfrm>
-            <a:off x="6035040" y="1719072"/>
-            <a:ext cx="2615184" cy="2615184"/>
-          </a:xfrm>
-          <a:prstGeom prst="rect">
-            <a:avLst/>
-          </a:prstGeom>
-        </p:spPr>
-      </p:pic>
-      <p:sp>
-        <p:nvSpPr>
-          <p:cNvPr id="12" name="TextBox 11"/>
-          <p:cNvSpPr txBox="1"/>
-          <p:nvPr/>
-        </p:nvSpPr>
-        <p:spPr>
-          <a:xfrm>
-            <a:off x="6126480" y="4864608"/>
-            <a:ext cx="2432304" cy="475488"/>
-          </a:xfrm>
-          <a:prstGeom prst="rect">
-            <a:avLst/>
-          </a:prstGeom>
-          <a:noFill/>
-        </p:spPr>
-        <p:txBody>
-          <a:bodyPr wrap="square" lIns="0" rIns="0" tIns="0" bIns="0" anchor="t">
-            <a:spAutoFit/>
-          </a:bodyPr>
-          <a:lstStyle/>
-          <a:p>
-            <a:pPr algn="ctr">
-              <a:lnSpc>
-                <a:spcPct val="112000"/>
-              </a:lnSpc>
-              <a:spcAft>
-                <a:spcPts val="200"/>
-              </a:spcAft>
-            </a:pPr>
-            <a:r>
-              <a:rPr sz="950" b="1">
-                <a:solidFill>
-                  <a:srgbClr val="0A0F1C"/>
-                </a:solidFill>
-                <a:latin typeface="Consolas"/>
-              </a:rPr>
-              <a:t>SCAN FOR THE</a:t>
-            </a:r>
-          </a:p>
-          <a:p>
-            <a:pPr algn="ctr">
-              <a:lnSpc>
-                <a:spcPct val="112000"/>
-              </a:lnSpc>
-              <a:spcAft>
-                <a:spcPts val="0"/>
-              </a:spcAft>
-            </a:pPr>
-            <a:r>
-              <a:rPr sz="950" b="1">
-                <a:solidFill>
-                  <a:srgbClr val="0A0F1C"/>
-                </a:solidFill>
-                <a:latin typeface="Consolas"/>
-              </a:rPr>
-              <a:t>LIVE APPLICATION</a:t>
-            </a:r>
-          </a:p>
-        </p:txBody>
-      </p:sp>
-      <p:sp>
-        <p:nvSpPr>
-          <p:cNvPr id="13" name="Rounded Rectangle 12"/>
-          <p:cNvSpPr/>
-          <p:nvPr/>
-        </p:nvSpPr>
-        <p:spPr>
-          <a:xfrm>
-            <a:off x="8796528" y="1517904"/>
-            <a:ext cx="2825496" cy="3968496"/>
-          </a:xfrm>
-          <a:prstGeom prst="roundRect">
-            <a:avLst>
-              <a:gd name="adj" fmla="val 8000"/>
-            </a:avLst>
-          </a:prstGeom>
-          <a:solidFill>
-            <a:srgbClr val="111A2C"/>
-          </a:solidFill>
-          <a:ln w="12700">
-            <a:solidFill>
-              <a:srgbClr val="223049"/>
-            </a:solidFill>
-          </a:ln>
-          <a:effectLst/>
-        </p:spPr>
-        <p:style>
-          <a:lnRef idx="1">
-            <a:schemeClr val="accent1"/>
-          </a:lnRef>
-          <a:fillRef idx="3">
-            <a:schemeClr val="accent1"/>
-          </a:fillRef>
-          <a:effectRef idx="2">
-            <a:schemeClr val="accent1"/>
-          </a:effectRef>
-          <a:fontRef idx="minor">
-            <a:schemeClr val="lt1"/>
-          </a:fontRef>
-        </p:style>
-        <p:txBody>
-          <a:bodyPr rtlCol="0" anchor="ctr"/>
-          <a:lstStyle/>
-          <a:p>
-            <a:pPr algn="ctr"/>
-          </a:p>
-        </p:txBody>
-      </p:sp>
-      <p:pic>
-        <p:nvPicPr>
-          <p:cNvPr id="14" name="Picture 13" descr="qr_repository.png"/>
-          <p:cNvPicPr>
-            <a:picLocks noChangeAspect="1"/>
-          </p:cNvPicPr>
-          <p:nvPr/>
-        </p:nvPicPr>
-        <p:blipFill>
-          <a:blip r:embed="rId5"/>
-          <a:stretch>
-            <a:fillRect/>
-          </a:stretch>
-        </p:blipFill>
-        <p:spPr>
-          <a:xfrm>
-            <a:off x="9637776" y="1737360"/>
-            <a:ext cx="1143000" cy="1143000"/>
-          </a:xfrm>
-          <a:prstGeom prst="rect">
-            <a:avLst/>
-          </a:prstGeom>
-        </p:spPr>
-      </p:pic>
-      <p:sp>
-        <p:nvSpPr>
-          <p:cNvPr id="15" name="TextBox 14"/>
-          <p:cNvSpPr txBox="1"/>
-          <p:nvPr/>
-        </p:nvSpPr>
-        <p:spPr>
-          <a:xfrm>
-            <a:off x="8979408" y="1773936"/>
-            <a:ext cx="603504" cy="914400"/>
-          </a:xfrm>
-          <a:prstGeom prst="rect">
-            <a:avLst/>
-          </a:prstGeom>
-          <a:noFill/>
-        </p:spPr>
-        <p:txBody>
-          <a:bodyPr wrap="square" lIns="0" rIns="0" tIns="0" bIns="0" anchor="t">
-            <a:spAutoFit/>
-          </a:bodyPr>
-          <a:lstStyle/>
-          <a:p>
-            <a:pPr algn="l">
-              <a:lnSpc>
-                <a:spcPct val="112000"/>
-              </a:lnSpc>
-              <a:spcAft>
-                <a:spcPts val="300"/>
-              </a:spcAft>
-            </a:pPr>
-            <a:r>
-              <a:rPr sz="850" b="1">
-                <a:solidFill>
-                  <a:srgbClr val="8CA0BE"/>
-                </a:solidFill>
-                <a:latin typeface="Consolas"/>
-              </a:rPr>
-              <a:t>SOURCE</a:t>
-            </a:r>
-          </a:p>
-          <a:p>
-            <a:pPr algn="l">
-              <a:lnSpc>
-                <a:spcPct val="112000"/>
-              </a:lnSpc>
-              <a:spcAft>
-                <a:spcPts val="0"/>
-              </a:spcAft>
-            </a:pPr>
-            <a:r>
-              <a:rPr sz="850" b="1">
-                <a:solidFill>
-                  <a:srgbClr val="8CA0BE"/>
-                </a:solidFill>
-                <a:latin typeface="Consolas"/>
-              </a:rPr>
-              <a:t>REPO</a:t>
-            </a:r>
-          </a:p>
-        </p:txBody>
-      </p:sp>
-      <p:sp>
-        <p:nvSpPr>
-          <p:cNvPr id="16" name="TextBox 15"/>
-          <p:cNvSpPr txBox="1"/>
-          <p:nvPr/>
-        </p:nvSpPr>
-        <p:spPr>
-          <a:xfrm>
-            <a:off x="8979408" y="2999232"/>
-            <a:ext cx="2459736" cy="2194560"/>
-          </a:xfrm>
-          <a:prstGeom prst="rect">
-            <a:avLst/>
-          </a:prstGeom>
-          <a:noFill/>
-        </p:spPr>
-        <p:txBody>
-          <a:bodyPr wrap="square" lIns="0" rIns="0" tIns="0" bIns="0" anchor="t">
-            <a:spAutoFit/>
-          </a:bodyPr>
-          <a:lstStyle/>
-          <a:p>
-            <a:pPr algn="l">
-              <a:lnSpc>
-                <a:spcPct val="112000"/>
-              </a:lnSpc>
-              <a:spcAft>
-                <a:spcPts val="500"/>
-              </a:spcAft>
-            </a:pPr>
-            <a:r>
-              <a:rPr sz="1900" b="1">
-                <a:solidFill>
-                  <a:srgbClr val="EAF0F7"/>
-                </a:solidFill>
-                <a:latin typeface="Segoe UI"/>
-              </a:rPr>
-              <a:t>Thank you</a:t>
-            </a:r>
-          </a:p>
-          <a:p>
-            <a:pPr algn="l">
-              <a:lnSpc>
-                <a:spcPct val="112000"/>
-              </a:lnSpc>
-              <a:spcAft>
-                <a:spcPts val="1000"/>
-              </a:spcAft>
-            </a:pPr>
-            <a:r>
-              <a:rPr sz="1100" b="0">
-                <a:solidFill>
-                  <a:srgbClr val="2FD8B4"/>
-                </a:solidFill>
-                <a:latin typeface="Segoe UI"/>
-              </a:rPr>
-              <a:t>Questions welcome.</a:t>
-            </a:r>
-          </a:p>
-          <a:p>
-            <a:pPr algn="l">
-              <a:lnSpc>
-                <a:spcPct val="118000"/>
-              </a:lnSpc>
-              <a:spcAft>
-                <a:spcPts val="0"/>
-              </a:spcAft>
-            </a:pPr>
-            <a:r>
-              <a:rPr sz="1040" b="0">
-                <a:solidFill>
-                  <a:srgbClr val="8CA0BE"/>
-                </a:solidFill>
-                <a:latin typeface="Segoe UI"/>
-              </a:rPr>
-              <a:t>RetainIQ — from a churn probability to a prioritised, explained, costed retention action.</a:t>
-            </a:r>
-          </a:p>
-        </p:txBody>
-      </p:sp>
-      <p:sp>
-        <p:nvSpPr>
-          <p:cNvPr id="17" name="Rectangle 16"/>
-          <p:cNvSpPr/>
-          <p:nvPr/>
-        </p:nvSpPr>
-        <p:spPr>
-          <a:xfrm>
-            <a:off x="10104120" y="4795113"/>
-            <a:ext cx="89382" cy="170992"/>
-          </a:xfrm>
-          <a:prstGeom prst="rect">
-            <a:avLst/>
-          </a:prstGeom>
-          <a:solidFill>
-            <a:srgbClr val="2FD8B4"/>
-          </a:solidFill>
-          <a:ln>
-            <a:noFill/>
-          </a:ln>
-          <a:effectLst/>
-        </p:spPr>
-        <p:style>
-          <a:lnRef idx="1">
-            <a:schemeClr val="accent1"/>
-          </a:lnRef>
-          <a:fillRef idx="3">
-            <a:schemeClr val="accent1"/>
-          </a:fillRef>
-          <a:effectRef idx="2">
-            <a:schemeClr val="accent1"/>
-          </a:effectRef>
-          <a:fontRef idx="minor">
-            <a:schemeClr val="lt1"/>
-          </a:fontRef>
-        </p:style>
-        <p:txBody>
-          <a:bodyPr rtlCol="0" anchor="ctr"/>
-          <a:lstStyle/>
-          <a:p>
-            <a:pPr algn="ctr"/>
-          </a:p>
-        </p:txBody>
-      </p:sp>
-      <p:sp>
-        <p:nvSpPr>
-          <p:cNvPr id="18" name="Rectangle 17"/>
-          <p:cNvSpPr/>
-          <p:nvPr/>
-        </p:nvSpPr>
-        <p:spPr>
-          <a:xfrm>
-            <a:off x="10259568" y="4670755"/>
-            <a:ext cx="89382" cy="295351"/>
-          </a:xfrm>
-          <a:prstGeom prst="rect">
-            <a:avLst/>
-          </a:prstGeom>
-          <a:solidFill>
-            <a:srgbClr val="2FD8B4"/>
-          </a:solidFill>
-          <a:ln>
-            <a:noFill/>
-          </a:ln>
-          <a:effectLst/>
-        </p:spPr>
-        <p:style>
-          <a:lnRef idx="1">
-            <a:schemeClr val="accent1"/>
-          </a:lnRef>
-          <a:fillRef idx="3">
-            <a:schemeClr val="accent1"/>
-          </a:fillRef>
-          <a:effectRef idx="2">
-            <a:schemeClr val="accent1"/>
-          </a:effectRef>
-          <a:fontRef idx="minor">
-            <a:schemeClr val="lt1"/>
-          </a:fontRef>
-        </p:style>
-        <p:txBody>
-          <a:bodyPr rtlCol="0" anchor="ctr"/>
-          <a:lstStyle/>
-          <a:p>
-            <a:pPr algn="ctr"/>
-          </a:p>
-        </p:txBody>
-      </p:sp>
-      <p:sp>
-        <p:nvSpPr>
-          <p:cNvPr id="19" name="Rectangle 18"/>
-          <p:cNvSpPr/>
-          <p:nvPr/>
-        </p:nvSpPr>
-        <p:spPr>
-          <a:xfrm>
-            <a:off x="10415016" y="4546396"/>
-            <a:ext cx="89382" cy="419709"/>
-          </a:xfrm>
-          <a:prstGeom prst="rect">
-            <a:avLst/>
-          </a:prstGeom>
-          <a:solidFill>
-            <a:srgbClr val="2FD8B4"/>
-          </a:solidFill>
-          <a:ln>
-            <a:noFill/>
-          </a:ln>
-          <a:effectLst/>
-        </p:spPr>
-        <p:style>
-          <a:lnRef idx="1">
-            <a:schemeClr val="accent1"/>
-          </a:lnRef>
-          <a:fillRef idx="3">
-            <a:schemeClr val="accent1"/>
-          </a:fillRef>
-          <a:effectRef idx="2">
-            <a:schemeClr val="accent1"/>
-          </a:effectRef>
-          <a:fontRef idx="minor">
-            <a:schemeClr val="lt1"/>
-          </a:fontRef>
-        </p:style>
-        <p:txBody>
-          <a:bodyPr rtlCol="0" anchor="ctr"/>
-          <a:lstStyle/>
-          <a:p>
-            <a:pPr algn="ctr"/>
-          </a:p>
-        </p:txBody>
-      </p:sp>
-      <p:sp>
-        <p:nvSpPr>
-          <p:cNvPr id="20" name="Rectangle 19"/>
-          <p:cNvSpPr/>
-          <p:nvPr/>
-        </p:nvSpPr>
-        <p:spPr>
-          <a:xfrm>
-            <a:off x="10570464" y="4422038"/>
-            <a:ext cx="89382" cy="544068"/>
-          </a:xfrm>
-          <a:prstGeom prst="rect">
-            <a:avLst/>
-          </a:prstGeom>
-          <a:solidFill>
-            <a:srgbClr val="2FD8B4"/>
-          </a:solidFill>
-          <a:ln>
-            <a:noFill/>
-          </a:ln>
-          <a:effectLst/>
-        </p:spPr>
-        <p:style>
-          <a:lnRef idx="1">
-            <a:schemeClr val="accent1"/>
-          </a:lnRef>
-          <a:fillRef idx="3">
-            <a:schemeClr val="accent1"/>
-          </a:fillRef>
-          <a:effectRef idx="2">
-            <a:schemeClr val="accent1"/>
-          </a:effectRef>
-          <a:fontRef idx="minor">
-            <a:schemeClr val="lt1"/>
-          </a:fontRef>
-        </p:style>
-        <p:txBody>
-          <a:bodyPr rtlCol="0" anchor="ctr"/>
-          <a:lstStyle/>
-          <a:p>
-            <a:pPr algn="ctr"/>
-          </a:p>
-        </p:txBody>
-      </p:sp>
-      <p:sp>
-        <p:nvSpPr>
-          <p:cNvPr id="21" name="Rectangle 20"/>
-          <p:cNvSpPr/>
-          <p:nvPr/>
-        </p:nvSpPr>
-        <p:spPr>
-          <a:xfrm>
-            <a:off x="10725912" y="4297680"/>
-            <a:ext cx="89382" cy="668426"/>
-          </a:xfrm>
-          <a:prstGeom prst="rect">
-            <a:avLst/>
-          </a:prstGeom>
-          <a:solidFill>
-            <a:srgbClr val="2FD8B4"/>
-          </a:solidFill>
-          <a:ln>
-            <a:noFill/>
-          </a:ln>
-          <a:effectLst/>
-        </p:spPr>
-        <p:style>
-          <a:lnRef idx="1">
-            <a:schemeClr val="accent1"/>
-          </a:lnRef>
-          <a:fillRef idx="3">
-            <a:schemeClr val="accent1"/>
-          </a:fillRef>
-          <a:effectRef idx="2">
-            <a:schemeClr val="accent1"/>
-          </a:effectRef>
-          <a:fontRef idx="minor">
-            <a:schemeClr val="lt1"/>
-          </a:fontRef>
-        </p:style>
-        <p:txBody>
-          <a:bodyPr rtlCol="0" anchor="ctr"/>
-          <a:lstStyle/>
-          <a:p>
-            <a:pPr algn="ctr"/>
-          </a:p>
-        </p:txBody>
-      </p:sp>
-      <p:sp>
-        <p:nvSpPr>
-          <p:cNvPr id="22" name="TextBox 21"/>
-          <p:cNvSpPr txBox="1"/>
-          <p:nvPr/>
-        </p:nvSpPr>
-        <p:spPr>
-          <a:xfrm>
-            <a:off x="566928" y="5669280"/>
-            <a:ext cx="11057839" cy="548640"/>
-          </a:xfrm>
-          <a:prstGeom prst="rect">
-            <a:avLst/>
-          </a:prstGeom>
-          <a:noFill/>
-        </p:spPr>
-        <p:txBody>
-          <a:bodyPr wrap="square" lIns="0" rIns="0" tIns="0" bIns="0" anchor="t">
-            <a:spAutoFit/>
-          </a:bodyPr>
-          <a:lstStyle/>
-          <a:p>
-            <a:pPr algn="l">
-              <a:lnSpc>
-                <a:spcPct val="112000"/>
-              </a:lnSpc>
-              <a:spcAft>
-                <a:spcPts val="0"/>
-              </a:spcAft>
-            </a:pPr>
-            <a:r>
-              <a:rPr sz="1050" b="0">
-                <a:solidFill>
-                  <a:srgbClr val="8CA0BE"/>
-                </a:solidFill>
-                <a:latin typeface="Consolas"/>
-              </a:rPr>
-              <a:t>Logesh S.  ·  B.Sc. Data Science  ·  RetainIQ Signal Ops Console  ·  80.34% accuracy  ·  84.91% ROC-AUC</a:t>
             </a:r>
           </a:p>
         </p:txBody>

</xml_diff>

<commit_message>
Add separate final thank you slide
Co-authored-by: arena-agent <297053741+arena-agent@users.noreply.github.com>
</commit_message>
<xml_diff>
--- a/presentation/RetainIQ_Project_Review.pptx
+++ b/presentation/RetainIQ_Project_Review.pptx
@@ -25,6 +25,7 @@
     <p:sldId id="273" r:id="rId25"/>
     <p:sldId id="274" r:id="rId26"/>
     <p:sldId id="275" r:id="rId27"/>
+    <p:sldId id="276" r:id="rId28"/>
   </p:sldIdLst>
   <p:sldSz cx="12191695" cy="6858000" type="screen4x3"/>
   <p:notesSz cx="6858000" cy="9144000"/>
@@ -1738,27 +1739,22 @@
           <a:lstStyle/>
           <a:p>
             <a:r>
-              <a:t>CLOSING (11:05–11:30) Leave this slide up for questions. It puts the live URL and</a:t>
-            </a:r>
-          </a:p>
-          <a:p>
-            <a:r>
-              <a:t>a scannable QR in front of the examiner and ends on the thesis, not a tool list.</a:t>
-            </a:r>
-          </a:p>
-          <a:p>
-            <a:r>
-              <a:t>"The contribution isn't the 80% — it's that a probability becomes a prioritised,</a:t>
-            </a:r>
-          </a:p>
-          <a:p>
-            <a:r>
-              <a:t>explained, costed action, in a product a retention team can actually open. Thank</a:t>
-            </a:r>
-          </a:p>
-          <a:p>
-            <a:r>
-              <a:t>you — happy to take questions."</a:t>
+              <a:t>LIVE DEMO / LINKS (11:05–11:20) Use this slide to hand off from the review to the</a:t>
+            </a:r>
+          </a:p>
+          <a:p>
+            <a:r>
+              <a:t>working product. The live URL is clickable and also available as a QR code; the</a:t>
+            </a:r>
+          </a:p>
+          <a:p>
+            <a:r>
+              <a:t>source repository has its own QR and link. The same scoring path powers the model,</a:t>
+            </a:r>
+          </a:p>
+          <a:p>
+            <a:r>
+              <a:t>risk bands, coefficient explanations and recommendations shown throughout the deck.</a:t>
             </a:r>
           </a:p>
           <a:p>
@@ -1768,7 +1764,87 @@
           </a:p>
           <a:p>
             <a:r>
-              <a:t>Remember the free tier sleeps — warm the app before you present.</a:t>
+              <a:t>The host is a free tier, so warm it before the presentation.</a:t>
+            </a:r>
+          </a:p>
+        </p:txBody>
+      </p:sp>
+      <p:sp>
+        <p:nvSpPr>
+          <p:cNvPr id="4" name="Slide Number Placeholder 3"/>
+          <p:cNvSpPr>
+            <a:spLocks noGrp="1"/>
+          </p:cNvSpPr>
+          <p:nvPr>
+            <p:ph type="sldNum" idx="5" sz="quarter"/>
+          </p:nvPr>
+        </p:nvSpPr>
+        <p:spPr/>
+      </p:sp>
+    </p:spTree>
+  </p:cSld>
+  <p:clrMapOvr>
+    <a:masterClrMapping/>
+  </p:clrMapOvr>
+</p:notes>
+</file>
+
+<file path=ppt/notesSlides/notesSlide21.xml><?xml version="1.0" encoding="utf-8"?>
+<p:notes xmlns:a="http://schemas.openxmlformats.org/drawingml/2006/main" xmlns:p="http://schemas.openxmlformats.org/presentationml/2006/main" xmlns:r="http://schemas.openxmlformats.org/officeDocument/2006/relationships">
+  <p:cSld>
+    <p:spTree>
+      <p:nvGrpSpPr>
+        <p:cNvPr id="1" name=""/>
+        <p:cNvGrpSpPr/>
+        <p:nvPr/>
+      </p:nvGrpSpPr>
+      <p:grpSpPr>
+        <a:xfrm>
+          <a:off x="0" y="0"/>
+          <a:ext cx="0" cy="0"/>
+          <a:chOff x="0" y="0"/>
+          <a:chExt cx="0" cy="0"/>
+        </a:xfrm>
+      </p:grpSpPr>
+      <p:sp>
+        <p:nvSpPr>
+          <p:cNvPr id="2" name="Slide Image Placeholder 1"/>
+          <p:cNvSpPr>
+            <a:spLocks noGrp="1"/>
+          </p:cNvSpPr>
+          <p:nvPr>
+            <p:ph type="sldImg" idx="2"/>
+          </p:nvPr>
+        </p:nvSpPr>
+        <p:spPr/>
+      </p:sp>
+      <p:sp>
+        <p:nvSpPr>
+          <p:cNvPr id="3" name="Notes Placeholder 2"/>
+          <p:cNvSpPr>
+            <a:spLocks noGrp="1"/>
+          </p:cNvSpPr>
+          <p:nvPr>
+            <p:ph type="body" idx="3" sz="quarter"/>
+          </p:nvPr>
+        </p:nvSpPr>
+        <p:spPr/>
+        <p:txBody>
+          <a:bodyPr/>
+          <a:lstStyle/>
+          <a:p>
+            <a:r>
+              <a:t>THANK YOU (11:20–11:30) End on this dedicated final slide. "Thank you for your</a:t>
+            </a:r>
+          </a:p>
+          <a:p>
+            <a:r>
+              <a:t>time — happy to take questions." Keep the contribution precise: the project turns</a:t>
+            </a:r>
+          </a:p>
+          <a:p>
+            <a:r>
+              <a:t>a churn probability into a prioritised, explained and costed retention action.</a:t>
             </a:r>
           </a:p>
           <a:p/>
@@ -1799,12 +1875,12 @@
           </a:p>
           <a:p>
             <a:r>
-              <a:t>· Isn't revenue-at-risk optimistic? It's exposure, not savings — the deck and the</a:t>
-            </a:r>
-          </a:p>
-          <a:p>
-            <a:r>
-              <a:t>  app both say so; validating it needs a live campaign.</a:t>
+              <a:t>· Isn't revenue-at-risk optimistic? It is exposure, not savings; validating it</a:t>
+            </a:r>
+          </a:p>
+          <a:p>
+            <a:r>
+              <a:t>  needs a live campaign.</a:t>
             </a:r>
           </a:p>
           <a:p>
@@ -27219,7 +27295,7 @@
                 </a:solidFill>
                 <a:latin typeface="Consolas"/>
               </a:rPr>
-              <a:t>THANK YOU</a:t>
+              <a:t>LIVE DEMO &amp; PROJECT LINKS</a:t>
             </a:r>
           </a:p>
         </p:txBody>
@@ -27853,36 +27929,36 @@
                 <a:spcPct val="112000"/>
               </a:lnSpc>
               <a:spcAft>
-                <a:spcPts val="500"/>
+                <a:spcPts val="700"/>
               </a:spcAft>
             </a:pPr>
             <a:r>
-              <a:rPr sz="1900" b="1">
+              <a:rPr sz="950" b="1">
+                <a:solidFill>
+                  <a:srgbClr val="2FD8B4"/>
+                </a:solidFill>
+                <a:latin typeface="Consolas"/>
+              </a:rPr>
+              <a:t>PROJECT TAKEAWAY</a:t>
+            </a:r>
+          </a:p>
+          <a:p>
+            <a:pPr algn="l">
+              <a:lnSpc>
+                <a:spcPct val="112000"/>
+              </a:lnSpc>
+              <a:spcAft>
+                <a:spcPts val="700"/>
+              </a:spcAft>
+            </a:pPr>
+            <a:r>
+              <a:rPr sz="1700" b="1">
                 <a:solidFill>
                   <a:srgbClr val="EAF0F7"/>
                 </a:solidFill>
                 <a:latin typeface="Segoe UI"/>
               </a:rPr>
-              <a:t>Thank you</a:t>
-            </a:r>
-          </a:p>
-          <a:p>
-            <a:pPr algn="l">
-              <a:lnSpc>
-                <a:spcPct val="112000"/>
-              </a:lnSpc>
-              <a:spcAft>
-                <a:spcPts val="1000"/>
-              </a:spcAft>
-            </a:pPr>
-            <a:r>
-              <a:rPr sz="1100" b="0">
-                <a:solidFill>
-                  <a:srgbClr val="2FD8B4"/>
-                </a:solidFill>
-                <a:latin typeface="Segoe UI"/>
-              </a:rPr>
-              <a:t>Questions welcome.</a:t>
+              <a:t>Probability → action</a:t>
             </a:r>
           </a:p>
           <a:p>
@@ -27901,7 +27977,7 @@
                 </a:solidFill>
                 <a:latin typeface="Segoe UI"/>
               </a:rPr>
-              <a:t>RetainIQ — from a churn probability to a prioritised, explained, costed retention action.</a:t>
+              <a:t>From churn risk to a prioritised, explained and costed retention response.</a:t>
             </a:r>
           </a:p>
         </p:txBody>
@@ -28164,6 +28240,1464 @@
                 <a:latin typeface="Consolas"/>
               </a:rPr>
               <a:t>Logesh S.  ·  B.Sc. Data Science  ·  RetainIQ Signal Ops Console  ·  80.34% accuracy  ·  84.91% ROC-AUC</a:t>
+            </a:r>
+          </a:p>
+        </p:txBody>
+      </p:sp>
+    </p:spTree>
+  </p:cSld>
+  <p:clrMapOvr>
+    <a:masterClrMapping/>
+  </p:clrMapOvr>
+</p:sld>
+</file>
+
+<file path=ppt/slides/slide21.xml><?xml version="1.0" encoding="utf-8"?>
+<p:sld xmlns:a="http://schemas.openxmlformats.org/drawingml/2006/main" xmlns:p="http://schemas.openxmlformats.org/presentationml/2006/main" xmlns:r="http://schemas.openxmlformats.org/officeDocument/2006/relationships">
+  <p:cSld>
+    <p:spTree>
+      <p:nvGrpSpPr>
+        <p:cNvPr id="1" name=""/>
+        <p:cNvGrpSpPr/>
+        <p:nvPr/>
+      </p:nvGrpSpPr>
+      <p:grpSpPr/>
+      <p:sp>
+        <p:nvSpPr>
+          <p:cNvPr id="2" name="Rectangle 1"/>
+          <p:cNvSpPr/>
+          <p:nvPr/>
+        </p:nvSpPr>
+        <p:spPr>
+          <a:xfrm>
+            <a:off x="0" y="0"/>
+            <a:ext cx="12191695" cy="6858000"/>
+          </a:xfrm>
+          <a:prstGeom prst="rect">
+            <a:avLst/>
+          </a:prstGeom>
+          <a:solidFill>
+            <a:srgbClr val="0A0F1C"/>
+          </a:solidFill>
+          <a:ln>
+            <a:noFill/>
+          </a:ln>
+          <a:effectLst/>
+        </p:spPr>
+        <p:style>
+          <a:lnRef idx="1">
+            <a:schemeClr val="accent1"/>
+          </a:lnRef>
+          <a:fillRef idx="3">
+            <a:schemeClr val="accent1"/>
+          </a:fillRef>
+          <a:effectRef idx="2">
+            <a:schemeClr val="accent1"/>
+          </a:effectRef>
+          <a:fontRef idx="minor">
+            <a:schemeClr val="lt1"/>
+          </a:fontRef>
+        </p:style>
+        <p:txBody>
+          <a:bodyPr rtlCol="0" anchor="ctr"/>
+          <a:lstStyle/>
+          <a:p>
+            <a:pPr algn="ctr"/>
+          </a:p>
+        </p:txBody>
+      </p:sp>
+      <p:sp>
+        <p:nvSpPr>
+          <p:cNvPr id="3" name="Rectangle 2"/>
+          <p:cNvSpPr/>
+          <p:nvPr/>
+        </p:nvSpPr>
+        <p:spPr>
+          <a:xfrm>
+            <a:off x="0" y="0"/>
+            <a:ext cx="12191695" cy="77724"/>
+          </a:xfrm>
+          <a:prstGeom prst="rect">
+            <a:avLst/>
+          </a:prstGeom>
+          <a:solidFill>
+            <a:srgbClr val="2FD8B4"/>
+          </a:solidFill>
+          <a:ln>
+            <a:noFill/>
+          </a:ln>
+          <a:effectLst/>
+        </p:spPr>
+        <p:style>
+          <a:lnRef idx="1">
+            <a:schemeClr val="accent1"/>
+          </a:lnRef>
+          <a:fillRef idx="3">
+            <a:schemeClr val="accent1"/>
+          </a:fillRef>
+          <a:effectRef idx="2">
+            <a:schemeClr val="accent1"/>
+          </a:effectRef>
+          <a:fontRef idx="minor">
+            <a:schemeClr val="lt1"/>
+          </a:fontRef>
+        </p:style>
+        <p:txBody>
+          <a:bodyPr rtlCol="0" anchor="ctr"/>
+          <a:lstStyle/>
+          <a:p>
+            <a:pPr algn="ctr"/>
+          </a:p>
+        </p:txBody>
+      </p:sp>
+      <p:sp>
+        <p:nvSpPr>
+          <p:cNvPr id="4" name="Rounded Rectangle 3"/>
+          <p:cNvSpPr/>
+          <p:nvPr/>
+        </p:nvSpPr>
+        <p:spPr>
+          <a:xfrm>
+            <a:off x="566928" y="1517904"/>
+            <a:ext cx="11057839" cy="4553712"/>
+          </a:xfrm>
+          <a:prstGeom prst="roundRect">
+            <a:avLst>
+              <a:gd name="adj" fmla="val 8000"/>
+            </a:avLst>
+          </a:prstGeom>
+          <a:solidFill>
+            <a:srgbClr val="111A2C"/>
+          </a:solidFill>
+          <a:ln w="12700">
+            <a:solidFill>
+              <a:srgbClr val="223049"/>
+            </a:solidFill>
+          </a:ln>
+          <a:effectLst/>
+        </p:spPr>
+        <p:style>
+          <a:lnRef idx="1">
+            <a:schemeClr val="accent1"/>
+          </a:lnRef>
+          <a:fillRef idx="3">
+            <a:schemeClr val="accent1"/>
+          </a:fillRef>
+          <a:effectRef idx="2">
+            <a:schemeClr val="accent1"/>
+          </a:effectRef>
+          <a:fontRef idx="minor">
+            <a:schemeClr val="lt1"/>
+          </a:fontRef>
+        </p:style>
+        <p:txBody>
+          <a:bodyPr rtlCol="0" anchor="ctr"/>
+          <a:lstStyle/>
+          <a:p>
+            <a:pPr algn="ctr"/>
+          </a:p>
+        </p:txBody>
+      </p:sp>
+      <p:sp>
+        <p:nvSpPr>
+          <p:cNvPr id="5" name="Rectangle 4"/>
+          <p:cNvSpPr/>
+          <p:nvPr/>
+        </p:nvSpPr>
+        <p:spPr>
+          <a:xfrm>
+            <a:off x="566928" y="1517904"/>
+            <a:ext cx="11057839" cy="32004"/>
+          </a:xfrm>
+          <a:prstGeom prst="rect">
+            <a:avLst/>
+          </a:prstGeom>
+          <a:solidFill>
+            <a:srgbClr val="2FD8B4"/>
+          </a:solidFill>
+          <a:ln>
+            <a:noFill/>
+          </a:ln>
+          <a:effectLst/>
+        </p:spPr>
+        <p:style>
+          <a:lnRef idx="1">
+            <a:schemeClr val="accent1"/>
+          </a:lnRef>
+          <a:fillRef idx="3">
+            <a:schemeClr val="accent1"/>
+          </a:fillRef>
+          <a:effectRef idx="2">
+            <a:schemeClr val="accent1"/>
+          </a:effectRef>
+          <a:fontRef idx="minor">
+            <a:schemeClr val="lt1"/>
+          </a:fontRef>
+        </p:style>
+        <p:txBody>
+          <a:bodyPr rtlCol="0" anchor="ctr"/>
+          <a:lstStyle/>
+          <a:p>
+            <a:pPr algn="ctr"/>
+          </a:p>
+        </p:txBody>
+      </p:sp>
+      <p:sp>
+        <p:nvSpPr>
+          <p:cNvPr id="6" name="TextBox 5"/>
+          <p:cNvSpPr txBox="1"/>
+          <p:nvPr/>
+        </p:nvSpPr>
+        <p:spPr>
+          <a:xfrm>
+            <a:off x="1024128" y="1773936"/>
+            <a:ext cx="10143439" cy="237744"/>
+          </a:xfrm>
+          <a:prstGeom prst="rect">
+            <a:avLst/>
+          </a:prstGeom>
+          <a:noFill/>
+        </p:spPr>
+        <p:txBody>
+          <a:bodyPr wrap="square" lIns="0" rIns="0" tIns="0" bIns="0" anchor="t">
+            <a:spAutoFit/>
+          </a:bodyPr>
+          <a:lstStyle/>
+          <a:p>
+            <a:pPr algn="ctr">
+              <a:lnSpc>
+                <a:spcPct val="112000"/>
+              </a:lnSpc>
+              <a:spcAft>
+                <a:spcPts val="0"/>
+              </a:spcAft>
+            </a:pPr>
+            <a:r>
+              <a:rPr sz="1000" b="1">
+                <a:solidFill>
+                  <a:srgbClr val="2FD8B4"/>
+                </a:solidFill>
+                <a:latin typeface="Consolas"/>
+              </a:rPr>
+              <a:t>RETAINIQ · SIGNAL OPS CONSOLE</a:t>
+            </a:r>
+          </a:p>
+        </p:txBody>
+      </p:sp>
+      <p:sp>
+        <p:nvSpPr>
+          <p:cNvPr id="7" name="Rectangle 6"/>
+          <p:cNvSpPr/>
+          <p:nvPr/>
+        </p:nvSpPr>
+        <p:spPr>
+          <a:xfrm>
+            <a:off x="5650992" y="2772460"/>
+            <a:ext cx="110413" cy="211226"/>
+          </a:xfrm>
+          <a:prstGeom prst="rect">
+            <a:avLst/>
+          </a:prstGeom>
+          <a:solidFill>
+            <a:srgbClr val="2FD8B4"/>
+          </a:solidFill>
+          <a:ln>
+            <a:noFill/>
+          </a:ln>
+          <a:effectLst/>
+        </p:spPr>
+        <p:style>
+          <a:lnRef idx="1">
+            <a:schemeClr val="accent1"/>
+          </a:lnRef>
+          <a:fillRef idx="3">
+            <a:schemeClr val="accent1"/>
+          </a:fillRef>
+          <a:effectRef idx="2">
+            <a:schemeClr val="accent1"/>
+          </a:effectRef>
+          <a:fontRef idx="minor">
+            <a:schemeClr val="lt1"/>
+          </a:fontRef>
+        </p:style>
+        <p:txBody>
+          <a:bodyPr rtlCol="0" anchor="ctr"/>
+          <a:lstStyle/>
+          <a:p>
+            <a:pPr algn="ctr"/>
+          </a:p>
+        </p:txBody>
+      </p:sp>
+      <p:sp>
+        <p:nvSpPr>
+          <p:cNvPr id="8" name="Rectangle 7"/>
+          <p:cNvSpPr/>
+          <p:nvPr/>
+        </p:nvSpPr>
+        <p:spPr>
+          <a:xfrm>
+            <a:off x="5843016" y="2618841"/>
+            <a:ext cx="110413" cy="364845"/>
+          </a:xfrm>
+          <a:prstGeom prst="rect">
+            <a:avLst/>
+          </a:prstGeom>
+          <a:solidFill>
+            <a:srgbClr val="2FD8B4"/>
+          </a:solidFill>
+          <a:ln>
+            <a:noFill/>
+          </a:ln>
+          <a:effectLst/>
+        </p:spPr>
+        <p:style>
+          <a:lnRef idx="1">
+            <a:schemeClr val="accent1"/>
+          </a:lnRef>
+          <a:fillRef idx="3">
+            <a:schemeClr val="accent1"/>
+          </a:fillRef>
+          <a:effectRef idx="2">
+            <a:schemeClr val="accent1"/>
+          </a:effectRef>
+          <a:fontRef idx="minor">
+            <a:schemeClr val="lt1"/>
+          </a:fontRef>
+        </p:style>
+        <p:txBody>
+          <a:bodyPr rtlCol="0" anchor="ctr"/>
+          <a:lstStyle/>
+          <a:p>
+            <a:pPr algn="ctr"/>
+          </a:p>
+        </p:txBody>
+      </p:sp>
+      <p:sp>
+        <p:nvSpPr>
+          <p:cNvPr id="9" name="Rectangle 8"/>
+          <p:cNvSpPr/>
+          <p:nvPr/>
+        </p:nvSpPr>
+        <p:spPr>
+          <a:xfrm>
+            <a:off x="6035040" y="2465222"/>
+            <a:ext cx="110413" cy="518464"/>
+          </a:xfrm>
+          <a:prstGeom prst="rect">
+            <a:avLst/>
+          </a:prstGeom>
+          <a:solidFill>
+            <a:srgbClr val="2FD8B4"/>
+          </a:solidFill>
+          <a:ln>
+            <a:noFill/>
+          </a:ln>
+          <a:effectLst/>
+        </p:spPr>
+        <p:style>
+          <a:lnRef idx="1">
+            <a:schemeClr val="accent1"/>
+          </a:lnRef>
+          <a:fillRef idx="3">
+            <a:schemeClr val="accent1"/>
+          </a:fillRef>
+          <a:effectRef idx="2">
+            <a:schemeClr val="accent1"/>
+          </a:effectRef>
+          <a:fontRef idx="minor">
+            <a:schemeClr val="lt1"/>
+          </a:fontRef>
+        </p:style>
+        <p:txBody>
+          <a:bodyPr rtlCol="0" anchor="ctr"/>
+          <a:lstStyle/>
+          <a:p>
+            <a:pPr algn="ctr"/>
+          </a:p>
+        </p:txBody>
+      </p:sp>
+      <p:sp>
+        <p:nvSpPr>
+          <p:cNvPr id="10" name="Rectangle 9"/>
+          <p:cNvSpPr/>
+          <p:nvPr/>
+        </p:nvSpPr>
+        <p:spPr>
+          <a:xfrm>
+            <a:off x="6227064" y="2311603"/>
+            <a:ext cx="110413" cy="672084"/>
+          </a:xfrm>
+          <a:prstGeom prst="rect">
+            <a:avLst/>
+          </a:prstGeom>
+          <a:solidFill>
+            <a:srgbClr val="2FD8B4"/>
+          </a:solidFill>
+          <a:ln>
+            <a:noFill/>
+          </a:ln>
+          <a:effectLst/>
+        </p:spPr>
+        <p:style>
+          <a:lnRef idx="1">
+            <a:schemeClr val="accent1"/>
+          </a:lnRef>
+          <a:fillRef idx="3">
+            <a:schemeClr val="accent1"/>
+          </a:fillRef>
+          <a:effectRef idx="2">
+            <a:schemeClr val="accent1"/>
+          </a:effectRef>
+          <a:fontRef idx="minor">
+            <a:schemeClr val="lt1"/>
+          </a:fontRef>
+        </p:style>
+        <p:txBody>
+          <a:bodyPr rtlCol="0" anchor="ctr"/>
+          <a:lstStyle/>
+          <a:p>
+            <a:pPr algn="ctr"/>
+          </a:p>
+        </p:txBody>
+      </p:sp>
+      <p:sp>
+        <p:nvSpPr>
+          <p:cNvPr id="11" name="Rectangle 10"/>
+          <p:cNvSpPr/>
+          <p:nvPr/>
+        </p:nvSpPr>
+        <p:spPr>
+          <a:xfrm>
+            <a:off x="6419088" y="2157984"/>
+            <a:ext cx="110413" cy="825703"/>
+          </a:xfrm>
+          <a:prstGeom prst="rect">
+            <a:avLst/>
+          </a:prstGeom>
+          <a:solidFill>
+            <a:srgbClr val="2FD8B4"/>
+          </a:solidFill>
+          <a:ln>
+            <a:noFill/>
+          </a:ln>
+          <a:effectLst/>
+        </p:spPr>
+        <p:style>
+          <a:lnRef idx="1">
+            <a:schemeClr val="accent1"/>
+          </a:lnRef>
+          <a:fillRef idx="3">
+            <a:schemeClr val="accent1"/>
+          </a:fillRef>
+          <a:effectRef idx="2">
+            <a:schemeClr val="accent1"/>
+          </a:effectRef>
+          <a:fontRef idx="minor">
+            <a:schemeClr val="lt1"/>
+          </a:fontRef>
+        </p:style>
+        <p:txBody>
+          <a:bodyPr rtlCol="0" anchor="ctr"/>
+          <a:lstStyle/>
+          <a:p>
+            <a:pPr algn="ctr"/>
+          </a:p>
+        </p:txBody>
+      </p:sp>
+      <p:sp>
+        <p:nvSpPr>
+          <p:cNvPr id="12" name="TextBox 11"/>
+          <p:cNvSpPr txBox="1"/>
+          <p:nvPr/>
+        </p:nvSpPr>
+        <p:spPr>
+          <a:xfrm>
+            <a:off x="1024128" y="3017520"/>
+            <a:ext cx="10143439" cy="768096"/>
+          </a:xfrm>
+          <a:prstGeom prst="rect">
+            <a:avLst/>
+          </a:prstGeom>
+          <a:noFill/>
+        </p:spPr>
+        <p:txBody>
+          <a:bodyPr wrap="square" lIns="0" rIns="0" tIns="0" bIns="0" anchor="t">
+            <a:spAutoFit/>
+          </a:bodyPr>
+          <a:lstStyle/>
+          <a:p>
+            <a:pPr algn="ctr">
+              <a:lnSpc>
+                <a:spcPct val="112000"/>
+              </a:lnSpc>
+              <a:spcAft>
+                <a:spcPts val="0"/>
+              </a:spcAft>
+            </a:pPr>
+            <a:r>
+              <a:rPr sz="4200" b="1">
+                <a:solidFill>
+                  <a:srgbClr val="EAF0F7"/>
+                </a:solidFill>
+                <a:latin typeface="Segoe UI"/>
+              </a:rPr>
+              <a:t>Thank You</a:t>
+            </a:r>
+          </a:p>
+        </p:txBody>
+      </p:sp>
+      <p:sp>
+        <p:nvSpPr>
+          <p:cNvPr id="13" name="TextBox 12"/>
+          <p:cNvSpPr txBox="1"/>
+          <p:nvPr/>
+        </p:nvSpPr>
+        <p:spPr>
+          <a:xfrm>
+            <a:off x="1024128" y="3886200"/>
+            <a:ext cx="10143439" cy="310896"/>
+          </a:xfrm>
+          <a:prstGeom prst="rect">
+            <a:avLst/>
+          </a:prstGeom>
+          <a:noFill/>
+        </p:spPr>
+        <p:txBody>
+          <a:bodyPr wrap="square" lIns="0" rIns="0" tIns="0" bIns="0" anchor="t">
+            <a:spAutoFit/>
+          </a:bodyPr>
+          <a:lstStyle/>
+          <a:p>
+            <a:pPr algn="ctr">
+              <a:lnSpc>
+                <a:spcPct val="112000"/>
+              </a:lnSpc>
+              <a:spcAft>
+                <a:spcPts val="0"/>
+              </a:spcAft>
+            </a:pPr>
+            <a:r>
+              <a:rPr sz="1600" b="0">
+                <a:solidFill>
+                  <a:srgbClr val="2FD8B4"/>
+                </a:solidFill>
+                <a:latin typeface="Segoe UI"/>
+              </a:rPr>
+              <a:t>Questions &amp; discussion</a:t>
+            </a:r>
+          </a:p>
+        </p:txBody>
+      </p:sp>
+      <p:sp>
+        <p:nvSpPr>
+          <p:cNvPr id="14" name="Rectangle 13"/>
+          <p:cNvSpPr/>
+          <p:nvPr/>
+        </p:nvSpPr>
+        <p:spPr>
+          <a:xfrm>
+            <a:off x="4370832" y="4370832"/>
+            <a:ext cx="3447288" cy="12801"/>
+          </a:xfrm>
+          <a:prstGeom prst="rect">
+            <a:avLst/>
+          </a:prstGeom>
+          <a:solidFill>
+            <a:srgbClr val="223049"/>
+          </a:solidFill>
+          <a:ln>
+            <a:noFill/>
+          </a:ln>
+          <a:effectLst/>
+        </p:spPr>
+        <p:style>
+          <a:lnRef idx="1">
+            <a:schemeClr val="accent1"/>
+          </a:lnRef>
+          <a:fillRef idx="3">
+            <a:schemeClr val="accent1"/>
+          </a:fillRef>
+          <a:effectRef idx="2">
+            <a:schemeClr val="accent1"/>
+          </a:effectRef>
+          <a:fontRef idx="minor">
+            <a:schemeClr val="lt1"/>
+          </a:fontRef>
+        </p:style>
+        <p:txBody>
+          <a:bodyPr rtlCol="0" anchor="ctr"/>
+          <a:lstStyle/>
+          <a:p>
+            <a:pPr algn="ctr"/>
+          </a:p>
+        </p:txBody>
+      </p:sp>
+      <p:sp>
+        <p:nvSpPr>
+          <p:cNvPr id="15" name="TextBox 14"/>
+          <p:cNvSpPr txBox="1"/>
+          <p:nvPr/>
+        </p:nvSpPr>
+        <p:spPr>
+          <a:xfrm>
+            <a:off x="1207007" y="4572000"/>
+            <a:ext cx="9777679" cy="438912"/>
+          </a:xfrm>
+          <a:prstGeom prst="rect">
+            <a:avLst/>
+          </a:prstGeom>
+          <a:noFill/>
+        </p:spPr>
+        <p:txBody>
+          <a:bodyPr wrap="square" lIns="0" rIns="0" tIns="0" bIns="0" anchor="t">
+            <a:spAutoFit/>
+          </a:bodyPr>
+          <a:lstStyle/>
+          <a:p>
+            <a:pPr algn="ctr">
+              <a:lnSpc>
+                <a:spcPct val="116000"/>
+              </a:lnSpc>
+              <a:spcAft>
+                <a:spcPts val="0"/>
+              </a:spcAft>
+            </a:pPr>
+            <a:r>
+              <a:rPr sz="1400" b="0">
+                <a:solidFill>
+                  <a:srgbClr val="8CA0BE"/>
+                </a:solidFill>
+                <a:latin typeface="Segoe UI"/>
+              </a:rPr>
+              <a:t>From churn probability to a prioritised, explained and costed retention action.</a:t>
+            </a:r>
+          </a:p>
+        </p:txBody>
+      </p:sp>
+      <p:sp>
+        <p:nvSpPr>
+          <p:cNvPr id="16" name="TextBox 15"/>
+          <p:cNvSpPr txBox="1"/>
+          <p:nvPr/>
+        </p:nvSpPr>
+        <p:spPr>
+          <a:xfrm>
+            <a:off x="1024128" y="5248656"/>
+            <a:ext cx="10143439" cy="228600"/>
+          </a:xfrm>
+          <a:prstGeom prst="rect">
+            <a:avLst/>
+          </a:prstGeom>
+          <a:noFill/>
+        </p:spPr>
+        <p:txBody>
+          <a:bodyPr wrap="square" lIns="0" rIns="0" tIns="0" bIns="0" anchor="t">
+            <a:spAutoFit/>
+          </a:bodyPr>
+          <a:lstStyle/>
+          <a:p>
+            <a:pPr algn="ctr">
+              <a:lnSpc>
+                <a:spcPct val="112000"/>
+              </a:lnSpc>
+              <a:spcAft>
+                <a:spcPts val="0"/>
+              </a:spcAft>
+            </a:pPr>
+            <a:r>
+              <a:rPr sz="1000" b="1">
+                <a:solidFill>
+                  <a:srgbClr val="4C8DFF"/>
+                </a:solidFill>
+                <a:latin typeface="Consolas"/>
+              </a:rPr>
+              <a:t>LOGESH S.  ·  B.SC. DATA SCIENCE</a:t>
+            </a:r>
+          </a:p>
+        </p:txBody>
+      </p:sp>
+      <p:sp>
+        <p:nvSpPr>
+          <p:cNvPr id="17" name="TextBox 16"/>
+          <p:cNvSpPr txBox="1"/>
+          <p:nvPr/>
+        </p:nvSpPr>
+        <p:spPr>
+          <a:xfrm>
+            <a:off x="1024128" y="5559552"/>
+            <a:ext cx="10143439" cy="228600"/>
+          </a:xfrm>
+          <a:prstGeom prst="rect">
+            <a:avLst/>
+          </a:prstGeom>
+          <a:noFill/>
+        </p:spPr>
+        <p:txBody>
+          <a:bodyPr wrap="square" lIns="0" rIns="0" tIns="0" bIns="0" anchor="t">
+            <a:spAutoFit/>
+          </a:bodyPr>
+          <a:lstStyle/>
+          <a:p>
+            <a:pPr algn="ctr">
+              <a:lnSpc>
+                <a:spcPct val="112000"/>
+              </a:lnSpc>
+              <a:spcAft>
+                <a:spcPts val="0"/>
+              </a:spcAft>
+            </a:pPr>
+            <a:r>
+              <a:rPr sz="950" b="0">
+                <a:solidFill>
+                  <a:srgbClr val="8CA0BE"/>
+                </a:solidFill>
+                <a:latin typeface="Consolas"/>
+              </a:rPr>
+              <a:t>80.34% ACCURACY  ·  84.91% ROC-AUC  ·  7,043 CUSTOMERS SCORED  ·  $92,539 HIGH-RISK MONTHLY EXPOSURE</a:t>
+            </a:r>
+          </a:p>
+        </p:txBody>
+      </p:sp>
+      <p:sp>
+        <p:nvSpPr>
+          <p:cNvPr id="18" name="Rectangle 17"/>
+          <p:cNvSpPr/>
+          <p:nvPr/>
+        </p:nvSpPr>
+        <p:spPr>
+          <a:xfrm>
+            <a:off x="566928" y="6309360"/>
+            <a:ext cx="743145" cy="43891"/>
+          </a:xfrm>
+          <a:prstGeom prst="rect">
+            <a:avLst/>
+          </a:prstGeom>
+          <a:solidFill>
+            <a:srgbClr val="2FD8B4"/>
+          </a:solidFill>
+          <a:ln>
+            <a:noFill/>
+          </a:ln>
+          <a:effectLst/>
+        </p:spPr>
+        <p:style>
+          <a:lnRef idx="1">
+            <a:schemeClr val="accent1"/>
+          </a:lnRef>
+          <a:fillRef idx="3">
+            <a:schemeClr val="accent1"/>
+          </a:fillRef>
+          <a:effectRef idx="2">
+            <a:schemeClr val="accent1"/>
+          </a:effectRef>
+          <a:fontRef idx="minor">
+            <a:schemeClr val="lt1"/>
+          </a:fontRef>
+        </p:style>
+        <p:txBody>
+          <a:bodyPr rtlCol="0" anchor="ctr"/>
+          <a:lstStyle/>
+          <a:p>
+            <a:pPr algn="ctr"/>
+          </a:p>
+        </p:txBody>
+      </p:sp>
+      <p:sp>
+        <p:nvSpPr>
+          <p:cNvPr id="19" name="Rectangle 18"/>
+          <p:cNvSpPr/>
+          <p:nvPr/>
+        </p:nvSpPr>
+        <p:spPr>
+          <a:xfrm>
+            <a:off x="1360365" y="6309360"/>
+            <a:ext cx="743145" cy="43891"/>
+          </a:xfrm>
+          <a:prstGeom prst="rect">
+            <a:avLst/>
+          </a:prstGeom>
+          <a:solidFill>
+            <a:srgbClr val="2FD8B4"/>
+          </a:solidFill>
+          <a:ln>
+            <a:noFill/>
+          </a:ln>
+          <a:effectLst/>
+        </p:spPr>
+        <p:style>
+          <a:lnRef idx="1">
+            <a:schemeClr val="accent1"/>
+          </a:lnRef>
+          <a:fillRef idx="3">
+            <a:schemeClr val="accent1"/>
+          </a:fillRef>
+          <a:effectRef idx="2">
+            <a:schemeClr val="accent1"/>
+          </a:effectRef>
+          <a:fontRef idx="minor">
+            <a:schemeClr val="lt1"/>
+          </a:fontRef>
+        </p:style>
+        <p:txBody>
+          <a:bodyPr rtlCol="0" anchor="ctr"/>
+          <a:lstStyle/>
+          <a:p>
+            <a:pPr algn="ctr"/>
+          </a:p>
+        </p:txBody>
+      </p:sp>
+      <p:sp>
+        <p:nvSpPr>
+          <p:cNvPr id="20" name="Rectangle 19"/>
+          <p:cNvSpPr/>
+          <p:nvPr/>
+        </p:nvSpPr>
+        <p:spPr>
+          <a:xfrm>
+            <a:off x="2153803" y="6309360"/>
+            <a:ext cx="743145" cy="43891"/>
+          </a:xfrm>
+          <a:prstGeom prst="rect">
+            <a:avLst/>
+          </a:prstGeom>
+          <a:solidFill>
+            <a:srgbClr val="2FD8B4"/>
+          </a:solidFill>
+          <a:ln>
+            <a:noFill/>
+          </a:ln>
+          <a:effectLst/>
+        </p:spPr>
+        <p:style>
+          <a:lnRef idx="1">
+            <a:schemeClr val="accent1"/>
+          </a:lnRef>
+          <a:fillRef idx="3">
+            <a:schemeClr val="accent1"/>
+          </a:fillRef>
+          <a:effectRef idx="2">
+            <a:schemeClr val="accent1"/>
+          </a:effectRef>
+          <a:fontRef idx="minor">
+            <a:schemeClr val="lt1"/>
+          </a:fontRef>
+        </p:style>
+        <p:txBody>
+          <a:bodyPr rtlCol="0" anchor="ctr"/>
+          <a:lstStyle/>
+          <a:p>
+            <a:pPr algn="ctr"/>
+          </a:p>
+        </p:txBody>
+      </p:sp>
+      <p:sp>
+        <p:nvSpPr>
+          <p:cNvPr id="21" name="Rectangle 20"/>
+          <p:cNvSpPr/>
+          <p:nvPr/>
+        </p:nvSpPr>
+        <p:spPr>
+          <a:xfrm>
+            <a:off x="2947241" y="6309360"/>
+            <a:ext cx="743145" cy="43891"/>
+          </a:xfrm>
+          <a:prstGeom prst="rect">
+            <a:avLst/>
+          </a:prstGeom>
+          <a:solidFill>
+            <a:srgbClr val="2FD8B4"/>
+          </a:solidFill>
+          <a:ln>
+            <a:noFill/>
+          </a:ln>
+          <a:effectLst/>
+        </p:spPr>
+        <p:style>
+          <a:lnRef idx="1">
+            <a:schemeClr val="accent1"/>
+          </a:lnRef>
+          <a:fillRef idx="3">
+            <a:schemeClr val="accent1"/>
+          </a:fillRef>
+          <a:effectRef idx="2">
+            <a:schemeClr val="accent1"/>
+          </a:effectRef>
+          <a:fontRef idx="minor">
+            <a:schemeClr val="lt1"/>
+          </a:fontRef>
+        </p:style>
+        <p:txBody>
+          <a:bodyPr rtlCol="0" anchor="ctr"/>
+          <a:lstStyle/>
+          <a:p>
+            <a:pPr algn="ctr"/>
+          </a:p>
+        </p:txBody>
+      </p:sp>
+      <p:sp>
+        <p:nvSpPr>
+          <p:cNvPr id="22" name="Rectangle 21"/>
+          <p:cNvSpPr/>
+          <p:nvPr/>
+        </p:nvSpPr>
+        <p:spPr>
+          <a:xfrm>
+            <a:off x="3740679" y="6309360"/>
+            <a:ext cx="743145" cy="43891"/>
+          </a:xfrm>
+          <a:prstGeom prst="rect">
+            <a:avLst/>
+          </a:prstGeom>
+          <a:solidFill>
+            <a:srgbClr val="2FD8B4"/>
+          </a:solidFill>
+          <a:ln>
+            <a:noFill/>
+          </a:ln>
+          <a:effectLst/>
+        </p:spPr>
+        <p:style>
+          <a:lnRef idx="1">
+            <a:schemeClr val="accent1"/>
+          </a:lnRef>
+          <a:fillRef idx="3">
+            <a:schemeClr val="accent1"/>
+          </a:fillRef>
+          <a:effectRef idx="2">
+            <a:schemeClr val="accent1"/>
+          </a:effectRef>
+          <a:fontRef idx="minor">
+            <a:schemeClr val="lt1"/>
+          </a:fontRef>
+        </p:style>
+        <p:txBody>
+          <a:bodyPr rtlCol="0" anchor="ctr"/>
+          <a:lstStyle/>
+          <a:p>
+            <a:pPr algn="ctr"/>
+          </a:p>
+        </p:txBody>
+      </p:sp>
+      <p:sp>
+        <p:nvSpPr>
+          <p:cNvPr id="23" name="Rectangle 22"/>
+          <p:cNvSpPr/>
+          <p:nvPr/>
+        </p:nvSpPr>
+        <p:spPr>
+          <a:xfrm>
+            <a:off x="4534117" y="6309360"/>
+            <a:ext cx="743145" cy="43891"/>
+          </a:xfrm>
+          <a:prstGeom prst="rect">
+            <a:avLst/>
+          </a:prstGeom>
+          <a:solidFill>
+            <a:srgbClr val="2FD8B4"/>
+          </a:solidFill>
+          <a:ln>
+            <a:noFill/>
+          </a:ln>
+          <a:effectLst/>
+        </p:spPr>
+        <p:style>
+          <a:lnRef idx="1">
+            <a:schemeClr val="accent1"/>
+          </a:lnRef>
+          <a:fillRef idx="3">
+            <a:schemeClr val="accent1"/>
+          </a:fillRef>
+          <a:effectRef idx="2">
+            <a:schemeClr val="accent1"/>
+          </a:effectRef>
+          <a:fontRef idx="minor">
+            <a:schemeClr val="lt1"/>
+          </a:fontRef>
+        </p:style>
+        <p:txBody>
+          <a:bodyPr rtlCol="0" anchor="ctr"/>
+          <a:lstStyle/>
+          <a:p>
+            <a:pPr algn="ctr"/>
+          </a:p>
+        </p:txBody>
+      </p:sp>
+      <p:sp>
+        <p:nvSpPr>
+          <p:cNvPr id="24" name="Rectangle 23"/>
+          <p:cNvSpPr/>
+          <p:nvPr/>
+        </p:nvSpPr>
+        <p:spPr>
+          <a:xfrm>
+            <a:off x="5327555" y="6309360"/>
+            <a:ext cx="743145" cy="43891"/>
+          </a:xfrm>
+          <a:prstGeom prst="rect">
+            <a:avLst/>
+          </a:prstGeom>
+          <a:solidFill>
+            <a:srgbClr val="2FD8B4"/>
+          </a:solidFill>
+          <a:ln>
+            <a:noFill/>
+          </a:ln>
+          <a:effectLst/>
+        </p:spPr>
+        <p:style>
+          <a:lnRef idx="1">
+            <a:schemeClr val="accent1"/>
+          </a:lnRef>
+          <a:fillRef idx="3">
+            <a:schemeClr val="accent1"/>
+          </a:fillRef>
+          <a:effectRef idx="2">
+            <a:schemeClr val="accent1"/>
+          </a:effectRef>
+          <a:fontRef idx="minor">
+            <a:schemeClr val="lt1"/>
+          </a:fontRef>
+        </p:style>
+        <p:txBody>
+          <a:bodyPr rtlCol="0" anchor="ctr"/>
+          <a:lstStyle/>
+          <a:p>
+            <a:pPr algn="ctr"/>
+          </a:p>
+        </p:txBody>
+      </p:sp>
+      <p:sp>
+        <p:nvSpPr>
+          <p:cNvPr id="25" name="Rectangle 24"/>
+          <p:cNvSpPr/>
+          <p:nvPr/>
+        </p:nvSpPr>
+        <p:spPr>
+          <a:xfrm>
+            <a:off x="6120993" y="6309360"/>
+            <a:ext cx="743145" cy="43891"/>
+          </a:xfrm>
+          <a:prstGeom prst="rect">
+            <a:avLst/>
+          </a:prstGeom>
+          <a:solidFill>
+            <a:srgbClr val="2FD8B4"/>
+          </a:solidFill>
+          <a:ln>
+            <a:noFill/>
+          </a:ln>
+          <a:effectLst/>
+        </p:spPr>
+        <p:style>
+          <a:lnRef idx="1">
+            <a:schemeClr val="accent1"/>
+          </a:lnRef>
+          <a:fillRef idx="3">
+            <a:schemeClr val="accent1"/>
+          </a:fillRef>
+          <a:effectRef idx="2">
+            <a:schemeClr val="accent1"/>
+          </a:effectRef>
+          <a:fontRef idx="minor">
+            <a:schemeClr val="lt1"/>
+          </a:fontRef>
+        </p:style>
+        <p:txBody>
+          <a:bodyPr rtlCol="0" anchor="ctr"/>
+          <a:lstStyle/>
+          <a:p>
+            <a:pPr algn="ctr"/>
+          </a:p>
+        </p:txBody>
+      </p:sp>
+      <p:sp>
+        <p:nvSpPr>
+          <p:cNvPr id="26" name="Rectangle 25"/>
+          <p:cNvSpPr/>
+          <p:nvPr/>
+        </p:nvSpPr>
+        <p:spPr>
+          <a:xfrm>
+            <a:off x="6914431" y="6309360"/>
+            <a:ext cx="743145" cy="43891"/>
+          </a:xfrm>
+          <a:prstGeom prst="rect">
+            <a:avLst/>
+          </a:prstGeom>
+          <a:solidFill>
+            <a:srgbClr val="2FD8B4"/>
+          </a:solidFill>
+          <a:ln>
+            <a:noFill/>
+          </a:ln>
+          <a:effectLst/>
+        </p:spPr>
+        <p:style>
+          <a:lnRef idx="1">
+            <a:schemeClr val="accent1"/>
+          </a:lnRef>
+          <a:fillRef idx="3">
+            <a:schemeClr val="accent1"/>
+          </a:fillRef>
+          <a:effectRef idx="2">
+            <a:schemeClr val="accent1"/>
+          </a:effectRef>
+          <a:fontRef idx="minor">
+            <a:schemeClr val="lt1"/>
+          </a:fontRef>
+        </p:style>
+        <p:txBody>
+          <a:bodyPr rtlCol="0" anchor="ctr"/>
+          <a:lstStyle/>
+          <a:p>
+            <a:pPr algn="ctr"/>
+          </a:p>
+        </p:txBody>
+      </p:sp>
+      <p:sp>
+        <p:nvSpPr>
+          <p:cNvPr id="27" name="Rectangle 26"/>
+          <p:cNvSpPr/>
+          <p:nvPr/>
+        </p:nvSpPr>
+        <p:spPr>
+          <a:xfrm>
+            <a:off x="7707869" y="6309360"/>
+            <a:ext cx="743145" cy="43891"/>
+          </a:xfrm>
+          <a:prstGeom prst="rect">
+            <a:avLst/>
+          </a:prstGeom>
+          <a:solidFill>
+            <a:srgbClr val="2FD8B4"/>
+          </a:solidFill>
+          <a:ln>
+            <a:noFill/>
+          </a:ln>
+          <a:effectLst/>
+        </p:spPr>
+        <p:style>
+          <a:lnRef idx="1">
+            <a:schemeClr val="accent1"/>
+          </a:lnRef>
+          <a:fillRef idx="3">
+            <a:schemeClr val="accent1"/>
+          </a:fillRef>
+          <a:effectRef idx="2">
+            <a:schemeClr val="accent1"/>
+          </a:effectRef>
+          <a:fontRef idx="minor">
+            <a:schemeClr val="lt1"/>
+          </a:fontRef>
+        </p:style>
+        <p:txBody>
+          <a:bodyPr rtlCol="0" anchor="ctr"/>
+          <a:lstStyle/>
+          <a:p>
+            <a:pPr algn="ctr"/>
+          </a:p>
+        </p:txBody>
+      </p:sp>
+      <p:sp>
+        <p:nvSpPr>
+          <p:cNvPr id="28" name="Rectangle 27"/>
+          <p:cNvSpPr/>
+          <p:nvPr/>
+        </p:nvSpPr>
+        <p:spPr>
+          <a:xfrm>
+            <a:off x="8501307" y="6309360"/>
+            <a:ext cx="743145" cy="43891"/>
+          </a:xfrm>
+          <a:prstGeom prst="rect">
+            <a:avLst/>
+          </a:prstGeom>
+          <a:solidFill>
+            <a:srgbClr val="2FD8B4"/>
+          </a:solidFill>
+          <a:ln>
+            <a:noFill/>
+          </a:ln>
+          <a:effectLst/>
+        </p:spPr>
+        <p:style>
+          <a:lnRef idx="1">
+            <a:schemeClr val="accent1"/>
+          </a:lnRef>
+          <a:fillRef idx="3">
+            <a:schemeClr val="accent1"/>
+          </a:fillRef>
+          <a:effectRef idx="2">
+            <a:schemeClr val="accent1"/>
+          </a:effectRef>
+          <a:fontRef idx="minor">
+            <a:schemeClr val="lt1"/>
+          </a:fontRef>
+        </p:style>
+        <p:txBody>
+          <a:bodyPr rtlCol="0" anchor="ctr"/>
+          <a:lstStyle/>
+          <a:p>
+            <a:pPr algn="ctr"/>
+          </a:p>
+        </p:txBody>
+      </p:sp>
+      <p:sp>
+        <p:nvSpPr>
+          <p:cNvPr id="29" name="Rectangle 28"/>
+          <p:cNvSpPr/>
+          <p:nvPr/>
+        </p:nvSpPr>
+        <p:spPr>
+          <a:xfrm>
+            <a:off x="9294745" y="6309360"/>
+            <a:ext cx="743145" cy="43891"/>
+          </a:xfrm>
+          <a:prstGeom prst="rect">
+            <a:avLst/>
+          </a:prstGeom>
+          <a:solidFill>
+            <a:srgbClr val="2FD8B4"/>
+          </a:solidFill>
+          <a:ln>
+            <a:noFill/>
+          </a:ln>
+          <a:effectLst/>
+        </p:spPr>
+        <p:style>
+          <a:lnRef idx="1">
+            <a:schemeClr val="accent1"/>
+          </a:lnRef>
+          <a:fillRef idx="3">
+            <a:schemeClr val="accent1"/>
+          </a:fillRef>
+          <a:effectRef idx="2">
+            <a:schemeClr val="accent1"/>
+          </a:effectRef>
+          <a:fontRef idx="minor">
+            <a:schemeClr val="lt1"/>
+          </a:fontRef>
+        </p:style>
+        <p:txBody>
+          <a:bodyPr rtlCol="0" anchor="ctr"/>
+          <a:lstStyle/>
+          <a:p>
+            <a:pPr algn="ctr"/>
+          </a:p>
+        </p:txBody>
+      </p:sp>
+      <p:sp>
+        <p:nvSpPr>
+          <p:cNvPr id="30" name="Rectangle 29"/>
+          <p:cNvSpPr/>
+          <p:nvPr/>
+        </p:nvSpPr>
+        <p:spPr>
+          <a:xfrm>
+            <a:off x="10088183" y="6309360"/>
+            <a:ext cx="743145" cy="43891"/>
+          </a:xfrm>
+          <a:prstGeom prst="rect">
+            <a:avLst/>
+          </a:prstGeom>
+          <a:solidFill>
+            <a:srgbClr val="2FD8B4"/>
+          </a:solidFill>
+          <a:ln>
+            <a:noFill/>
+          </a:ln>
+          <a:effectLst/>
+        </p:spPr>
+        <p:style>
+          <a:lnRef idx="1">
+            <a:schemeClr val="accent1"/>
+          </a:lnRef>
+          <a:fillRef idx="3">
+            <a:schemeClr val="accent1"/>
+          </a:fillRef>
+          <a:effectRef idx="2">
+            <a:schemeClr val="accent1"/>
+          </a:effectRef>
+          <a:fontRef idx="minor">
+            <a:schemeClr val="lt1"/>
+          </a:fontRef>
+        </p:style>
+        <p:txBody>
+          <a:bodyPr rtlCol="0" anchor="ctr"/>
+          <a:lstStyle/>
+          <a:p>
+            <a:pPr algn="ctr"/>
+          </a:p>
+        </p:txBody>
+      </p:sp>
+      <p:sp>
+        <p:nvSpPr>
+          <p:cNvPr id="31" name="Rectangle 30"/>
+          <p:cNvSpPr/>
+          <p:nvPr/>
+        </p:nvSpPr>
+        <p:spPr>
+          <a:xfrm>
+            <a:off x="10881621" y="6309360"/>
+            <a:ext cx="743145" cy="43891"/>
+          </a:xfrm>
+          <a:prstGeom prst="rect">
+            <a:avLst/>
+          </a:prstGeom>
+          <a:solidFill>
+            <a:srgbClr val="2FD8B4"/>
+          </a:solidFill>
+          <a:ln>
+            <a:noFill/>
+          </a:ln>
+          <a:effectLst/>
+        </p:spPr>
+        <p:style>
+          <a:lnRef idx="1">
+            <a:schemeClr val="accent1"/>
+          </a:lnRef>
+          <a:fillRef idx="3">
+            <a:schemeClr val="accent1"/>
+          </a:fillRef>
+          <a:effectRef idx="2">
+            <a:schemeClr val="accent1"/>
+          </a:effectRef>
+          <a:fontRef idx="minor">
+            <a:schemeClr val="lt1"/>
+          </a:fontRef>
+        </p:style>
+        <p:txBody>
+          <a:bodyPr rtlCol="0" anchor="ctr"/>
+          <a:lstStyle/>
+          <a:p>
+            <a:pPr algn="ctr"/>
+          </a:p>
+        </p:txBody>
+      </p:sp>
+      <p:sp>
+        <p:nvSpPr>
+          <p:cNvPr id="32" name="Rectangle 31"/>
+          <p:cNvSpPr/>
+          <p:nvPr/>
+        </p:nvSpPr>
+        <p:spPr>
+          <a:xfrm>
+            <a:off x="566928" y="6455664"/>
+            <a:ext cx="11057839" cy="9144"/>
+          </a:xfrm>
+          <a:prstGeom prst="rect">
+            <a:avLst/>
+          </a:prstGeom>
+          <a:solidFill>
+            <a:srgbClr val="223049"/>
+          </a:solidFill>
+          <a:ln>
+            <a:noFill/>
+          </a:ln>
+          <a:effectLst/>
+        </p:spPr>
+        <p:style>
+          <a:lnRef idx="1">
+            <a:schemeClr val="accent1"/>
+          </a:lnRef>
+          <a:fillRef idx="3">
+            <a:schemeClr val="accent1"/>
+          </a:fillRef>
+          <a:effectRef idx="2">
+            <a:schemeClr val="accent1"/>
+          </a:effectRef>
+          <a:fontRef idx="minor">
+            <a:schemeClr val="lt1"/>
+          </a:fontRef>
+        </p:style>
+        <p:txBody>
+          <a:bodyPr rtlCol="0" anchor="ctr"/>
+          <a:lstStyle/>
+          <a:p>
+            <a:pPr algn="ctr"/>
+          </a:p>
+        </p:txBody>
+      </p:sp>
+      <p:sp>
+        <p:nvSpPr>
+          <p:cNvPr id="33" name="TextBox 32"/>
+          <p:cNvSpPr txBox="1"/>
+          <p:nvPr/>
+        </p:nvSpPr>
+        <p:spPr>
+          <a:xfrm>
+            <a:off x="566928" y="6510528"/>
+            <a:ext cx="9509760" cy="219456"/>
+          </a:xfrm>
+          <a:prstGeom prst="rect">
+            <a:avLst/>
+          </a:prstGeom>
+          <a:noFill/>
+        </p:spPr>
+        <p:txBody>
+          <a:bodyPr wrap="square" lIns="0" rIns="0" tIns="0" bIns="0" anchor="t">
+            <a:spAutoFit/>
+          </a:bodyPr>
+          <a:lstStyle/>
+          <a:p>
+            <a:pPr algn="l">
+              <a:lnSpc>
+                <a:spcPct val="112000"/>
+              </a:lnSpc>
+              <a:spcAft>
+                <a:spcPts val="0"/>
+              </a:spcAft>
+            </a:pPr>
+            <a:r>
+              <a:rPr sz="900" b="0">
+                <a:solidFill>
+                  <a:srgbClr val="8CA0BE"/>
+                </a:solidFill>
+                <a:latin typeface="Segoe UI"/>
+              </a:rPr>
+              <a:t>RetainIQ · Signal Ops Console</a:t>
+            </a:r>
+          </a:p>
+        </p:txBody>
+      </p:sp>
+      <p:sp>
+        <p:nvSpPr>
+          <p:cNvPr id="34" name="TextBox 33"/>
+          <p:cNvSpPr txBox="1"/>
+          <p:nvPr/>
+        </p:nvSpPr>
+        <p:spPr>
+          <a:xfrm>
+            <a:off x="10527487" y="6510528"/>
+            <a:ext cx="1097280" cy="219456"/>
+          </a:xfrm>
+          <a:prstGeom prst="rect">
+            <a:avLst/>
+          </a:prstGeom>
+          <a:noFill/>
+        </p:spPr>
+        <p:txBody>
+          <a:bodyPr wrap="square" lIns="0" rIns="0" tIns="0" bIns="0" anchor="t">
+            <a:spAutoFit/>
+          </a:bodyPr>
+          <a:lstStyle/>
+          <a:p>
+            <a:pPr algn="r">
+              <a:lnSpc>
+                <a:spcPct val="112000"/>
+              </a:lnSpc>
+              <a:spcAft>
+                <a:spcPts val="0"/>
+              </a:spcAft>
+            </a:pPr>
+            <a:r>
+              <a:rPr sz="900" b="0">
+                <a:solidFill>
+                  <a:srgbClr val="8CA0BE"/>
+                </a:solidFill>
+                <a:latin typeface="Consolas"/>
+              </a:rPr>
+              <a:t>21</a:t>
             </a:r>
           </a:p>
         </p:txBody>

</xml_diff>

<commit_message>
Make slide three explicitly about business problems
Co-authored-by: arena-agent <297053741+arena-agent@users.noreply.github.com>
</commit_message>
<xml_diff>
--- a/presentation/RetainIQ_Project_Review.pptx
+++ b/presentation/RetainIQ_Project_Review.pptx
@@ -31555,7 +31555,7 @@
                 </a:solidFill>
                 <a:latin typeface="Segoe UI"/>
               </a:rPr>
-              <a:t>The problem: retention is still reactive</a:t>
+              <a:t>Business Understanding: retention is still reactive</a:t>
             </a:r>
           </a:p>
         </p:txBody>
@@ -31597,7 +31597,7 @@
                 </a:solidFill>
                 <a:latin typeface="Segoe UI"/>
               </a:rPr>
-              <a:t>Reports explain what happened. They do not say who leaves next.</a:t>
+              <a:t>Churn is high, and teams often learn who left only after the fact.</a:t>
             </a:r>
           </a:p>
         </p:txBody>
@@ -31683,7 +31683,7 @@
                 </a:solidFill>
                 <a:latin typeface="Segoe UI"/>
               </a:rPr>
-              <a:t>▸  Churn compounds.</a:t>
+              <a:t>▸  Churn is a material business problem.</a:t>
             </a:r>
           </a:p>
           <a:p>
@@ -31724,7 +31724,7 @@
                 </a:solidFill>
                 <a:latin typeface="Segoe UI"/>
               </a:rPr>
-              <a:t>▸  Dashboards describe, they do not prioritise.</a:t>
+              <a:t>▸  Current retention is backward-looking.</a:t>
             </a:r>
           </a:p>
           <a:p>
@@ -31743,7 +31743,7 @@
                 </a:solidFill>
                 <a:latin typeface="Segoe UI"/>
               </a:rPr>
-              <a:t>     Knowing last quarter's churn rate does not tell a retention team whom to call today.</a:t>
+              <a:t>     Historical reporting shows who already left, not which customers need attention today.</a:t>
             </a:r>
           </a:p>
           <a:p>
@@ -31765,7 +31765,7 @@
                 </a:solidFill>
                 <a:latin typeface="Segoe UI"/>
               </a:rPr>
-              <a:t>▸  Generic campaigns waste budget.</a:t>
+              <a:t>▸  One-size-fits-all offers waste budget.</a:t>
             </a:r>
           </a:p>
           <a:p>
@@ -31784,7 +31784,7 @@
                 </a:solidFill>
                 <a:latin typeface="Segoe UI"/>
               </a:rPr>
-              <a:t>     Blanket offers discount loyal customers and still miss the ones about to leave.</a:t>
+              <a:t>     Discounts can go to customers who would stay, while still missing those likely to leave.</a:t>
             </a:r>
           </a:p>
         </p:txBody>

</xml_diff>

<commit_message>
Prepare seminar guide and clarify evaluation claims
Co-authored-by: arena-agent <297053741+arena-agent@users.noreply.github.com>
</commit_message>
<xml_diff>
--- a/presentation/RetainIQ_Project_Review.pptx
+++ b/presentation/RetainIQ_Project_Review.pptx
@@ -1060,22 +1060,27 @@
           </a:p>
           <a:p>
             <a:r>
-              <a:t>Then the validation, which is the point of the slide: "I checked the bands against</a:t>
+              <a:t>Then the in-dataset check: "Across this full portfolio, observed churn rises from</a:t>
             </a:r>
           </a:p>
           <a:p>
             <a:r>
-              <a:t>the real churn labels. Low risk actually churns 9.5%, medium 42%, high 73%. The</a:t>
+              <a:t>9.5% in low risk, to 42% in medium and 73% in high. That shows the bands order</a:t>
             </a:r>
           </a:p>
           <a:p>
             <a:r>
-              <a:t>band is a genuine ordering of risk, not a cosmetic split."</a:t>
+              <a:t>this dataset; it is not independent or external validation."</a:t>
             </a:r>
           </a:p>
           <a:p>
             <a:r>
-              <a:t>Close operationally: "the team starts with 1,135 customers instead of 7,043."</a:t>
+              <a:t>Close operationally: "the team can prioritise 1,135 high-risk rows, rather than</a:t>
+            </a:r>
+          </a:p>
+          <a:p>
+            <a:r>
+              <a:t>starting with all 7,043." Do not generalise the 73% rate beyond this dataset.</a:t>
             </a:r>
           </a:p>
         </p:txBody>
@@ -1640,12 +1645,17 @@
           <a:lstStyle/>
           <a:p>
             <a:r>
-              <a:t>(0:35–1:05) "Everything I show you maps to one of these fourteen boxes, and the</a:t>
+              <a:t>(0:35–1:05) "The core project workflow maps to these fourteen phases, grouped into</a:t>
             </a:r>
           </a:p>
           <a:p>
             <a:r>
-              <a:t>boxes group into three acts."</a:t>
+              <a:t>three acts. The comparison, responsibility, demo and closing slides frame that</a:t>
+            </a:r>
+          </a:p>
+          <a:p>
+            <a:r>
+              <a:t>technical journey."</a:t>
             </a:r>
           </a:p>
           <a:p>
@@ -1740,7 +1750,7 @@
           <a:lstStyle/>
           <a:p>
             <a:r>
-              <a:t>(11:00–11:30) Most students hide this slide. Put it up and read it.</a:t>
+              <a:t>(11:00–11:30) Most students hide this slide. Put it up and speak precisely.</a:t>
             </a:r>
           </a:p>
           <a:p>
@@ -1755,32 +1765,37 @@
           </a:p>
           <a:p>
             <a:r>
-              <a:t>savings, only as exposure. And I wouldn't ship a retention campaign aimed at</a:t>
+              <a:t>savings, only as exposure. And I wouldn't target by age without a fairness audit.</a:t>
             </a:r>
           </a:p>
           <a:p>
             <a:r>
-              <a:t>senior citizens without a bias audit — they churn at 41.7%, nearly double the</a:t>
+              <a:t>Senior-customer churn is 41.7% versus 23.6% for non-seniors (1.77×); the overall</a:t>
             </a:r>
           </a:p>
           <a:p>
             <a:r>
-              <a:t>base rate, so a risk-optimising model will concentrate offers on them."</a:t>
+              <a:t>rate is 26.54%. We have not measured subgroup errors or offer allocation, so that</a:t>
             </a:r>
           </a:p>
           <a:p>
             <a:r>
-              <a:t>Then close the loop: "and the fix for the recall number is already measured — 0.35</a:t>
+              <a:t>gap is a fairness risk to audit, not a claim of demonstrated bias."</a:t>
             </a:r>
           </a:p>
           <a:p>
             <a:r>
-              <a:t>catches 71.7%. That's the next cycle, which starts back at Phase 02 with drift</a:t>
+              <a:t>Then close the loop: "and the operating-point experiment shows what is possible —</a:t>
             </a:r>
           </a:p>
           <a:p>
             <a:r>
-              <a:t>monitoring."</a:t>
+              <a:t>0.35 reaches 71.7% recall and 62.98% F1 on this test split. Choosing a threshold</a:t>
+            </a:r>
+          </a:p>
+          <a:p>
+            <a:r>
+              <a:t>still needs a business decision about offer capacity and the cost of false alarms."</a:t>
             </a:r>
           </a:p>
         </p:txBody>
@@ -2261,22 +2276,32 @@
           <a:lstStyle/>
           <a:p>
             <a:r>
-              <a:t>(2:20–3:00) Quick pass on the tiles. Spend the time on the right-hand callouts:</a:t>
+              <a:t>(2:20–3:00) Quick pass on the tiles. Say that both partitions round to 26.54%</a:t>
             </a:r>
           </a:p>
           <a:p>
             <a:r>
-              <a:t>"the split is stratified, so both halves carry exactly the same 26.54% churn rate</a:t>
+              <a:t>churn because the split is stratified. Be precise: the 1,409 test rows were held</a:t>
             </a:r>
           </a:p>
           <a:p>
             <a:r>
-              <a:t>— the model never sees a distorted class balance."</a:t>
+              <a:t>out from fitting, but were used to compare and select candidate models. This is</a:t>
             </a:r>
           </a:p>
           <a:p>
             <a:r>
-              <a:t>And the parity point: "the 30-column contract is saved next to the model and</a:t>
+              <a:t>internal evaluation, not an untouched final or external test. A future nested-CV</a:t>
+            </a:r>
+          </a:p>
+          <a:p>
+            <a:r>
+              <a:t>or external cohort would give a stronger final estimate.</a:t>
+            </a:r>
+          </a:p>
+          <a:p>
+            <a:r>
+              <a:t>Then the parity point: "the 30-column contract is saved next to the model and</a:t>
             </a:r>
           </a:p>
           <a:p>
@@ -21143,7 +21168,7 @@
                 </a:solidFill>
                 <a:latin typeface="Consolas"/>
               </a:rPr>
-              <a:t>VALIDATION</a:t>
+              <a:t>IN-DATASET CHECK</a:t>
             </a:r>
           </a:p>
           <a:p>
@@ -21162,7 +21187,7 @@
                 </a:solidFill>
                 <a:latin typeface="Segoe UI"/>
               </a:rPr>
-              <a:t>The bands track reality: actual churn is 9.5% in low risk, 42.0% in medium and 73.0% in high risk. The segmentation is not decoration — it orders the portfolio correctly.</a:t>
+              <a:t>Across all 7,043 rows, observed churn rises from 9.5% (low) to 42.0% (medium) to 73.0% (high). This demonstrates risk ordering in this dataset, not independent or external validation.</a:t>
             </a:r>
           </a:p>
         </p:txBody>
@@ -21271,7 +21296,7 @@
                 </a:solidFill>
                 <a:latin typeface="Segoe UI"/>
               </a:rPr>
-              <a:t>Instead of calling 7,043 customers, the team starts with 1,135 — 16.1% of the base, where 73% will actually leave — carrying $92,539 of recurring monthly charges.</a:t>
+              <a:t>The team can prioritise 1,135 high-risk rows (16.1% of the base). In this dataset, 73% of that band churned; its observed monthly charges total $92,539.</a:t>
             </a:r>
           </a:p>
         </p:txBody>
@@ -38587,7 +38612,7 @@
                 </a:solidFill>
                 <a:latin typeface="Segoe UI"/>
               </a:rPr>
-              <a:t>This is the map for the whole talk — every slide that follows is one of these boxes</a:t>
+              <a:t>The core project workflow: fourteen phases grouped into three acts</a:t>
             </a:r>
           </a:p>
         </p:txBody>
@@ -41068,7 +41093,7 @@
                 </a:solidFill>
                 <a:latin typeface="Segoe UI"/>
               </a:rPr>
-              <a:t>▸  Senior citizens churn at 41.7% — nearly double the base rate. A model optimising for churn risk will systematically concentrate its retention offers on them.</a:t>
+              <a:t>▸  Senior-customer churn is 41.7% vs 23.6% for non-seniors (1.77×); the overall rate is 26.54%. Senior status is a model input; whether scores or offers concentrate unevenly requires a subgroup audit.</a:t>
             </a:r>
           </a:p>
           <a:p>
@@ -41087,7 +41112,7 @@
                 </a:solidFill>
                 <a:latin typeface="Segoe UI"/>
               </a:rPr>
-              <a:t>▸  A blanket discount aimed at that group is not neutral; it can read as exploitative pricing.</a:t>
+              <a:t>▸  A blanket age-based discount could be inequitable or perceived as exploitative pricing.</a:t>
             </a:r>
           </a:p>
           <a:p>
@@ -54892,7 +54917,7 @@
                 </a:solidFill>
                 <a:latin typeface="Segoe UI"/>
               </a:rPr>
-              <a:t>1,869 churned against 5,174 retained. The split is stratified, so both halves carry the identical 26.54% churn rate: 5,634 rows train, 1,409 rows are held back and touched only once.</a:t>
+              <a:t>1,869 churned and 5,174 retained. Stratified 80/20 split: 5,634 train and 1,409 test rows; both round to 26.54% churn. The test rows were held out from fitting, then used to compare candidate models—so this is not a final untouched validation set.</a:t>
             </a:r>
           </a:p>
         </p:txBody>

</xml_diff>